<commit_message>
vault backup: 2026-09-11 09:50:25
</commit_message>
<xml_diff>
--- a/SDLC/Projects/TMP-specimen-sorter-api — Specimen Sorter API/assets/Specimen Sorter API - Screen vs API.pptx
+++ b/SDLC/Projects/TMP-specimen-sorter-api — Specimen Sorter API/assets/Specimen Sorter API - Screen vs API.pptx
@@ -19,9 +19,10 @@
     <p:sldId id="267" r:id="rId13"/>
     <p:sldId id="268" r:id="rId14"/>
     <p:sldId id="269" r:id="rId15"/>
+    <p:sldId id="270" r:id="rId16"/>
   </p:sldIdLst>
   <p:notesMasterIdLst>
-    <p:notesMasterId r:id="rId16"/>
+    <p:notesMasterId r:id="rId17"/>
   </p:notesMasterIdLst>
   <p:sldSz cx="12192000" cy="6858000"/>
   <p:notesSz cx="6858000" cy="12192000"/>
@@ -515,7 +516,7 @@
           <a:p>
             <a:r>
               <a:rPr lang="en-US" dirty="0"/>
-              <a:t>This is a walkthrough of what moves off the screen, not a CP3 recap. Staff Specimen Acknowledgement stays as the fallback for Relabel and Failure.</a:t>
+              <a:t>Walkthrough of what moves off the screen. Staff Specimen Acknowledgement stays the fallback for Relabel and Failure.</a:t>
             </a:r>
             <a:endParaRPr lang="en-US" dirty="0"/>
           </a:p>
@@ -603,7 +604,7 @@
           <a:p>
             <a:r>
               <a:rPr lang="en-US" dirty="0"/>
-              <a:t>Partial DFT remainder is Relabel as well. DFT still uses Spec Ack register later, not the DFT register API.</a:t>
+              <a:t>Do not auto-create an unmapped doctor or location. Soft set on the previous two slides is not Failure.</a:t>
             </a:r>
             <a:endParaRPr lang="en-US" dirty="0"/>
           </a:p>
@@ -691,7 +692,7 @@
           <a:p>
             <a:r>
               <a:rPr lang="en-US" dirty="0"/>
-              <a:t>Report destination can follow request location when that Spec Ack option is on. The convertor already does that; the API ports it, it does not invent a new rule.</a:t>
+              <a:t>Partial DFT remainder is Relabel. DFT still uses Spec Ack register, not the DFT register API.</a:t>
             </a:r>
             <a:endParaRPr lang="en-US" dirty="0"/>
           </a:p>
@@ -779,7 +780,7 @@
           <a:p>
             <a:r>
               <a:rPr lang="en-US" dirty="0"/>
-              <a:t>Same three staff print services, in-process, no HTTP loopback. Registration only. A send-out form after local register is still a worksheet on that path, not a print after SEND_OUT.</a:t>
+              <a:t>Report destination can follow request location when that Spec Ack option is on. Port the existing rule. Do not invent a new one.</a:t>
             </a:r>
             <a:endParaRPr lang="en-US" dirty="0"/>
           </a:p>
@@ -867,7 +868,7 @@
           <a:p>
             <a:r>
               <a:rPr lang="en-US" dirty="0"/>
-              <a:t>PHLC is already backend today. The change is when it runs and that the sorter does not wait. Do not invent a new PHLC contract.</a:t>
+              <a:t>Same three staff print services, in-process, no HTTP loopback. Registration only.</a:t>
             </a:r>
             <a:endParaRPr lang="en-US" dirty="0"/>
           </a:p>
@@ -955,7 +956,7 @@
           <a:p>
             <a:r>
               <a:rPr lang="en-US" dirty="0"/>
-              <a:t>Close on the latency split so print arguments do not reopen the 4 second budget.</a:t>
+              <a:t>PHLC is already backend. The change is when it runs. Do not invent a new PHLC contract.</a:t>
             </a:r>
             <a:endParaRPr lang="en-US" dirty="0"/>
           </a:p>
@@ -979,6 +980,94 @@
             <a:fld id="{F7021451-1387-4CA6-816F-3879F97B5CBC}" type="slidenum">
               <a:rPr lang="en-US"/>
               <a:t>14</a:t>
+            </a:fld>
+            <a:endParaRPr lang="en-US"/>
+          </a:p>
+        </p:txBody>
+      </p:sp>
+    </p:spTree>
+    <p:extLst>
+      <p:ext uri="{BB962C8B-B14F-4D97-AF65-F5344CB8AC3E}">
+        <p14:creationId xmlns:p14="http://schemas.microsoft.com/office/powerpoint/2010/main" val="1024086991"/>
+      </p:ext>
+    </p:extLst>
+  </p:cSld>
+  <p:clrMapOvr>
+    <a:masterClrMapping/>
+  </p:clrMapOvr>
+</p:notes>
+</file>
+
+<file path=ppt/notesSlides/notesSlide15.xml><?xml version="1.0" encoding="utf-8"?>
+<p:notes xmlns:a="http://schemas.openxmlformats.org/drawingml/2006/main" xmlns:r="http://schemas.openxmlformats.org/officeDocument/2006/relationships" xmlns:p="http://schemas.openxmlformats.org/presentationml/2006/main">
+  <p:cSld>
+    <p:spTree>
+      <p:nvGrpSpPr>
+        <p:cNvPr id="1" name=""/>
+        <p:cNvGrpSpPr/>
+        <p:nvPr/>
+      </p:nvGrpSpPr>
+      <p:grpSpPr>
+        <a:xfrm>
+          <a:off x="0" y="0"/>
+          <a:ext cx="0" cy="0"/>
+          <a:chOff x="0" y="0"/>
+          <a:chExt cx="0" cy="0"/>
+        </a:xfrm>
+      </p:grpSpPr>
+      <p:sp>
+        <p:nvSpPr>
+          <p:cNvPr id="2" name="Slide Image Placeholder 1"/>
+          <p:cNvSpPr>
+            <a:spLocks noGrp="1" noRot="1" noChangeAspect="1"/>
+          </p:cNvSpPr>
+          <p:nvPr>
+            <p:ph type="sldImg"/>
+          </p:nvPr>
+        </p:nvSpPr>
+        <p:spPr/>
+      </p:sp>
+      <p:sp>
+        <p:nvSpPr>
+          <p:cNvPr id="3" name="Notes Placeholder 2"/>
+          <p:cNvSpPr>
+            <a:spLocks noGrp="1"/>
+          </p:cNvSpPr>
+          <p:nvPr>
+            <p:ph type="body" idx="1"/>
+          </p:nvPr>
+        </p:nvSpPr>
+        <p:spPr/>
+        <p:txBody>
+          <a:bodyPr/>
+          <a:lstStyle/>
+          <a:p>
+            <a:r>
+              <a:rPr lang="en-US" dirty="0"/>
+              <a:t>Close on the latency split so print arguments do not reopen the 4 second budget.</a:t>
+            </a:r>
+            <a:endParaRPr lang="en-US" dirty="0"/>
+          </a:p>
+        </p:txBody>
+      </p:sp>
+      <p:sp>
+        <p:nvSpPr>
+          <p:cNvPr id="4" name="Slide Number Placeholder 3"/>
+          <p:cNvSpPr>
+            <a:spLocks noGrp="1"/>
+          </p:cNvSpPr>
+          <p:nvPr>
+            <p:ph type="sldNum" sz="quarter" idx="10"/>
+          </p:nvPr>
+        </p:nvSpPr>
+        <p:spPr/>
+        <p:txBody>
+          <a:bodyPr/>
+          <a:lstStyle/>
+          <a:p>
+            <a:fld id="{F7021451-1387-4CA6-816F-3879F97B5CBC}" type="slidenum">
+              <a:rPr lang="en-US"/>
+              <a:t>15</a:t>
             </a:fld>
             <a:endParaRPr lang="en-US"/>
           </a:p>
@@ -1043,7 +1132,7 @@
           <a:p>
             <a:r>
               <a:rPr lang="en-US" dirty="0"/>
-              <a:t>Walk left to right as the POST does: retrieve, then send-out or register packing, then print and PHLC only if Registered.</a:t>
+              <a:t>Walk the POST in order: retrieve, send-out or register packing, then print and PHLC only if Registered.</a:t>
             </a:r>
             <a:endParaRPr lang="en-US" dirty="0"/>
           </a:p>
@@ -1219,7 +1308,7 @@
           <a:p>
             <a:r>
               <a:rPr lang="en-US" dirty="0"/>
-              <a:t>Say that the GET retrieve stays for staff. The sorter must not call it. CPS and HMS only in v1. DFT and STAR on those labs still retrieve.</a:t>
+              <a:t>The staff retrieve GET stays. The sorter must not call it. CPS and HMS only. DFT and STAR on those labs still retrieve.</a:t>
             </a:r>
             <a:endParaRPr lang="en-US" dirty="0"/>
           </a:p>
@@ -1307,7 +1396,7 @@
           <a:p>
             <a:r>
               <a:rPr lang="en-US" dirty="0"/>
-              <a:t>Name the list as the send-out test table if asked, not as a Flex routine. Audit will add SORT_SO beside the existing SEND_OUT write in a later package.</a:t>
+              <a:t>Call the list the send-out test table if asked. Mixed is Failure so the sorter does not split one tube.</a:t>
             </a:r>
             <a:endParaRPr lang="en-US" dirty="0"/>
           </a:p>
@@ -1395,7 +1484,7 @@
           <a:p>
             <a:r>
               <a:rPr lang="en-US" dirty="0"/>
-              <a:t>Register on the service already expects a packed request. That is why middleware cannot call the staff register endpoint as-is.</a:t>
+              <a:t>Register already expects a packed request. That is why middleware cannot call the staff register endpoint as-is.</a:t>
             </a:r>
             <a:endParaRPr lang="en-US" dirty="0"/>
           </a:p>
@@ -1483,7 +1572,7 @@
           <a:p>
             <a:r>
               <a:rPr lang="en-US" dirty="0"/>
-              <a:t>The mixed-path change is the one to say out loud. Staff can still proceed after that popup. The sorter cannot split the tube.</a:t>
+              <a:t>Say the mixed change out loud. Staff can still click through that popup. The sorter cannot split the tube.</a:t>
             </a:r>
             <a:endParaRPr lang="en-US" dirty="0"/>
           </a:p>
@@ -1571,7 +1660,7 @@
           <a:p>
             <a:r>
               <a:rPr lang="en-US" dirty="0"/>
-              <a:t>These are the R6 soft set. Mixed is not on this slide because the locked design made it Failure.</a:t>
+              <a:t>First half of the soft set from the confirmed requirement. Next slide has the rest.</a:t>
             </a:r>
             <a:endParaRPr lang="en-US" dirty="0"/>
           </a:p>
@@ -1659,7 +1748,7 @@
           <a:p>
             <a:r>
               <a:rPr lang="en-US" dirty="0"/>
-              <a:t>Walk the five rows, then the takeaway for test-dict and identity mismatch. Do not auto-create an unmapped doctor or location.</a:t>
+              <a:t>Mixed is not here. The locked design made mixed a hard Failure.</a:t>
             </a:r>
             <a:endParaRPr lang="en-US" dirty="0"/>
           </a:p>
@@ -2631,7 +2720,7 @@
                 <a:ea typeface="Calibri" pitchFamily="34" charset="-122"/>
                 <a:cs typeface="Calibri" pitchFamily="34" charset="-120"/>
               </a:rPr>
-              <a:t>1 / 14</a:t>
+              <a:t>1 / 15</a:t>
             </a:r>
             <a:endParaRPr lang="en-US" sz="900" dirty="0"/>
           </a:p>
@@ -2695,7 +2784,7 @@
                 <a:ea typeface="Calibri" pitchFamily="34" charset="-122"/>
                 <a:cs typeface="Calibri" pitchFamily="34" charset="-120"/>
               </a:rPr>
-              <a:t>TEST GROUPING AND REQUEST NO.</a:t>
+              <a:t>REGISTRATION CHECKS</a:t>
             </a:r>
             <a:endParaRPr lang="en-US" sz="1100" dirty="0"/>
           </a:p>
@@ -2734,7 +2823,7 @@
                 <a:ea typeface="Cambria" pitchFamily="34" charset="-122"/>
                 <a:cs typeface="Cambria" pitchFamily="34" charset="-120"/>
               </a:rPr>
-              <a:t>USID becomes the request no. only when the tube can carry it.</a:t>
+              <a:t>Hard checks that return Failure</a:t>
             </a:r>
             <a:endParaRPr lang="en-US" sz="3000" dirty="0"/>
           </a:p>
@@ -2749,19 +2838,19 @@
         <p:spPr>
           <a:xfrm>
             <a:off x="548640" y="1737360"/>
-            <a:ext cx="5394960" cy="3063240"/>
+            <a:ext cx="3526536" cy="3108960"/>
           </a:xfrm>
           <a:prstGeom prst="roundRect">
             <a:avLst>
-              <a:gd name="adj" fmla="val 1194"/>
+              <a:gd name="adj" fmla="val 1176"/>
             </a:avLst>
           </a:prstGeom>
           <a:solidFill>
-            <a:srgbClr val="F1F3F3"/>
+            <a:srgbClr val="F7E7E4"/>
           </a:solidFill>
           <a:ln w="12700">
             <a:solidFill>
-              <a:srgbClr val="F1F3F3"/>
+              <a:srgbClr val="F7E7E4"/>
             </a:solidFill>
             <a:prstDash val="solid"/>
           </a:ln>
@@ -2775,8 +2864,92 @@
         </p:nvSpPr>
         <p:spPr>
           <a:xfrm>
-            <a:off x="822960" y="1956816"/>
-            <a:ext cx="4846320" cy="256032"/>
+            <a:off x="822960" y="1993392"/>
+            <a:ext cx="384048" cy="384048"/>
+          </a:xfrm>
+          <a:prstGeom prst="ellipse">
+            <a:avLst/>
+          </a:prstGeom>
+          <a:solidFill>
+            <a:srgbClr val="A8443A"/>
+          </a:solidFill>
+          <a:ln>
+            <a:solidFill>
+              <a:srgbClr val="A8443A"/>
+            </a:solidFill>
+          </a:ln>
+        </p:spPr>
+        <p:txBody>
+          <a:bodyPr wrap="square" rtlCol="0" anchor="ctr"/>
+          <a:lstStyle/>
+          <a:p>
+            <a:pPr algn="ctr" indent="0" marL="0">
+              <a:buNone/>
+            </a:pPr>
+            <a:r>
+              <a:rPr lang="en-US" sz="1300" b="1" dirty="0">
+                <a:solidFill>
+                  <a:srgbClr val="FFFFFF"/>
+                </a:solidFill>
+                <a:latin typeface="Calibri" pitchFamily="34" charset="0"/>
+                <a:ea typeface="Calibri" pitchFamily="34" charset="-122"/>
+                <a:cs typeface="Calibri" pitchFamily="34" charset="-120"/>
+              </a:rPr>
+              <a:t>1</a:t>
+            </a:r>
+            <a:endParaRPr lang="en-US" sz="1300" dirty="0"/>
+          </a:p>
+        </p:txBody>
+      </p:sp>
+      <p:sp>
+        <p:nvSpPr>
+          <p:cNvPr id="6" name="Text 4"/>
+          <p:cNvSpPr/>
+          <p:nvPr/>
+        </p:nvSpPr>
+        <p:spPr>
+          <a:xfrm>
+            <a:off x="822960" y="2560320"/>
+            <a:ext cx="2977896" cy="274320"/>
+          </a:xfrm>
+          <a:prstGeom prst="rect">
+            <a:avLst/>
+          </a:prstGeom>
+          <a:noFill/>
+          <a:ln/>
+        </p:spPr>
+        <p:txBody>
+          <a:bodyPr wrap="square" rtlCol="0" anchor="ctr"/>
+          <a:lstStyle/>
+          <a:p>
+            <a:pPr algn="l" indent="0" marL="0">
+              <a:buNone/>
+            </a:pPr>
+            <a:r>
+              <a:rPr lang="en-US" sz="1100" dirty="0">
+                <a:solidFill>
+                  <a:srgbClr val="A8443A"/>
+                </a:solidFill>
+                <a:latin typeface="Courier New" pitchFamily="34" charset="0"/>
+                <a:ea typeface="Courier New" pitchFamily="34" charset="-122"/>
+                <a:cs typeface="Courier New" pitchFamily="34" charset="-120"/>
+              </a:rPr>
+              <a:t>1162-1170, 1090</a:t>
+            </a:r>
+            <a:endParaRPr lang="en-US" sz="1100" dirty="0"/>
+          </a:p>
+        </p:txBody>
+      </p:sp>
+      <p:sp>
+        <p:nvSpPr>
+          <p:cNvPr id="7" name="Text 5"/>
+          <p:cNvSpPr/>
+          <p:nvPr/>
+        </p:nvSpPr>
+        <p:spPr>
+          <a:xfrm>
+            <a:off x="822960" y="2926080"/>
+            <a:ext cx="2977896" cy="457200"/>
           </a:xfrm>
           <a:prstGeom prst="rect">
             <a:avLst/>
@@ -2795,49 +2968,7 @@
               <a:buNone/>
             </a:pPr>
             <a:r>
-              <a:rPr lang="en-US" sz="900" dirty="0">
-                <a:solidFill>
-                  <a:srgbClr val="56676C"/>
-                </a:solidFill>
-                <a:latin typeface="Calibri" pitchFamily="34" charset="0"/>
-                <a:ea typeface="Calibri" pitchFamily="34" charset="-122"/>
-                <a:cs typeface="Calibri" pitchFamily="34" charset="-120"/>
-              </a:rPr>
-              <a:t>MANUAL</a:t>
-            </a:r>
-            <a:endParaRPr lang="en-US" sz="900" dirty="0"/>
-          </a:p>
-        </p:txBody>
-      </p:sp>
-      <p:sp>
-        <p:nvSpPr>
-          <p:cNvPr id="6" name="Text 4"/>
-          <p:cNvSpPr/>
-          <p:nvPr/>
-        </p:nvSpPr>
-        <p:spPr>
-          <a:xfrm>
-            <a:off x="822960" y="2267712"/>
-            <a:ext cx="4846320" cy="457200"/>
-          </a:xfrm>
-          <a:prstGeom prst="rect">
-            <a:avLst/>
-          </a:prstGeom>
-          <a:noFill/>
-          <a:ln/>
-        </p:spPr>
-        <p:txBody>
-          <a:bodyPr wrap="square" rtlCol="0" anchor="t"/>
-          <a:lstStyle/>
-          <a:p>
-            <a:pPr algn="l" indent="0" marL="0">
-              <a:lnSpc>
-                <a:spcPct val="115000"/>
-              </a:lnSpc>
-              <a:buNone/>
-            </a:pPr>
-            <a:r>
-              <a:rPr lang="en-US" sz="1800" dirty="0">
+              <a:rPr lang="en-US" sz="1700" dirty="0">
                 <a:solidFill>
                   <a:srgbClr val="08323B"/>
                 </a:solidFill>
@@ -2845,22 +2976,22 @@
                 <a:ea typeface="Cambria" pitchFamily="34" charset="-122"/>
                 <a:cs typeface="Cambria" pitchFamily="34" charset="-120"/>
               </a:rPr>
-              <a:t>Screen groups tests, then assigns</a:t>
-            </a:r>
-            <a:endParaRPr lang="en-US" sz="1800" dirty="0"/>
-          </a:p>
-        </p:txBody>
-      </p:sp>
-      <p:sp>
-        <p:nvSpPr>
-          <p:cNvPr id="7" name="Text 5"/>
-          <p:cNvSpPr/>
-          <p:nvPr/>
-        </p:nvSpPr>
-        <p:spPr>
-          <a:xfrm>
-            <a:off x="822960" y="2816352"/>
-            <a:ext cx="4846320" cy="1801368"/>
+              <a:t>Unmapped ward / doctor</a:t>
+            </a:r>
+            <a:endParaRPr lang="en-US" sz="1700" dirty="0"/>
+          </a:p>
+        </p:txBody>
+      </p:sp>
+      <p:sp>
+        <p:nvSpPr>
+          <p:cNvPr id="8" name="Text 6"/>
+          <p:cNvSpPr/>
+          <p:nvPr/>
+        </p:nvSpPr>
+        <p:spPr>
+          <a:xfrm>
+            <a:off x="822960" y="3456432"/>
+            <a:ext cx="2977896" cy="1207008"/>
           </a:xfrm>
           <a:prstGeom prst="rect">
             <a:avLst/>
@@ -2874,7 +3005,7 @@
           <a:p>
             <a:pPr algn="l" indent="0" marL="0">
               <a:lnSpc>
-                <a:spcPct val="140000"/>
+                <a:spcPct val="115000"/>
               </a:lnSpc>
               <a:buNone/>
             </a:pPr>
@@ -2887,94 +3018,34 @@
                 <a:ea typeface="Calibri" pitchFamily="34" charset="-122"/>
                 <a:cs typeface="Calibri" pitchFamily="34" charset="-120"/>
               </a:rPr>
-              <a:t>·  Tests are grouped before Register. Each group needs a request no.</a:t>
+              <a:t>Doctor, location, specialty, report dest, or report copy has no LIS id.</a:t>
             </a:r>
             <a:endParaRPr lang="en-US" sz="1300" dirty="0"/>
           </a:p>
-          <a:p>
-            <a:pPr algn="l" indent="0" marL="0">
-              <a:lnSpc>
-                <a:spcPct val="140000"/>
-              </a:lnSpc>
-              <a:buNone/>
-            </a:pPr>
-            <a:r>
-              <a:rPr lang="en-US" sz="1300" dirty="0">
-                <a:solidFill>
-                  <a:srgbClr val="56676C"/>
-                </a:solidFill>
-                <a:latin typeface="Calibri" pitchFamily="34" charset="0"/>
-                <a:ea typeface="Calibri" pitchFamily="34" charset="-122"/>
-                <a:cs typeface="Calibri" pitchFamily="34" charset="-120"/>
-              </a:rPr>
-              <a:t>·  USID can be the request no. when the screen says it is eligible.</a:t>
-            </a:r>
-            <a:endParaRPr lang="en-US" sz="1300" dirty="0"/>
-          </a:p>
-          <a:p>
-            <a:pPr algn="l" indent="0" marL="0">
-              <a:lnSpc>
-                <a:spcPct val="140000"/>
-              </a:lnSpc>
-              <a:buNone/>
-            </a:pPr>
-            <a:r>
-              <a:rPr lang="en-US" sz="1300" dirty="0">
-                <a:solidFill>
-                  <a:srgbClr val="56676C"/>
-                </a:solidFill>
-                <a:latin typeface="Calibri" pitchFamily="34" charset="0"/>
-                <a:ea typeface="Calibri" pitchFamily="34" charset="-122"/>
-                <a:cs typeface="Calibri" pitchFamily="34" charset="-120"/>
-              </a:rPr>
-              <a:t>·  Staff can tick Relabel USID and force a new label.</a:t>
-            </a:r>
-            <a:endParaRPr lang="en-US" sz="1300" dirty="0"/>
-          </a:p>
-          <a:p>
-            <a:pPr algn="l" indent="0" marL="0">
-              <a:lnSpc>
-                <a:spcPct val="140000"/>
-              </a:lnSpc>
-              <a:buNone/>
-            </a:pPr>
-            <a:r>
-              <a:rPr lang="en-US" sz="1300" dirty="0">
-                <a:solidFill>
-                  <a:srgbClr val="56676C"/>
-                </a:solidFill>
-                <a:latin typeface="Calibri" pitchFamily="34" charset="0"/>
-                <a:ea typeface="Calibri" pitchFamily="34" charset="-122"/>
-                <a:cs typeface="Calibri" pitchFamily="34" charset="-120"/>
-              </a:rPr>
-              <a:t>·  More than one group, multi-specimen, suffix not 0, DFT same time-flag, or force relabel: do not use USID.</a:t>
-            </a:r>
-            <a:endParaRPr lang="en-US" sz="1300" dirty="0"/>
-          </a:p>
-        </p:txBody>
-      </p:sp>
-      <p:sp>
-        <p:nvSpPr>
-          <p:cNvPr id="8" name="Shape 6"/>
-          <p:cNvSpPr/>
-          <p:nvPr/>
-        </p:nvSpPr>
-        <p:spPr>
-          <a:xfrm>
-            <a:off x="6245352" y="1737360"/>
-            <a:ext cx="5394960" cy="3063240"/>
+        </p:txBody>
+      </p:sp>
+      <p:sp>
+        <p:nvSpPr>
+          <p:cNvPr id="9" name="Shape 7"/>
+          <p:cNvSpPr/>
+          <p:nvPr/>
+        </p:nvSpPr>
+        <p:spPr>
+          <a:xfrm>
+            <a:off x="4331208" y="1737360"/>
+            <a:ext cx="3526536" cy="3108960"/>
           </a:xfrm>
           <a:prstGeom prst="roundRect">
             <a:avLst>
-              <a:gd name="adj" fmla="val 1194"/>
+              <a:gd name="adj" fmla="val 1176"/>
             </a:avLst>
           </a:prstGeom>
           <a:solidFill>
-            <a:srgbClr val="E4F0F2"/>
+            <a:srgbClr val="F7E7E4"/>
           </a:solidFill>
           <a:ln w="12700">
             <a:solidFill>
-              <a:srgbClr val="E4F0F2"/>
+              <a:srgbClr val="F7E7E4"/>
             </a:solidFill>
             <a:prstDash val="solid"/>
           </a:ln>
@@ -2982,14 +3053,98 @@
       </p:sp>
       <p:sp>
         <p:nvSpPr>
-          <p:cNvPr id="9" name="Text 7"/>
-          <p:cNvSpPr/>
-          <p:nvPr/>
-        </p:nvSpPr>
-        <p:spPr>
-          <a:xfrm>
-            <a:off x="6519672" y="1956816"/>
-            <a:ext cx="4846320" cy="256032"/>
+          <p:cNvPr id="10" name="Text 8"/>
+          <p:cNvSpPr/>
+          <p:nvPr/>
+        </p:nvSpPr>
+        <p:spPr>
+          <a:xfrm>
+            <a:off x="4605528" y="1993392"/>
+            <a:ext cx="384048" cy="384048"/>
+          </a:xfrm>
+          <a:prstGeom prst="ellipse">
+            <a:avLst/>
+          </a:prstGeom>
+          <a:solidFill>
+            <a:srgbClr val="A8443A"/>
+          </a:solidFill>
+          <a:ln>
+            <a:solidFill>
+              <a:srgbClr val="A8443A"/>
+            </a:solidFill>
+          </a:ln>
+        </p:spPr>
+        <p:txBody>
+          <a:bodyPr wrap="square" rtlCol="0" anchor="ctr"/>
+          <a:lstStyle/>
+          <a:p>
+            <a:pPr algn="ctr" indent="0" marL="0">
+              <a:buNone/>
+            </a:pPr>
+            <a:r>
+              <a:rPr lang="en-US" sz="1300" b="1" dirty="0">
+                <a:solidFill>
+                  <a:srgbClr val="FFFFFF"/>
+                </a:solidFill>
+                <a:latin typeface="Calibri" pitchFamily="34" charset="0"/>
+                <a:ea typeface="Calibri" pitchFamily="34" charset="-122"/>
+                <a:cs typeface="Calibri" pitchFamily="34" charset="-120"/>
+              </a:rPr>
+              <a:t>2</a:t>
+            </a:r>
+            <a:endParaRPr lang="en-US" sz="1300" dirty="0"/>
+          </a:p>
+        </p:txBody>
+      </p:sp>
+      <p:sp>
+        <p:nvSpPr>
+          <p:cNvPr id="11" name="Text 9"/>
+          <p:cNvSpPr/>
+          <p:nvPr/>
+        </p:nvSpPr>
+        <p:spPr>
+          <a:xfrm>
+            <a:off x="4605528" y="2560320"/>
+            <a:ext cx="2977896" cy="274320"/>
+          </a:xfrm>
+          <a:prstGeom prst="rect">
+            <a:avLst/>
+          </a:prstGeom>
+          <a:noFill/>
+          <a:ln/>
+        </p:spPr>
+        <p:txBody>
+          <a:bodyPr wrap="square" rtlCol="0" anchor="ctr"/>
+          <a:lstStyle/>
+          <a:p>
+            <a:pPr algn="l" indent="0" marL="0">
+              <a:buNone/>
+            </a:pPr>
+            <a:r>
+              <a:rPr lang="en-US" sz="1100" dirty="0">
+                <a:solidFill>
+                  <a:srgbClr val="A8443A"/>
+                </a:solidFill>
+                <a:latin typeface="Courier New" pitchFamily="34" charset="0"/>
+                <a:ea typeface="Courier New" pitchFamily="34" charset="-122"/>
+                <a:cs typeface="Courier New" pitchFamily="34" charset="-120"/>
+              </a:rPr>
+              <a:t>R12</a:t>
+            </a:r>
+            <a:endParaRPr lang="en-US" sz="1100" dirty="0"/>
+          </a:p>
+        </p:txBody>
+      </p:sp>
+      <p:sp>
+        <p:nvSpPr>
+          <p:cNvPr id="12" name="Text 10"/>
+          <p:cNvSpPr/>
+          <p:nvPr/>
+        </p:nvSpPr>
+        <p:spPr>
+          <a:xfrm>
+            <a:off x="4605528" y="2926080"/>
+            <a:ext cx="2977896" cy="457200"/>
           </a:xfrm>
           <a:prstGeom prst="rect">
             <a:avLst/>
@@ -3008,49 +3163,7 @@
               <a:buNone/>
             </a:pPr>
             <a:r>
-              <a:rPr lang="en-US" sz="900" dirty="0">
-                <a:solidFill>
-                  <a:srgbClr val="0B6E7F"/>
-                </a:solidFill>
-                <a:latin typeface="Calibri" pitchFamily="34" charset="0"/>
-                <a:ea typeface="Calibri" pitchFamily="34" charset="-122"/>
-                <a:cs typeface="Calibri" pitchFamily="34" charset="-120"/>
-              </a:rPr>
-              <a:t>SORTER POST</a:t>
-            </a:r>
-            <a:endParaRPr lang="en-US" sz="900" dirty="0"/>
-          </a:p>
-        </p:txBody>
-      </p:sp>
-      <p:sp>
-        <p:nvSpPr>
-          <p:cNvPr id="10" name="Text 8"/>
-          <p:cNvSpPr/>
-          <p:nvPr/>
-        </p:nvSpPr>
-        <p:spPr>
-          <a:xfrm>
-            <a:off x="6519672" y="2267712"/>
-            <a:ext cx="4846320" cy="457200"/>
-          </a:xfrm>
-          <a:prstGeom prst="rect">
-            <a:avLst/>
-          </a:prstGeom>
-          <a:noFill/>
-          <a:ln/>
-        </p:spPr>
-        <p:txBody>
-          <a:bodyPr wrap="square" rtlCol="0" anchor="t"/>
-          <a:lstStyle/>
-          <a:p>
-            <a:pPr algn="l" indent="0" marL="0">
-              <a:lnSpc>
-                <a:spcPct val="115000"/>
-              </a:lnSpc>
-              <a:buNone/>
-            </a:pPr>
-            <a:r>
-              <a:rPr lang="en-US" sz="1800" dirty="0">
+              <a:rPr lang="en-US" sz="1700" dirty="0">
                 <a:solidFill>
                   <a:srgbClr val="08323B"/>
                 </a:solidFill>
@@ -3058,22 +3171,22 @@
                 <a:ea typeface="Cambria" pitchFamily="34" charset="-122"/>
                 <a:cs typeface="Cambria" pitchFamily="34" charset="-120"/>
               </a:rPr>
-              <a:t>Same grouping. No checkbox.</a:t>
-            </a:r>
-            <a:endParaRPr lang="en-US" sz="1800" dirty="0"/>
-          </a:p>
-        </p:txBody>
-      </p:sp>
-      <p:sp>
-        <p:nvSpPr>
-          <p:cNvPr id="11" name="Text 9"/>
-          <p:cNvSpPr/>
-          <p:nvPr/>
-        </p:nvSpPr>
-        <p:spPr>
-          <a:xfrm>
-            <a:off x="6519672" y="2816352"/>
-            <a:ext cx="4846320" cy="1801368"/>
+              <a:t>Datetime</a:t>
+            </a:r>
+            <a:endParaRPr lang="en-US" sz="1700" dirty="0"/>
+          </a:p>
+        </p:txBody>
+      </p:sp>
+      <p:sp>
+        <p:nvSpPr>
+          <p:cNvPr id="13" name="Text 11"/>
+          <p:cNvSpPr/>
+          <p:nvPr/>
+        </p:nvSpPr>
+        <p:spPr>
+          <a:xfrm>
+            <a:off x="4605528" y="3456432"/>
+            <a:ext cx="2977896" cy="1207008"/>
           </a:xfrm>
           <a:prstGeom prst="rect">
             <a:avLst/>
@@ -3087,7 +3200,7 @@
           <a:p>
             <a:pPr algn="l" indent="0" marL="0">
               <a:lnSpc>
-                <a:spcPct val="140000"/>
+                <a:spcPct val="115000"/>
               </a:lnSpc>
               <a:buNone/>
             </a:pPr>
@@ -3100,14 +3213,189 @@
                 <a:ea typeface="Calibri" pitchFamily="34" charset="-122"/>
                 <a:cs typeface="Calibri" pitchFamily="34" charset="-120"/>
               </a:rPr>
-              <a:t>·  Same grouping and the same Relabel rules, without a user Relabel tick.</a:t>
+              <a:t>Collection before DOB. Ack before collection or request. Ack in the future.</a:t>
             </a:r>
             <a:endParaRPr lang="en-US" sz="1300" dirty="0"/>
           </a:p>
-          <a:p>
-            <a:pPr algn="l" indent="0" marL="0">
-              <a:lnSpc>
-                <a:spcPct val="140000"/>
+        </p:txBody>
+      </p:sp>
+      <p:sp>
+        <p:nvSpPr>
+          <p:cNvPr id="14" name="Shape 12"/>
+          <p:cNvSpPr/>
+          <p:nvPr/>
+        </p:nvSpPr>
+        <p:spPr>
+          <a:xfrm>
+            <a:off x="8113776" y="1737360"/>
+            <a:ext cx="3526536" cy="3108960"/>
+          </a:xfrm>
+          <a:prstGeom prst="roundRect">
+            <a:avLst>
+              <a:gd name="adj" fmla="val 1176"/>
+            </a:avLst>
+          </a:prstGeom>
+          <a:solidFill>
+            <a:srgbClr val="F7E7E4"/>
+          </a:solidFill>
+          <a:ln w="12700">
+            <a:solidFill>
+              <a:srgbClr val="F7E7E4"/>
+            </a:solidFill>
+            <a:prstDash val="solid"/>
+          </a:ln>
+        </p:spPr>
+      </p:sp>
+      <p:sp>
+        <p:nvSpPr>
+          <p:cNvPr id="15" name="Text 13"/>
+          <p:cNvSpPr/>
+          <p:nvPr/>
+        </p:nvSpPr>
+        <p:spPr>
+          <a:xfrm>
+            <a:off x="8388096" y="1993392"/>
+            <a:ext cx="384048" cy="384048"/>
+          </a:xfrm>
+          <a:prstGeom prst="ellipse">
+            <a:avLst/>
+          </a:prstGeom>
+          <a:solidFill>
+            <a:srgbClr val="A8443A"/>
+          </a:solidFill>
+          <a:ln>
+            <a:solidFill>
+              <a:srgbClr val="A8443A"/>
+            </a:solidFill>
+          </a:ln>
+        </p:spPr>
+        <p:txBody>
+          <a:bodyPr wrap="square" rtlCol="0" anchor="ctr"/>
+          <a:lstStyle/>
+          <a:p>
+            <a:pPr algn="ctr" indent="0" marL="0">
+              <a:buNone/>
+            </a:pPr>
+            <a:r>
+              <a:rPr lang="en-US" sz="1300" b="1" dirty="0">
+                <a:solidFill>
+                  <a:srgbClr val="FFFFFF"/>
+                </a:solidFill>
+                <a:latin typeface="Calibri" pitchFamily="34" charset="0"/>
+                <a:ea typeface="Calibri" pitchFamily="34" charset="-122"/>
+                <a:cs typeface="Calibri" pitchFamily="34" charset="-120"/>
+              </a:rPr>
+              <a:t>3</a:t>
+            </a:r>
+            <a:endParaRPr lang="en-US" sz="1300" dirty="0"/>
+          </a:p>
+        </p:txBody>
+      </p:sp>
+      <p:sp>
+        <p:nvSpPr>
+          <p:cNvPr id="16" name="Text 14"/>
+          <p:cNvSpPr/>
+          <p:nvPr/>
+        </p:nvSpPr>
+        <p:spPr>
+          <a:xfrm>
+            <a:off x="8388096" y="2560320"/>
+            <a:ext cx="2977896" cy="274320"/>
+          </a:xfrm>
+          <a:prstGeom prst="rect">
+            <a:avLst/>
+          </a:prstGeom>
+          <a:noFill/>
+          <a:ln/>
+        </p:spPr>
+        <p:txBody>
+          <a:bodyPr wrap="square" rtlCol="0" anchor="ctr"/>
+          <a:lstStyle/>
+          <a:p>
+            <a:pPr algn="l" indent="0" marL="0">
+              <a:buNone/>
+            </a:pPr>
+            <a:r>
+              <a:rPr lang="en-US" sz="1100" dirty="0">
+                <a:solidFill>
+                  <a:srgbClr val="A8443A"/>
+                </a:solidFill>
+                <a:latin typeface="Courier New" pitchFamily="34" charset="0"/>
+                <a:ea typeface="Courier New" pitchFamily="34" charset="-122"/>
+                <a:cs typeface="Courier New" pitchFamily="34" charset="-120"/>
+              </a:rPr>
+              <a:t>4422</a:t>
+            </a:r>
+            <a:endParaRPr lang="en-US" sz="1100" dirty="0"/>
+          </a:p>
+        </p:txBody>
+      </p:sp>
+      <p:sp>
+        <p:nvSpPr>
+          <p:cNvPr id="17" name="Text 15"/>
+          <p:cNvSpPr/>
+          <p:nvPr/>
+        </p:nvSpPr>
+        <p:spPr>
+          <a:xfrm>
+            <a:off x="8388096" y="2926080"/>
+            <a:ext cx="2977896" cy="457200"/>
+          </a:xfrm>
+          <a:prstGeom prst="rect">
+            <a:avLst/>
+          </a:prstGeom>
+          <a:noFill/>
+          <a:ln/>
+        </p:spPr>
+        <p:txBody>
+          <a:bodyPr wrap="square" rtlCol="0" anchor="t"/>
+          <a:lstStyle/>
+          <a:p>
+            <a:pPr algn="l" indent="0" marL="0">
+              <a:lnSpc>
+                <a:spcPct val="115000"/>
+              </a:lnSpc>
+              <a:buNone/>
+            </a:pPr>
+            <a:r>
+              <a:rPr lang="en-US" sz="1700" dirty="0">
+                <a:solidFill>
+                  <a:srgbClr val="08323B"/>
+                </a:solidFill>
+                <a:latin typeface="Cambria" pitchFamily="34" charset="0"/>
+                <a:ea typeface="Cambria" pitchFamily="34" charset="-122"/>
+                <a:cs typeface="Cambria" pitchFamily="34" charset="-120"/>
+              </a:rPr>
+              <a:t>STAR / mixed / empty</a:t>
+            </a:r>
+            <a:endParaRPr lang="en-US" sz="1700" dirty="0"/>
+          </a:p>
+        </p:txBody>
+      </p:sp>
+      <p:sp>
+        <p:nvSpPr>
+          <p:cNvPr id="18" name="Text 16"/>
+          <p:cNvSpPr/>
+          <p:nvPr/>
+        </p:nvSpPr>
+        <p:spPr>
+          <a:xfrm>
+            <a:off x="8388096" y="3456432"/>
+            <a:ext cx="2977896" cy="1207008"/>
+          </a:xfrm>
+          <a:prstGeom prst="rect">
+            <a:avLst/>
+          </a:prstGeom>
+          <a:noFill/>
+          <a:ln/>
+        </p:spPr>
+        <p:txBody>
+          <a:bodyPr wrap="square" rtlCol="0" anchor="t"/>
+          <a:lstStyle/>
+          <a:p>
+            <a:pPr algn="l" indent="0" marL="0">
+              <a:lnSpc>
+                <a:spcPct val="115000"/>
               </a:lnSpc>
               <a:buNone/>
             </a:pPr>
@@ -3120,55 +3408,15 @@
                 <a:ea typeface="Calibri" pitchFamily="34" charset="-122"/>
                 <a:cs typeface="Calibri" pitchFamily="34" charset="-120"/>
               </a:rPr>
-              <a:t>·  Single group, one specimen, suffix 0, not force-relabel: request no. = USID.</a:t>
+              <a:t>No workbench location. Local plus send-out. Already used, all registered, all deleted, rejected.</a:t>
             </a:r>
             <a:endParaRPr lang="en-US" sz="1300" dirty="0"/>
           </a:p>
-          <a:p>
-            <a:pPr algn="l" indent="0" marL="0">
-              <a:lnSpc>
-                <a:spcPct val="140000"/>
-              </a:lnSpc>
-              <a:buNone/>
-            </a:pPr>
-            <a:r>
-              <a:rPr lang="en-US" sz="1300" dirty="0">
-                <a:solidFill>
-                  <a:srgbClr val="56676C"/>
-                </a:solidFill>
-                <a:latin typeface="Calibri" pitchFamily="34" charset="0"/>
-                <a:ea typeface="Calibri" pitchFamily="34" charset="-122"/>
-                <a:cs typeface="Calibri" pitchFamily="34" charset="-120"/>
-              </a:rPr>
-              <a:t>·  Otherwise return Relabel. Do not write a lab request. Do not invent a number.</a:t>
-            </a:r>
-            <a:endParaRPr lang="en-US" sz="1300" dirty="0"/>
-          </a:p>
-          <a:p>
-            <a:pPr algn="l" indent="0" marL="0">
-              <a:lnSpc>
-                <a:spcPct val="140000"/>
-              </a:lnSpc>
-              <a:buNone/>
-            </a:pPr>
-            <a:r>
-              <a:rPr lang="en-US" sz="1300" dirty="0">
-                <a:solidFill>
-                  <a:srgbClr val="56676C"/>
-                </a:solidFill>
-                <a:latin typeface="Calibri" pitchFamily="34" charset="0"/>
-                <a:ea typeface="Calibri" pitchFamily="34" charset="-122"/>
-                <a:cs typeface="Calibri" pitchFamily="34" charset="-120"/>
-              </a:rPr>
-              <a:t>·  Caller cannot send an assigned request no. Auto-gen-only is still Relabel.</a:t>
-            </a:r>
-            <a:endParaRPr lang="en-US" sz="1300" dirty="0"/>
-          </a:p>
-        </p:txBody>
-      </p:sp>
-      <p:sp>
-        <p:nvSpPr>
-          <p:cNvPr id="12" name="Shape 10"/>
+        </p:txBody>
+      </p:sp>
+      <p:sp>
+        <p:nvSpPr>
+          <p:cNvPr id="19" name="Shape 17"/>
           <p:cNvSpPr/>
           <p:nvPr/>
         </p:nvSpPr>
@@ -3195,7 +3443,7 @@
       </p:sp>
       <p:sp>
         <p:nvSpPr>
-          <p:cNvPr id="13" name="Text 11"/>
+          <p:cNvPr id="20" name="Text 18"/>
           <p:cNvSpPr/>
           <p:nvPr/>
         </p:nvSpPr>
@@ -3229,7 +3477,7 @@
                 <a:ea typeface="Calibri" pitchFamily="34" charset="-122"/>
                 <a:cs typeface="Calibri" pitchFamily="34" charset="-120"/>
               </a:rPr>
-              <a:t>Relabel is its own status. It is not Failure and not Registered.</a:t>
+              <a:t>Also Failure: missing test dictionary, HKID or name mismatch, APS / BBS / MBS, unknown sorter id.</a:t>
             </a:r>
             <a:endParaRPr lang="en-US" sz="1400" dirty="0"/>
           </a:p>
@@ -3237,7 +3485,7 @@
       </p:sp>
       <p:sp>
         <p:nvSpPr>
-          <p:cNvPr id="14" name="Text 12"/>
+          <p:cNvPr id="21" name="Text 19"/>
           <p:cNvSpPr/>
           <p:nvPr/>
         </p:nvSpPr>
@@ -3271,7 +3519,7 @@
                 <a:ea typeface="Calibri" pitchFamily="34" charset="-122"/>
                 <a:cs typeface="Calibri" pitchFamily="34" charset="-120"/>
               </a:rPr>
-              <a:t>10 / 14</a:t>
+              <a:t>10 / 15</a:t>
             </a:r>
             <a:endParaRPr lang="en-US" sz="900" dirty="0"/>
           </a:p>
@@ -3335,7 +3583,7 @@
                 <a:ea typeface="Calibri" pitchFamily="34" charset="-122"/>
                 <a:cs typeface="Calibri" pitchFamily="34" charset="-120"/>
               </a:rPr>
-              <a:t>WARD AND DOCTOR MAPPING</a:t>
+              <a:t>TEST GROUPING AND REQUEST NO.</a:t>
             </a:r>
             <a:endParaRPr lang="en-US" sz="1100" dirty="0"/>
           </a:p>
@@ -3374,7 +3622,7 @@
                 <a:ea typeface="Cambria" pitchFamily="34" charset="-122"/>
                 <a:cs typeface="Cambria" pitchFamily="34" charset="-120"/>
               </a:rPr>
-              <a:t>The screen maps office codes. The POST fails if a map is missing.</a:t>
+              <a:t>USID is the request no. only when eligible</a:t>
             </a:r>
             <a:endParaRPr lang="en-US" sz="3000" dirty="0"/>
           </a:p>
@@ -3485,7 +3733,7 @@
                 <a:ea typeface="Cambria" pitchFamily="34" charset="-122"/>
                 <a:cs typeface="Cambria" pitchFamily="34" charset="-120"/>
               </a:rPr>
-              <a:t>Map, then popup if empty</a:t>
+              <a:t>Screen groups, then assigns</a:t>
             </a:r>
             <a:endParaRPr lang="en-US" sz="1800" dirty="0"/>
           </a:p>
@@ -3527,7 +3775,7 @@
                 <a:ea typeface="Calibri" pitchFamily="34" charset="-122"/>
                 <a:cs typeface="Calibri" pitchFamily="34" charset="-120"/>
               </a:rPr>
-              <a:t>·  Request doctor, request location, specialty, report destination, and report copy are mapped from dictionary.</a:t>
+              <a:t>·  Tests are grouped before Register. Each group needs a request no.</a:t>
             </a:r>
             <a:endParaRPr lang="en-US" sz="1300" dirty="0"/>
           </a:p>
@@ -3547,7 +3795,7 @@
                 <a:ea typeface="Calibri" pitchFamily="34" charset="-122"/>
                 <a:cs typeface="Calibri" pitchFamily="34" charset="-120"/>
               </a:rPr>
-              <a:t>·  Unmapped doctor, location, specialty, dest, or copy blocks Register.</a:t>
+              <a:t>·  USID can be the request no. when the screen says it is eligible.</a:t>
             </a:r>
             <a:endParaRPr lang="en-US" sz="1300" dirty="0"/>
           </a:p>
@@ -3567,7 +3815,7 @@
                 <a:ea typeface="Calibri" pitchFamily="34" charset="-122"/>
                 <a:cs typeface="Calibri" pitchFamily="34" charset="-120"/>
               </a:rPr>
-              <a:t>·  Staff can create a doctor from the screen when dictionary allows it.</a:t>
+              <a:t>·  Staff can tick Relabel. Multi-group, multi-specimen, suffix not 0, or force: no USID.</a:t>
             </a:r>
             <a:endParaRPr lang="en-US" sz="1300" dirty="0"/>
           </a:p>
@@ -3678,7 +3926,7 @@
                 <a:ea typeface="Cambria" pitchFamily="34" charset="-122"/>
                 <a:cs typeface="Cambria" pitchFamily="34" charset="-120"/>
               </a:rPr>
-              <a:t>Same map. No create.</a:t>
+              <a:t>Same grouping. No checkbox.</a:t>
             </a:r>
             <a:endParaRPr lang="en-US" sz="1800" dirty="0"/>
           </a:p>
@@ -3720,7 +3968,7 @@
                 <a:ea typeface="Calibri" pitchFamily="34" charset="-122"/>
                 <a:cs typeface="Calibri" pitchFamily="34" charset="-120"/>
               </a:rPr>
-              <a:t>·  Same five mappings go onto the packed register call.</a:t>
+              <a:t>·  Same Relabel rules, without a user tick.</a:t>
             </a:r>
             <a:endParaRPr lang="en-US" sz="1300" dirty="0"/>
           </a:p>
@@ -3740,7 +3988,7 @@
                 <a:ea typeface="Calibri" pitchFamily="34" charset="-122"/>
                 <a:cs typeface="Calibri" pitchFamily="34" charset="-120"/>
               </a:rPr>
-              <a:t>·  Any miss is Failure with the same message codes as Spec Ack.</a:t>
+              <a:t>·  One group, one specimen, suffix 0, not force: request no. = USID.</a:t>
             </a:r>
             <a:endParaRPr lang="en-US" sz="1300" dirty="0"/>
           </a:p>
@@ -3760,7 +4008,7 @@
                 <a:ea typeface="Calibri" pitchFamily="34" charset="-122"/>
                 <a:cs typeface="Calibri" pitchFamily="34" charset="-120"/>
               </a:rPr>
-              <a:t>·  Do not auto-create a doctor or a location. Send the tube to staff Spec Ack.</a:t>
+              <a:t>·  Else Relabel. No lab request. No invented number. No caller-assigned request no.</a:t>
             </a:r>
             <a:endParaRPr lang="en-US" sz="1300" dirty="0"/>
           </a:p>
@@ -3829,7 +4077,7 @@
                 <a:ea typeface="Calibri" pitchFamily="34" charset="-122"/>
                 <a:cs typeface="Calibri" pitchFamily="34" charset="-120"/>
               </a:rPr>
-              <a:t>Do not compare workbench lab to the order test lab.</a:t>
+              <a:t>Relabel is its own status. Not Failure. Not Registered.</a:t>
             </a:r>
             <a:endParaRPr lang="en-US" sz="1400" dirty="0"/>
           </a:p>
@@ -3871,7 +4119,7 @@
                 <a:ea typeface="Calibri" pitchFamily="34" charset="-122"/>
                 <a:cs typeface="Calibri" pitchFamily="34" charset="-120"/>
               </a:rPr>
-              <a:t>11 / 14</a:t>
+              <a:t>11 / 15</a:t>
             </a:r>
             <a:endParaRPr lang="en-US" sz="900" dirty="0"/>
           </a:p>
@@ -3935,7 +4183,7 @@
                 <a:ea typeface="Calibri" pitchFamily="34" charset="-122"/>
                 <a:cs typeface="Calibri" pitchFamily="34" charset="-120"/>
               </a:rPr>
-              <a:t>WORKSHEET PRINTING</a:t>
+              <a:t>WARD AND DOCTOR MAPPING</a:t>
             </a:r>
             <a:endParaRPr lang="en-US" sz="1100" dirty="0"/>
           </a:p>
@@ -3974,7 +4222,7 @@
                 <a:ea typeface="Cambria" pitchFamily="34" charset="-122"/>
                 <a:cs typeface="Cambria" pitchFamily="34" charset="-120"/>
               </a:rPr>
-              <a:t>Staff pick a worksheet. The POST prints every one, after it has already returned.</a:t>
+              <a:t>A missing map stops the POST</a:t>
             </a:r>
             <a:endParaRPr lang="en-US" sz="3000" dirty="0"/>
           </a:p>
@@ -4085,7 +4333,7 @@
                 <a:ea typeface="Cambria" pitchFamily="34" charset="-122"/>
                 <a:cs typeface="Cambria" pitchFamily="34" charset="-120"/>
               </a:rPr>
-              <a:t>Print after Register</a:t>
+              <a:t>Map, then popup</a:t>
             </a:r>
             <a:endParaRPr lang="en-US" sz="1800" dirty="0"/>
           </a:p>
@@ -4127,7 +4375,7 @@
                 <a:ea typeface="Calibri" pitchFamily="34" charset="-122"/>
                 <a:cs typeface="Calibri" pitchFamily="34" charset="-120"/>
               </a:rPr>
-              <a:t>·  After a successful register, staff can print GCRS, send-out, and SH worksheets.</a:t>
+              <a:t>·  Doctor, location, specialty, report dest, and report copy come from dictionary.</a:t>
             </a:r>
             <a:endParaRPr lang="en-US" sz="1300" dirty="0"/>
           </a:p>
@@ -4147,7 +4395,7 @@
                 <a:ea typeface="Calibri" pitchFamily="34" charset="-122"/>
                 <a:cs typeface="Calibri" pitchFamily="34" charset="-120"/>
               </a:rPr>
-              <a:t>·  If more than one worksheet, staff pick which to print.</a:t>
+              <a:t>·  Unmapped codes block Register.</a:t>
             </a:r>
             <a:endParaRPr lang="en-US" sz="1300" dirty="0"/>
           </a:p>
@@ -4167,7 +4415,7 @@
                 <a:ea typeface="Calibri" pitchFamily="34" charset="-122"/>
                 <a:cs typeface="Calibri" pitchFamily="34" charset="-120"/>
               </a:rPr>
-              <a:t>·  Labels can also print on the staff path.</a:t>
+              <a:t>·  Staff can create a doctor when dictionary allows it.</a:t>
             </a:r>
             <a:endParaRPr lang="en-US" sz="1300" dirty="0"/>
           </a:p>
@@ -4278,7 +4526,7 @@
                 <a:ea typeface="Cambria" pitchFamily="34" charset="-122"/>
                 <a:cs typeface="Cambria" pitchFamily="34" charset="-120"/>
               </a:rPr>
-              <a:t>Print all, off the wait</a:t>
+              <a:t>Same map. No create.</a:t>
             </a:r>
             <a:endParaRPr lang="en-US" sz="1800" dirty="0"/>
           </a:p>
@@ -4320,7 +4568,7 @@
                 <a:ea typeface="Calibri" pitchFamily="34" charset="-122"/>
                 <a:cs typeface="Calibri" pitchFamily="34" charset="-120"/>
               </a:rPr>
-              <a:t>·  Return REGISTERED first. Then print every worksheet Spec Ack would have. No picker.</a:t>
+              <a:t>·  Same five mappings go onto the packed register call.</a:t>
             </a:r>
             <a:endParaRPr lang="en-US" sz="1300" dirty="0"/>
           </a:p>
@@ -4340,7 +4588,7 @@
                 <a:ea typeface="Calibri" pitchFamily="34" charset="-122"/>
                 <a:cs typeface="Calibri" pitchFamily="34" charset="-120"/>
               </a:rPr>
-              <a:t>·  Send-out, Relabel, and Failure print nothing.</a:t>
+              <a:t>·  Any miss is Failure, same message codes as Spec Ack.</a:t>
             </a:r>
             <a:endParaRPr lang="en-US" sz="1300" dirty="0"/>
           </a:p>
@@ -4360,7 +4608,7 @@
                 <a:ea typeface="Calibri" pitchFamily="34" charset="-122"/>
                 <a:cs typeface="Calibri" pitchFamily="34" charset="-120"/>
               </a:rPr>
-              <a:t>·  No labels. Late worksheet is allowed. Print fail is ALS warn; status stays Registered.</a:t>
+              <a:t>·  Do not auto-create a doctor or location. Send the tube to staff.</a:t>
             </a:r>
             <a:endParaRPr lang="en-US" sz="1300" dirty="0"/>
           </a:p>
@@ -4429,7 +4677,7 @@
                 <a:ea typeface="Calibri" pitchFamily="34" charset="-122"/>
                 <a:cs typeface="Calibri" pitchFamily="34" charset="-120"/>
               </a:rPr>
-              <a:t>p95 under 4 seconds is retrieve plus send-out or register. Print is not on that clock.</a:t>
+              <a:t>Do not compare workbench lab to the order test lab.</a:t>
             </a:r>
             <a:endParaRPr lang="en-US" sz="1400" dirty="0"/>
           </a:p>
@@ -4471,7 +4719,7 @@
                 <a:ea typeface="Calibri" pitchFamily="34" charset="-122"/>
                 <a:cs typeface="Calibri" pitchFamily="34" charset="-120"/>
               </a:rPr>
-              <a:t>12 / 14</a:t>
+              <a:t>12 / 15</a:t>
             </a:r>
             <a:endParaRPr lang="en-US" sz="900" dirty="0"/>
           </a:p>
@@ -4535,7 +4783,7 @@
                 <a:ea typeface="Calibri" pitchFamily="34" charset="-122"/>
                 <a:cs typeface="Calibri" pitchFamily="34" charset="-120"/>
               </a:rPr>
-              <a:t>PHLC ELECTRONIC ORDER</a:t>
+              <a:t>WORKSHEET PRINTING</a:t>
             </a:r>
             <a:endParaRPr lang="en-US" sz="1100" dirty="0"/>
           </a:p>
@@ -4574,7 +4822,7 @@
                 <a:ea typeface="Cambria" pitchFamily="34" charset="-122"/>
                 <a:cs typeface="Cambria" pitchFamily="34" charset="-120"/>
               </a:rPr>
-              <a:t>PHLC stays a backend create. The POST calls it only after Registered.</a:t>
+              <a:t>Print all after Registered, not before</a:t>
             </a:r>
             <a:endParaRPr lang="en-US" sz="3000" dirty="0"/>
           </a:p>
@@ -4685,7 +4933,7 @@
                 <a:ea typeface="Cambria" pitchFamily="34" charset="-122"/>
                 <a:cs typeface="Cambria" pitchFamily="34" charset="-120"/>
               </a:rPr>
-              <a:t>Screen calls PHLC after register</a:t>
+              <a:t>Staff print after Register</a:t>
             </a:r>
             <a:endParaRPr lang="en-US" sz="1800" dirty="0"/>
           </a:p>
@@ -4727,7 +4975,7 @@
                 <a:ea typeface="Calibri" pitchFamily="34" charset="-122"/>
                 <a:cs typeface="Calibri" pitchFamily="34" charset="-120"/>
               </a:rPr>
-              <a:t>·  After Register, Spec Ack creates a PHLC electronic order when the lab option is on.</a:t>
+              <a:t>·  Staff can print GCRS, send-out, and SH worksheets after register.</a:t>
             </a:r>
             <a:endParaRPr lang="en-US" sz="1300" dirty="0"/>
           </a:p>
@@ -4747,7 +4995,7 @@
                 <a:ea typeface="Calibri" pitchFamily="34" charset="-122"/>
                 <a:cs typeface="Calibri" pitchFamily="34" charset="-120"/>
               </a:rPr>
-              <a:t>·  Destination must match the PHLC rule Spec Ack already uses.</a:t>
+              <a:t>·  If more than one worksheet, staff pick.</a:t>
             </a:r>
             <a:endParaRPr lang="en-US" sz="1300" dirty="0"/>
           </a:p>
@@ -4767,7 +5015,7 @@
                 <a:ea typeface="Calibri" pitchFamily="34" charset="-122"/>
                 <a:cs typeface="Calibri" pitchFamily="34" charset="-120"/>
               </a:rPr>
-              <a:t>·  Staff wait on the screen for that call.</a:t>
+              <a:t>·  Labels can also print on the staff path.</a:t>
             </a:r>
             <a:endParaRPr lang="en-US" sz="1300" dirty="0"/>
           </a:p>
@@ -4878,7 +5126,7 @@
                 <a:ea typeface="Cambria" pitchFamily="34" charset="-122"/>
                 <a:cs typeface="Cambria" pitchFamily="34" charset="-120"/>
               </a:rPr>
-              <a:t>Same create, after HTTP return</a:t>
+              <a:t>Print all, after the HTTP return</a:t>
             </a:r>
             <a:endParaRPr lang="en-US" sz="1800" dirty="0"/>
           </a:p>
@@ -4920,7 +5168,7 @@
                 <a:ea typeface="Calibri" pitchFamily="34" charset="-122"/>
                 <a:cs typeface="Calibri" pitchFamily="34" charset="-120"/>
               </a:rPr>
-              <a:t>·  Same PHLC create as Spec Ack, in-process, after REGISTERED is already back.</a:t>
+              <a:t>·  Return REGISTERED first. Then print every worksheet Spec Ack would. No picker.</a:t>
             </a:r>
             <a:endParaRPr lang="en-US" sz="1300" dirty="0"/>
           </a:p>
@@ -4940,7 +5188,7 @@
                 <a:ea typeface="Calibri" pitchFamily="34" charset="-122"/>
                 <a:cs typeface="Calibri" pitchFamily="34" charset="-120"/>
               </a:rPr>
-              <a:t>·  Only when Spec Ack would send to PHLC. Send-out, Relabel, and Failure skip it.</a:t>
+              <a:t>·  Send-out, Relabel, and Failure print nothing. No labels.</a:t>
             </a:r>
             <a:endParaRPr lang="en-US" sz="1300" dirty="0"/>
           </a:p>
@@ -4960,7 +5208,7 @@
                 <a:ea typeface="Calibri" pitchFamily="34" charset="-122"/>
                 <a:cs typeface="Calibri" pitchFamily="34" charset="-120"/>
               </a:rPr>
-              <a:t>·  PHLC fail is ALS warn. The sorter status stays Registered.</a:t>
+              <a:t>·  Late worksheet is allowed. Print fail is ALS. Status stays Registered.</a:t>
             </a:r>
             <a:endParaRPr lang="en-US" sz="1300" dirty="0"/>
           </a:p>
@@ -5029,7 +5277,7 @@
                 <a:ea typeface="Calibri" pitchFamily="34" charset="-122"/>
                 <a:cs typeface="Calibri" pitchFamily="34" charset="-120"/>
               </a:rPr>
-              <a:t>No labels on the sorter path. Worksheet and PHLC never run on Send-out.</a:t>
+              <a:t>p95 under 4 seconds is retrieve plus send-out or register. Print is off that clock.</a:t>
             </a:r>
             <a:endParaRPr lang="en-US" sz="1400" dirty="0"/>
           </a:p>
@@ -5071,7 +5319,7 @@
                 <a:ea typeface="Calibri" pitchFamily="34" charset="-122"/>
                 <a:cs typeface="Calibri" pitchFamily="34" charset="-120"/>
               </a:rPr>
-              <a:t>13 / 14</a:t>
+              <a:t>13 / 15</a:t>
             </a:r>
             <a:endParaRPr lang="en-US" sz="900" dirty="0"/>
           </a:p>
@@ -5088,6 +5336,606 @@
 <file path=ppt/slides/slide14.xml><?xml version="1.0" encoding="utf-8"?>
 <p:sld xmlns:a="http://schemas.openxmlformats.org/drawingml/2006/main" xmlns:r="http://schemas.openxmlformats.org/officeDocument/2006/relationships" xmlns:p="http://schemas.openxmlformats.org/presentationml/2006/main">
   <p:cSld name="Slide 14">
+    <p:spTree>
+      <p:nvGrpSpPr>
+        <p:cNvPr id="1" name=""/>
+        <p:cNvGrpSpPr/>
+        <p:nvPr/>
+      </p:nvGrpSpPr>
+      <p:grpSpPr>
+        <a:xfrm>
+          <a:off x="0" y="0"/>
+          <a:ext cx="0" cy="0"/>
+          <a:chOff x="0" y="0"/>
+          <a:chExt cx="0" cy="0"/>
+        </a:xfrm>
+      </p:grpSpPr>
+      <p:sp>
+        <p:nvSpPr>
+          <p:cNvPr id="2" name="Text 0"/>
+          <p:cNvSpPr/>
+          <p:nvPr/>
+        </p:nvSpPr>
+        <p:spPr>
+          <a:xfrm>
+            <a:off x="548640" y="347472"/>
+            <a:ext cx="8229600" cy="274320"/>
+          </a:xfrm>
+          <a:prstGeom prst="rect">
+            <a:avLst/>
+          </a:prstGeom>
+          <a:noFill/>
+          <a:ln/>
+        </p:spPr>
+        <p:txBody>
+          <a:bodyPr wrap="square" rtlCol="0" anchor="ctr"/>
+          <a:lstStyle/>
+          <a:p>
+            <a:pPr indent="0" marL="0">
+              <a:buNone/>
+            </a:pPr>
+            <a:r>
+              <a:rPr lang="en-US" sz="1100" spc="140" kern="0" dirty="0">
+                <a:solidFill>
+                  <a:srgbClr val="0B6E7F"/>
+                </a:solidFill>
+                <a:latin typeface="Calibri" pitchFamily="34" charset="0"/>
+                <a:ea typeface="Calibri" pitchFamily="34" charset="-122"/>
+                <a:cs typeface="Calibri" pitchFamily="34" charset="-120"/>
+              </a:rPr>
+              <a:t>PHLC ELECTRONIC ORDER</a:t>
+            </a:r>
+            <a:endParaRPr lang="en-US" sz="1100" dirty="0"/>
+          </a:p>
+        </p:txBody>
+      </p:sp>
+      <p:sp>
+        <p:nvSpPr>
+          <p:cNvPr id="3" name="Text 1"/>
+          <p:cNvSpPr/>
+          <p:nvPr/>
+        </p:nvSpPr>
+        <p:spPr>
+          <a:xfrm>
+            <a:off x="548640" y="621792"/>
+            <a:ext cx="10515600" cy="640080"/>
+          </a:xfrm>
+          <a:prstGeom prst="rect">
+            <a:avLst/>
+          </a:prstGeom>
+          <a:noFill/>
+          <a:ln/>
+        </p:spPr>
+        <p:txBody>
+          <a:bodyPr wrap="square" rtlCol="0" anchor="ctr"/>
+          <a:lstStyle/>
+          <a:p>
+            <a:pPr indent="0" marL="0">
+              <a:buNone/>
+            </a:pPr>
+            <a:r>
+              <a:rPr lang="en-US" sz="3000" dirty="0">
+                <a:solidFill>
+                  <a:srgbClr val="08323B"/>
+                </a:solidFill>
+                <a:latin typeface="Cambria" pitchFamily="34" charset="0"/>
+                <a:ea typeface="Cambria" pitchFamily="34" charset="-122"/>
+                <a:cs typeface="Cambria" pitchFamily="34" charset="-120"/>
+              </a:rPr>
+              <a:t>PHLC after Registered, after return</a:t>
+            </a:r>
+            <a:endParaRPr lang="en-US" sz="3000" dirty="0"/>
+          </a:p>
+        </p:txBody>
+      </p:sp>
+      <p:sp>
+        <p:nvSpPr>
+          <p:cNvPr id="4" name="Shape 2"/>
+          <p:cNvSpPr/>
+          <p:nvPr/>
+        </p:nvSpPr>
+        <p:spPr>
+          <a:xfrm>
+            <a:off x="548640" y="1737360"/>
+            <a:ext cx="5394960" cy="3063240"/>
+          </a:xfrm>
+          <a:prstGeom prst="roundRect">
+            <a:avLst>
+              <a:gd name="adj" fmla="val 1194"/>
+            </a:avLst>
+          </a:prstGeom>
+          <a:solidFill>
+            <a:srgbClr val="F1F3F3"/>
+          </a:solidFill>
+          <a:ln w="12700">
+            <a:solidFill>
+              <a:srgbClr val="F1F3F3"/>
+            </a:solidFill>
+            <a:prstDash val="solid"/>
+          </a:ln>
+        </p:spPr>
+      </p:sp>
+      <p:sp>
+        <p:nvSpPr>
+          <p:cNvPr id="5" name="Text 3"/>
+          <p:cNvSpPr/>
+          <p:nvPr/>
+        </p:nvSpPr>
+        <p:spPr>
+          <a:xfrm>
+            <a:off x="822960" y="1956816"/>
+            <a:ext cx="4846320" cy="256032"/>
+          </a:xfrm>
+          <a:prstGeom prst="rect">
+            <a:avLst/>
+          </a:prstGeom>
+          <a:noFill/>
+          <a:ln/>
+        </p:spPr>
+        <p:txBody>
+          <a:bodyPr wrap="square" rtlCol="0" anchor="t"/>
+          <a:lstStyle/>
+          <a:p>
+            <a:pPr algn="l" indent="0" marL="0">
+              <a:lnSpc>
+                <a:spcPct val="115000"/>
+              </a:lnSpc>
+              <a:buNone/>
+            </a:pPr>
+            <a:r>
+              <a:rPr lang="en-US" sz="900" dirty="0">
+                <a:solidFill>
+                  <a:srgbClr val="56676C"/>
+                </a:solidFill>
+                <a:latin typeface="Calibri" pitchFamily="34" charset="0"/>
+                <a:ea typeface="Calibri" pitchFamily="34" charset="-122"/>
+                <a:cs typeface="Calibri" pitchFamily="34" charset="-120"/>
+              </a:rPr>
+              <a:t>MANUAL</a:t>
+            </a:r>
+            <a:endParaRPr lang="en-US" sz="900" dirty="0"/>
+          </a:p>
+        </p:txBody>
+      </p:sp>
+      <p:sp>
+        <p:nvSpPr>
+          <p:cNvPr id="6" name="Text 4"/>
+          <p:cNvSpPr/>
+          <p:nvPr/>
+        </p:nvSpPr>
+        <p:spPr>
+          <a:xfrm>
+            <a:off x="822960" y="2267712"/>
+            <a:ext cx="4846320" cy="457200"/>
+          </a:xfrm>
+          <a:prstGeom prst="rect">
+            <a:avLst/>
+          </a:prstGeom>
+          <a:noFill/>
+          <a:ln/>
+        </p:spPr>
+        <p:txBody>
+          <a:bodyPr wrap="square" rtlCol="0" anchor="t"/>
+          <a:lstStyle/>
+          <a:p>
+            <a:pPr algn="l" indent="0" marL="0">
+              <a:lnSpc>
+                <a:spcPct val="115000"/>
+              </a:lnSpc>
+              <a:buNone/>
+            </a:pPr>
+            <a:r>
+              <a:rPr lang="en-US" sz="1800" dirty="0">
+                <a:solidFill>
+                  <a:srgbClr val="08323B"/>
+                </a:solidFill>
+                <a:latin typeface="Cambria" pitchFamily="34" charset="0"/>
+                <a:ea typeface="Cambria" pitchFamily="34" charset="-122"/>
+                <a:cs typeface="Cambria" pitchFamily="34" charset="-120"/>
+              </a:rPr>
+              <a:t>Screen calls PHLC after register</a:t>
+            </a:r>
+            <a:endParaRPr lang="en-US" sz="1800" dirty="0"/>
+          </a:p>
+        </p:txBody>
+      </p:sp>
+      <p:sp>
+        <p:nvSpPr>
+          <p:cNvPr id="7" name="Text 5"/>
+          <p:cNvSpPr/>
+          <p:nvPr/>
+        </p:nvSpPr>
+        <p:spPr>
+          <a:xfrm>
+            <a:off x="822960" y="2816352"/>
+            <a:ext cx="4846320" cy="1801368"/>
+          </a:xfrm>
+          <a:prstGeom prst="rect">
+            <a:avLst/>
+          </a:prstGeom>
+          <a:noFill/>
+          <a:ln/>
+        </p:spPr>
+        <p:txBody>
+          <a:bodyPr wrap="square" rtlCol="0" anchor="t"/>
+          <a:lstStyle/>
+          <a:p>
+            <a:pPr algn="l" indent="0" marL="0">
+              <a:lnSpc>
+                <a:spcPct val="140000"/>
+              </a:lnSpc>
+              <a:buNone/>
+            </a:pPr>
+            <a:r>
+              <a:rPr lang="en-US" sz="1300" dirty="0">
+                <a:solidFill>
+                  <a:srgbClr val="56676C"/>
+                </a:solidFill>
+                <a:latin typeface="Calibri" pitchFamily="34" charset="0"/>
+                <a:ea typeface="Calibri" pitchFamily="34" charset="-122"/>
+                <a:cs typeface="Calibri" pitchFamily="34" charset="-120"/>
+              </a:rPr>
+              <a:t>·  Spec Ack creates a PHLC order when the lab option is on.</a:t>
+            </a:r>
+            <a:endParaRPr lang="en-US" sz="1300" dirty="0"/>
+          </a:p>
+          <a:p>
+            <a:pPr algn="l" indent="0" marL="0">
+              <a:lnSpc>
+                <a:spcPct val="140000"/>
+              </a:lnSpc>
+              <a:buNone/>
+            </a:pPr>
+            <a:r>
+              <a:rPr lang="en-US" sz="1300" dirty="0">
+                <a:solidFill>
+                  <a:srgbClr val="56676C"/>
+                </a:solidFill>
+                <a:latin typeface="Calibri" pitchFamily="34" charset="0"/>
+                <a:ea typeface="Calibri" pitchFamily="34" charset="-122"/>
+                <a:cs typeface="Calibri" pitchFamily="34" charset="-120"/>
+              </a:rPr>
+              <a:t>·  Destination must match the existing PHLC rule.</a:t>
+            </a:r>
+            <a:endParaRPr lang="en-US" sz="1300" dirty="0"/>
+          </a:p>
+          <a:p>
+            <a:pPr algn="l" indent="0" marL="0">
+              <a:lnSpc>
+                <a:spcPct val="140000"/>
+              </a:lnSpc>
+              <a:buNone/>
+            </a:pPr>
+            <a:r>
+              <a:rPr lang="en-US" sz="1300" dirty="0">
+                <a:solidFill>
+                  <a:srgbClr val="56676C"/>
+                </a:solidFill>
+                <a:latin typeface="Calibri" pitchFamily="34" charset="0"/>
+                <a:ea typeface="Calibri" pitchFamily="34" charset="-122"/>
+                <a:cs typeface="Calibri" pitchFamily="34" charset="-120"/>
+              </a:rPr>
+              <a:t>·  Staff wait on the screen for that call.</a:t>
+            </a:r>
+            <a:endParaRPr lang="en-US" sz="1300" dirty="0"/>
+          </a:p>
+        </p:txBody>
+      </p:sp>
+      <p:sp>
+        <p:nvSpPr>
+          <p:cNvPr id="8" name="Shape 6"/>
+          <p:cNvSpPr/>
+          <p:nvPr/>
+        </p:nvSpPr>
+        <p:spPr>
+          <a:xfrm>
+            <a:off x="6245352" y="1737360"/>
+            <a:ext cx="5394960" cy="3063240"/>
+          </a:xfrm>
+          <a:prstGeom prst="roundRect">
+            <a:avLst>
+              <a:gd name="adj" fmla="val 1194"/>
+            </a:avLst>
+          </a:prstGeom>
+          <a:solidFill>
+            <a:srgbClr val="E4F0F2"/>
+          </a:solidFill>
+          <a:ln w="12700">
+            <a:solidFill>
+              <a:srgbClr val="E4F0F2"/>
+            </a:solidFill>
+            <a:prstDash val="solid"/>
+          </a:ln>
+        </p:spPr>
+      </p:sp>
+      <p:sp>
+        <p:nvSpPr>
+          <p:cNvPr id="9" name="Text 7"/>
+          <p:cNvSpPr/>
+          <p:nvPr/>
+        </p:nvSpPr>
+        <p:spPr>
+          <a:xfrm>
+            <a:off x="6519672" y="1956816"/>
+            <a:ext cx="4846320" cy="256032"/>
+          </a:xfrm>
+          <a:prstGeom prst="rect">
+            <a:avLst/>
+          </a:prstGeom>
+          <a:noFill/>
+          <a:ln/>
+        </p:spPr>
+        <p:txBody>
+          <a:bodyPr wrap="square" rtlCol="0" anchor="t"/>
+          <a:lstStyle/>
+          <a:p>
+            <a:pPr algn="l" indent="0" marL="0">
+              <a:lnSpc>
+                <a:spcPct val="115000"/>
+              </a:lnSpc>
+              <a:buNone/>
+            </a:pPr>
+            <a:r>
+              <a:rPr lang="en-US" sz="900" dirty="0">
+                <a:solidFill>
+                  <a:srgbClr val="0B6E7F"/>
+                </a:solidFill>
+                <a:latin typeface="Calibri" pitchFamily="34" charset="0"/>
+                <a:ea typeface="Calibri" pitchFamily="34" charset="-122"/>
+                <a:cs typeface="Calibri" pitchFamily="34" charset="-120"/>
+              </a:rPr>
+              <a:t>SORTER POST</a:t>
+            </a:r>
+            <a:endParaRPr lang="en-US" sz="900" dirty="0"/>
+          </a:p>
+        </p:txBody>
+      </p:sp>
+      <p:sp>
+        <p:nvSpPr>
+          <p:cNvPr id="10" name="Text 8"/>
+          <p:cNvSpPr/>
+          <p:nvPr/>
+        </p:nvSpPr>
+        <p:spPr>
+          <a:xfrm>
+            <a:off x="6519672" y="2267712"/>
+            <a:ext cx="4846320" cy="457200"/>
+          </a:xfrm>
+          <a:prstGeom prst="rect">
+            <a:avLst/>
+          </a:prstGeom>
+          <a:noFill/>
+          <a:ln/>
+        </p:spPr>
+        <p:txBody>
+          <a:bodyPr wrap="square" rtlCol="0" anchor="t"/>
+          <a:lstStyle/>
+          <a:p>
+            <a:pPr algn="l" indent="0" marL="0">
+              <a:lnSpc>
+                <a:spcPct val="115000"/>
+              </a:lnSpc>
+              <a:buNone/>
+            </a:pPr>
+            <a:r>
+              <a:rPr lang="en-US" sz="1800" dirty="0">
+                <a:solidFill>
+                  <a:srgbClr val="08323B"/>
+                </a:solidFill>
+                <a:latin typeface="Cambria" pitchFamily="34" charset="0"/>
+                <a:ea typeface="Cambria" pitchFamily="34" charset="-122"/>
+                <a:cs typeface="Cambria" pitchFamily="34" charset="-120"/>
+              </a:rPr>
+              <a:t>Same create. Sorter does not wait.</a:t>
+            </a:r>
+            <a:endParaRPr lang="en-US" sz="1800" dirty="0"/>
+          </a:p>
+        </p:txBody>
+      </p:sp>
+      <p:sp>
+        <p:nvSpPr>
+          <p:cNvPr id="11" name="Text 9"/>
+          <p:cNvSpPr/>
+          <p:nvPr/>
+        </p:nvSpPr>
+        <p:spPr>
+          <a:xfrm>
+            <a:off x="6519672" y="2816352"/>
+            <a:ext cx="4846320" cy="1801368"/>
+          </a:xfrm>
+          <a:prstGeom prst="rect">
+            <a:avLst/>
+          </a:prstGeom>
+          <a:noFill/>
+          <a:ln/>
+        </p:spPr>
+        <p:txBody>
+          <a:bodyPr wrap="square" rtlCol="0" anchor="t"/>
+          <a:lstStyle/>
+          <a:p>
+            <a:pPr algn="l" indent="0" marL="0">
+              <a:lnSpc>
+                <a:spcPct val="140000"/>
+              </a:lnSpc>
+              <a:buNone/>
+            </a:pPr>
+            <a:r>
+              <a:rPr lang="en-US" sz="1300" dirty="0">
+                <a:solidFill>
+                  <a:srgbClr val="56676C"/>
+                </a:solidFill>
+                <a:latin typeface="Calibri" pitchFamily="34" charset="0"/>
+                <a:ea typeface="Calibri" pitchFamily="34" charset="-122"/>
+                <a:cs typeface="Calibri" pitchFamily="34" charset="-120"/>
+              </a:rPr>
+              <a:t>·  Same PHLC create, in-process, after REGISTERED is already back.</a:t>
+            </a:r>
+            <a:endParaRPr lang="en-US" sz="1300" dirty="0"/>
+          </a:p>
+          <a:p>
+            <a:pPr algn="l" indent="0" marL="0">
+              <a:lnSpc>
+                <a:spcPct val="140000"/>
+              </a:lnSpc>
+              <a:buNone/>
+            </a:pPr>
+            <a:r>
+              <a:rPr lang="en-US" sz="1300" dirty="0">
+                <a:solidFill>
+                  <a:srgbClr val="56676C"/>
+                </a:solidFill>
+                <a:latin typeface="Calibri" pitchFamily="34" charset="0"/>
+                <a:ea typeface="Calibri" pitchFamily="34" charset="-122"/>
+                <a:cs typeface="Calibri" pitchFamily="34" charset="-120"/>
+              </a:rPr>
+              <a:t>·  Only when Spec Ack would send. Send-out, Relabel, and Failure skip it.</a:t>
+            </a:r>
+            <a:endParaRPr lang="en-US" sz="1300" dirty="0"/>
+          </a:p>
+          <a:p>
+            <a:pPr algn="l" indent="0" marL="0">
+              <a:lnSpc>
+                <a:spcPct val="140000"/>
+              </a:lnSpc>
+              <a:buNone/>
+            </a:pPr>
+            <a:r>
+              <a:rPr lang="en-US" sz="1300" dirty="0">
+                <a:solidFill>
+                  <a:srgbClr val="56676C"/>
+                </a:solidFill>
+                <a:latin typeface="Calibri" pitchFamily="34" charset="0"/>
+                <a:ea typeface="Calibri" pitchFamily="34" charset="-122"/>
+                <a:cs typeface="Calibri" pitchFamily="34" charset="-120"/>
+              </a:rPr>
+              <a:t>·  PHLC fail is ALS. Sorter status stays Registered.</a:t>
+            </a:r>
+            <a:endParaRPr lang="en-US" sz="1300" dirty="0"/>
+          </a:p>
+        </p:txBody>
+      </p:sp>
+      <p:sp>
+        <p:nvSpPr>
+          <p:cNvPr id="12" name="Shape 10"/>
+          <p:cNvSpPr/>
+          <p:nvPr/>
+        </p:nvSpPr>
+        <p:spPr>
+          <a:xfrm>
+            <a:off x="548640" y="4983480"/>
+            <a:ext cx="11091672" cy="868680"/>
+          </a:xfrm>
+          <a:prstGeom prst="roundRect">
+            <a:avLst>
+              <a:gd name="adj" fmla="val 4211"/>
+            </a:avLst>
+          </a:prstGeom>
+          <a:solidFill>
+            <a:srgbClr val="FAEEDB"/>
+          </a:solidFill>
+          <a:ln w="12700">
+            <a:solidFill>
+              <a:srgbClr val="FAEEDB"/>
+            </a:solidFill>
+            <a:prstDash val="solid"/>
+          </a:ln>
+        </p:spPr>
+      </p:sp>
+      <p:sp>
+        <p:nvSpPr>
+          <p:cNvPr id="13" name="Text 11"/>
+          <p:cNvSpPr/>
+          <p:nvPr/>
+        </p:nvSpPr>
+        <p:spPr>
+          <a:xfrm>
+            <a:off x="868680" y="5120640"/>
+            <a:ext cx="10424160" cy="594360"/>
+          </a:xfrm>
+          <a:prstGeom prst="rect">
+            <a:avLst/>
+          </a:prstGeom>
+          <a:noFill/>
+          <a:ln/>
+        </p:spPr>
+        <p:txBody>
+          <a:bodyPr wrap="square" rtlCol="0" anchor="ctr"/>
+          <a:lstStyle/>
+          <a:p>
+            <a:pPr algn="l" indent="0" marL="0">
+              <a:lnSpc>
+                <a:spcPct val="120000"/>
+              </a:lnSpc>
+              <a:buNone/>
+            </a:pPr>
+            <a:r>
+              <a:rPr lang="en-US" sz="1400" dirty="0">
+                <a:solidFill>
+                  <a:srgbClr val="08323B"/>
+                </a:solidFill>
+                <a:latin typeface="Calibri" pitchFamily="34" charset="0"/>
+                <a:ea typeface="Calibri" pitchFamily="34" charset="-122"/>
+                <a:cs typeface="Calibri" pitchFamily="34" charset="-120"/>
+              </a:rPr>
+              <a:t>No labels on the sorter path. Worksheet and PHLC never run on Send-out.</a:t>
+            </a:r>
+            <a:endParaRPr lang="en-US" sz="1400" dirty="0"/>
+          </a:p>
+        </p:txBody>
+      </p:sp>
+      <p:sp>
+        <p:nvSpPr>
+          <p:cNvPr id="14" name="Text 12"/>
+          <p:cNvSpPr/>
+          <p:nvPr/>
+        </p:nvSpPr>
+        <p:spPr>
+          <a:xfrm>
+            <a:off x="10405872" y="6144768"/>
+            <a:ext cx="1097280" cy="201168"/>
+          </a:xfrm>
+          <a:prstGeom prst="rect">
+            <a:avLst/>
+          </a:prstGeom>
+          <a:noFill/>
+          <a:ln/>
+        </p:spPr>
+        <p:txBody>
+          <a:bodyPr wrap="square" rtlCol="0" anchor="t"/>
+          <a:lstStyle/>
+          <a:p>
+            <a:pPr algn="r" indent="0" marL="0">
+              <a:lnSpc>
+                <a:spcPct val="115000"/>
+              </a:lnSpc>
+              <a:buNone/>
+            </a:pPr>
+            <a:r>
+              <a:rPr lang="en-US" sz="900" dirty="0">
+                <a:solidFill>
+                  <a:srgbClr val="56676C"/>
+                </a:solidFill>
+                <a:latin typeface="Calibri" pitchFamily="34" charset="0"/>
+                <a:ea typeface="Calibri" pitchFamily="34" charset="-122"/>
+                <a:cs typeface="Calibri" pitchFamily="34" charset="-120"/>
+              </a:rPr>
+              <a:t>14 / 15</a:t>
+            </a:r>
+            <a:endParaRPr lang="en-US" sz="900" dirty="0"/>
+          </a:p>
+        </p:txBody>
+      </p:sp>
+    </p:spTree>
+  </p:cSld>
+  <p:clrMapOvr>
+    <a:masterClrMapping/>
+  </p:clrMapOvr>
+</p:sld>
+</file>
+
+<file path=ppt/slides/slide15.xml><?xml version="1.0" encoding="utf-8"?>
+<p:sld xmlns:a="http://schemas.openxmlformats.org/drawingml/2006/main" xmlns:r="http://schemas.openxmlformats.org/officeDocument/2006/relationships" xmlns:p="http://schemas.openxmlformats.org/presentationml/2006/main">
+  <p:cSld name="Slide 15">
     <p:bg>
       <p:bgPr>
         <a:solidFill>
@@ -5889,7 +6737,7 @@
                 <a:ea typeface="Calibri" pitchFamily="34" charset="-122"/>
                 <a:cs typeface="Calibri" pitchFamily="34" charset="-120"/>
               </a:rPr>
-              <a:t>14 / 14</a:t>
+              <a:t>15 / 15</a:t>
             </a:r>
             <a:endParaRPr lang="en-US" sz="900" dirty="0"/>
           </a:p>
@@ -6778,7 +7626,7 @@
                 <a:ea typeface="Calibri" pitchFamily="34" charset="-122"/>
                 <a:cs typeface="Calibri" pitchFamily="34" charset="-120"/>
               </a:rPr>
-              <a:t>   Registered only, after return</a:t>
+              <a:t>   then PHLC, Registered only</a:t>
             </a:r>
             <a:endParaRPr lang="en-US" sz="1500" dirty="0"/>
           </a:p>
@@ -6820,7 +7668,7 @@
                 <a:ea typeface="Calibri" pitchFamily="34" charset="-122"/>
                 <a:cs typeface="Calibri" pitchFamily="34" charset="-120"/>
               </a:rPr>
-              <a:t>2 / 14</a:t>
+              <a:t>2 / 15</a:t>
             </a:r>
             <a:endParaRPr lang="en-US" sz="900" dirty="0"/>
           </a:p>
@@ -6923,7 +7771,7 @@
                 <a:ea typeface="Cambria" pitchFamily="34" charset="-122"/>
                 <a:cs typeface="Cambria" pitchFamily="34" charset="-120"/>
               </a:rPr>
-              <a:t>The screen still owns the click path. The POST owns the sorter path.</a:t>
+              <a:t>Staff keep the clicks. The POST owns the sorter.</a:t>
             </a:r>
             <a:endParaRPr lang="en-US" sz="3000" dirty="0"/>
           </a:p>
@@ -6965,7 +7813,7 @@
                 <a:ea typeface="Cambria" pitchFamily="34" charset="-122"/>
                 <a:cs typeface="Cambria" pitchFamily="34" charset="-120"/>
               </a:rPr>
-              <a:t>Middleware sends a USID and sorter id. LIS decides the bin. Staff Spec Ack does not change.</a:t>
+              <a:t>Middleware sends a USID and sorter id. LIS returns the bin.</a:t>
             </a:r>
             <a:endParaRPr lang="en-US" sz="1700" dirty="0"/>
           </a:p>
@@ -7121,7 +7969,7 @@
                 <a:ea typeface="Calibri" pitchFamily="34" charset="-122"/>
                 <a:cs typeface="Calibri" pitchFamily="34" charset="-120"/>
               </a:rPr>
-              <a:t>Staff scan, see alerts, press Send-out or Register. Packing and checks run on the screen first.</a:t>
+              <a:t>Staff scan, see alerts, then press Send-out or Register. Packing runs on the screen.</a:t>
             </a:r>
             <a:endParaRPr lang="en-US" sz="1250" dirty="0"/>
           </a:p>
@@ -7277,7 +8125,7 @@
                 <a:ea typeface="Calibri" pitchFamily="34" charset="-122"/>
                 <a:cs typeface="Calibri" pitchFamily="34" charset="-120"/>
               </a:rPr>
-              <a:t>One call on the Spec Ack service. Same retrieve, send-out, register, print, and PHLC writes. Soft text stays off the body.</a:t>
+              <a:t>One call. Same retrieve, send-out, register, print, and PHLC writes. Soft text is not on the body.</a:t>
             </a:r>
             <a:endParaRPr lang="en-US" sz="1250" dirty="0"/>
           </a:p>
@@ -7433,7 +8281,7 @@
                 <a:ea typeface="Calibri" pitchFamily="34" charset="-122"/>
                 <a:cs typeface="Calibri" pitchFamily="34" charset="-120"/>
               </a:rPr>
-              <a:t>Relabel and Failure bins go back to staff Spec Ack. No new screen.</a:t>
+              <a:t>Relabel and Failure go back to staff Spec Ack. No new screen.</a:t>
             </a:r>
             <a:endParaRPr lang="en-US" sz="1250" dirty="0"/>
           </a:p>
@@ -7519,7 +8367,7 @@
                 <a:ea typeface="Calibri" pitchFamily="34" charset="-122"/>
                 <a:cs typeface="Calibri" pitchFamily="34" charset="-120"/>
               </a:rPr>
-              <a:t>Confirm each action below matches today's Spec Ack rule, except mixed send-out and the staff checkbox.</a:t>
+              <a:t>Confirm each action matches Spec Ack, except mixed send-out and the Relabel checkbox.</a:t>
             </a:r>
             <a:endParaRPr lang="en-US" sz="1400" dirty="0"/>
           </a:p>
@@ -7561,7 +8409,7 @@
                 <a:ea typeface="Calibri" pitchFamily="34" charset="-122"/>
                 <a:cs typeface="Calibri" pitchFamily="34" charset="-120"/>
               </a:rPr>
-              <a:t>3 / 14</a:t>
+              <a:t>3 / 15</a:t>
             </a:r>
             <a:endParaRPr lang="en-US" sz="900" dirty="0"/>
           </a:p>
@@ -7664,7 +8512,7 @@
                 <a:ea typeface="Cambria" pitchFamily="34" charset="-122"/>
                 <a:cs typeface="Cambria" pitchFamily="34" charset="-120"/>
               </a:rPr>
-              <a:t>Staff can search several keys. The sorter sends a USID only.</a:t>
+              <a:t>Sorter lookup is USID only</a:t>
             </a:r>
             <a:endParaRPr lang="en-US" sz="3000" dirty="0"/>
           </a:p>
@@ -7837,7 +8685,7 @@
                 <a:ea typeface="Calibri" pitchFamily="34" charset="-122"/>
                 <a:cs typeface="Calibri" pitchFamily="34" charset="-120"/>
               </a:rPr>
-              <a:t>·  Format, allowed sending hospital, and check digit run first.</a:t>
+              <a:t>·  Format, allowed hospital, and check digit run first.</a:t>
             </a:r>
             <a:endParaRPr lang="en-US" sz="1300" dirty="0"/>
           </a:p>
@@ -7858,26 +8706,6 @@
                 <a:cs typeface="Calibri" pitchFamily="34" charset="-120"/>
               </a:rPr>
               <a:t>·  Not found stops the screen (1336 / 1337 / 1338 / 1377).</a:t>
-            </a:r>
-            <a:endParaRPr lang="en-US" sz="1300" dirty="0"/>
-          </a:p>
-          <a:p>
-            <a:pPr algn="l" indent="0" marL="0">
-              <a:lnSpc>
-                <a:spcPct val="140000"/>
-              </a:lnSpc>
-              <a:buNone/>
-            </a:pPr>
-            <a:r>
-              <a:rPr lang="en-US" sz="1300" dirty="0">
-                <a:solidFill>
-                  <a:srgbClr val="56676C"/>
-                </a:solidFill>
-                <a:latin typeface="Calibri" pitchFamily="34" charset="0"/>
-                <a:ea typeface="Calibri" pitchFamily="34" charset="-122"/>
-                <a:cs typeface="Calibri" pitchFamily="34" charset="-120"/>
-              </a:rPr>
-              <a:t>·  Retrieve GET on the service uses a hard-coded demo user.</a:t>
             </a:r>
             <a:endParaRPr lang="en-US" sz="1300" dirty="0"/>
           </a:p>
@@ -8030,7 +8858,7 @@
                 <a:ea typeface="Calibri" pitchFamily="34" charset="-122"/>
                 <a:cs typeface="Calibri" pitchFamily="34" charset="-120"/>
               </a:rPr>
-              <a:t>·  Body needs usid and sorterId. No order-no or request-no lookup.</a:t>
+              <a:t>·  Body needs usid and sorterId. No order-no lookup.</a:t>
             </a:r>
             <a:endParaRPr lang="en-US" sz="1300" dirty="0"/>
           </a:p>
@@ -8050,7 +8878,7 @@
                 <a:ea typeface="Calibri" pitchFamily="34" charset="-122"/>
                 <a:cs typeface="Calibri" pitchFamily="34" charset="-120"/>
               </a:rPr>
-              <a:t>·  Same format, allowed hospital, and check digit. Miss is Failure.</a:t>
+              <a:t>·  Same format rules. Miss is Failure. Wrong HKID or name is Failure.</a:t>
             </a:r>
             <a:endParaRPr lang="en-US" sz="1300" dirty="0"/>
           </a:p>
@@ -8070,27 +8898,7 @@
                 <a:ea typeface="Calibri" pitchFamily="34" charset="-122"/>
                 <a:cs typeface="Calibri" pitchFamily="34" charset="-120"/>
               </a:rPr>
-              <a:t>·  Retrieve runs in-process as the sorter LIS user, not the demo user.</a:t>
-            </a:r>
-            <a:endParaRPr lang="en-US" sz="1300" dirty="0"/>
-          </a:p>
-          <a:p>
-            <a:pPr algn="l" indent="0" marL="0">
-              <a:lnSpc>
-                <a:spcPct val="140000"/>
-              </a:lnSpc>
-              <a:buNone/>
-            </a:pPr>
-            <a:r>
-              <a:rPr lang="en-US" sz="1300" dirty="0">
-                <a:solidFill>
-                  <a:srgbClr val="56676C"/>
-                </a:solidFill>
-                <a:latin typeface="Calibri" pitchFamily="34" charset="0"/>
-                <a:ea typeface="Calibri" pitchFamily="34" charset="-122"/>
-                <a:cs typeface="Calibri" pitchFamily="34" charset="-120"/>
-              </a:rPr>
-              <a:t>·  Optional HKID or name, if sent and wrong, is Failure. APS / BBS / MBS is Failure.</a:t>
+              <a:t>·  In-process retrieve as the sorter user. APS / BBS / MBS is Failure.</a:t>
             </a:r>
             <a:endParaRPr lang="en-US" sz="1300" dirty="0"/>
           </a:p>
@@ -8159,7 +8967,7 @@
                 <a:ea typeface="Calibri" pitchFamily="34" charset="-122"/>
                 <a:cs typeface="Calibri" pitchFamily="34" charset="-120"/>
               </a:rPr>
-              <a:t>Hospital omitted on the POST is taken from the sorter map and workbench.</a:t>
+              <a:t>Hospital omitted on the POST comes from the sorter map and workbench.</a:t>
             </a:r>
             <a:endParaRPr lang="en-US" sz="1400" dirty="0"/>
           </a:p>
@@ -8201,7 +9009,7 @@
                 <a:ea typeface="Calibri" pitchFamily="34" charset="-122"/>
                 <a:cs typeface="Calibri" pitchFamily="34" charset="-120"/>
               </a:rPr>
-              <a:t>4 / 14</a:t>
+              <a:t>4 / 15</a:t>
             </a:r>
             <a:endParaRPr lang="en-US" sz="900" dirty="0"/>
           </a:p>
@@ -8304,7 +9112,7 @@
                 <a:ea typeface="Cambria" pitchFamily="34" charset="-122"/>
                 <a:cs typeface="Cambria" pitchFamily="34" charset="-120"/>
               </a:rPr>
-              <a:t>Staff press Send-out. The POST looks up the cluster list.</a:t>
+              <a:t>The send-out list decides, not a click</a:t>
             </a:r>
             <a:endParaRPr lang="en-US" sz="3000" dirty="0"/>
           </a:p>
@@ -8415,7 +9223,7 @@
                 <a:ea typeface="Cambria" pitchFamily="34" charset="-122"/>
                 <a:cs typeface="Cambria" pitchFamily="34" charset="-120"/>
               </a:rPr>
-              <a:t>Click after the order is on screen</a:t>
+              <a:t>Staff press Send-out</a:t>
             </a:r>
             <a:endParaRPr lang="en-US" sz="1800" dirty="0"/>
           </a:p>
@@ -8457,7 +9265,7 @@
                 <a:ea typeface="Calibri" pitchFamily="34" charset="-122"/>
                 <a:cs typeface="Calibri" pitchFamily="34" charset="-120"/>
               </a:rPr>
-              <a:t>·  Staff decide Send-out from what they see.</a:t>
+              <a:t>·  Staff choose Send-out after the order is on screen.</a:t>
             </a:r>
             <a:endParaRPr lang="en-US" sz="1300" dirty="0"/>
           </a:p>
@@ -8477,7 +9285,7 @@
                 <a:ea typeface="Calibri" pitchFamily="34" charset="-122"/>
                 <a:cs typeface="Calibri" pitchFamily="34" charset="-120"/>
               </a:rPr>
-              <a:t>·  Backend acks a Printed or Collected specimen, writes tracking, and writes SEND_OUT.</a:t>
+              <a:t>·  Backend acks Printed or Collected, writes tracking, writes SEND_OUT.</a:t>
             </a:r>
             <a:endParaRPr lang="en-US" sz="1300" dirty="0"/>
           </a:p>
@@ -8497,7 +9305,7 @@
                 <a:ea typeface="Calibri" pitchFamily="34" charset="-122"/>
                 <a:cs typeface="Calibri" pitchFamily="34" charset="-120"/>
               </a:rPr>
-              <a:t>·  A GCRS test is send-out when its cluster code is on the send-out list for that lab and hospital.</a:t>
+              <a:t>·  A test is send-out when its cluster code is on the list for that lab and hospital.</a:t>
             </a:r>
             <a:endParaRPr lang="en-US" sz="1300" dirty="0"/>
           </a:p>
@@ -8608,7 +9416,7 @@
                 <a:ea typeface="Cambria" pitchFamily="34" charset="-122"/>
                 <a:cs typeface="Cambria" pitchFamily="34" charset="-120"/>
               </a:rPr>
-              <a:t>Same list, no staff click</a:t>
+              <a:t>Same list. No flag from the sorter.</a:t>
             </a:r>
             <a:endParaRPr lang="en-US" sz="1800" dirty="0"/>
           </a:p>
@@ -8650,7 +9458,7 @@
                 <a:ea typeface="Calibri" pitchFamily="34" charset="-122"/>
                 <a:cs typeface="Calibri" pitchFamily="34" charset="-120"/>
               </a:rPr>
-              <a:t>·  Join the test code to the send-out list for lab and hospital.</a:t>
+              <a:t>·  Join the test to the send-out list for lab and hospital.</a:t>
             </a:r>
             <a:endParaRPr lang="en-US" sz="1300" dirty="0"/>
           </a:p>
@@ -8670,7 +9478,7 @@
                 <a:ea typeface="Calibri" pitchFamily="34" charset="-122"/>
                 <a:cs typeface="Calibri" pitchFamily="34" charset="-120"/>
               </a:rPr>
-              <a:t>·  All tests on the list: existing send-out write, status SEND_OUT.</a:t>
+              <a:t>·  All on the list: existing send-out write, status SEND_OUT.</a:t>
             </a:r>
             <a:endParaRPr lang="en-US" sz="1300" dirty="0"/>
           </a:p>
@@ -8690,27 +9498,7 @@
                 <a:ea typeface="Calibri" pitchFamily="34" charset="-122"/>
                 <a:cs typeface="Calibri" pitchFamily="34" charset="-120"/>
               </a:rPr>
-              <a:t>·  Local and send-out on the same USID: Failure. Do not send out a subset.</a:t>
-            </a:r>
-            <a:endParaRPr lang="en-US" sz="1300" dirty="0"/>
-          </a:p>
-          <a:p>
-            <a:pPr algn="l" indent="0" marL="0">
-              <a:lnSpc>
-                <a:spcPct val="140000"/>
-              </a:lnSpc>
-              <a:buNone/>
-            </a:pPr>
-            <a:r>
-              <a:rPr lang="en-US" sz="1300" dirty="0">
-                <a:solidFill>
-                  <a:srgbClr val="56676C"/>
-                </a:solidFill>
-                <a:latin typeface="Calibri" pitchFamily="34" charset="0"/>
-                <a:ea typeface="Calibri" pitchFamily="34" charset="-122"/>
-                <a:cs typeface="Calibri" pitchFamily="34" charset="-120"/>
-              </a:rPr>
-              <a:t>·  No worksheet and no PHLC on this path.</a:t>
+              <a:t>·  Local plus send-out on one USID: Failure. No worksheet. No PHLC.</a:t>
             </a:r>
             <a:endParaRPr lang="en-US" sz="1300" dirty="0"/>
           </a:p>
@@ -8779,7 +9567,7 @@
                 <a:ea typeface="Calibri" pitchFamily="34" charset="-122"/>
                 <a:cs typeface="Calibri" pitchFamily="34" charset="-120"/>
               </a:rPr>
-              <a:t>The sorter does not send a send-out flag. The list decides.</a:t>
+              <a:t>The sorter does not send a send-out flag.</a:t>
             </a:r>
             <a:endParaRPr lang="en-US" sz="1400" dirty="0"/>
           </a:p>
@@ -8821,7 +9609,7 @@
                 <a:ea typeface="Calibri" pitchFamily="34" charset="-122"/>
                 <a:cs typeface="Calibri" pitchFamily="34" charset="-120"/>
               </a:rPr>
-              <a:t>5 / 14</a:t>
+              <a:t>5 / 15</a:t>
             </a:r>
             <a:endParaRPr lang="en-US" sz="900" dirty="0"/>
           </a:p>
@@ -8937,7 +9725,7 @@
                 <a:ea typeface="Cambria" pitchFamily="34" charset="-122"/>
                 <a:cs typeface="Cambria" pitchFamily="34" charset="-120"/>
               </a:rPr>
-              <a:t>Three screen jobs sit in front of Register</a:t>
+              <a:t>Three jobs sit in front of Register</a:t>
             </a:r>
             <a:endParaRPr lang="en-US" sz="3600" dirty="0"/>
           </a:p>
@@ -8979,7 +9767,7 @@
                 <a:ea typeface="Calibri" pitchFamily="34" charset="-122"/>
                 <a:cs typeface="Calibri" pitchFamily="34" charset="-120"/>
               </a:rPr>
-              <a:t>Checks. Test groups and request no. Ward and doctor mapping. The POST must do all three before it calls register.</a:t>
+              <a:t>Checks. Test groups and request no. Ward and doctor mapping.</a:t>
             </a:r>
             <a:endParaRPr lang="en-US" sz="1500" dirty="0"/>
           </a:p>
@@ -9021,7 +9809,7 @@
                 <a:ea typeface="Calibri" pitchFamily="34" charset="-122"/>
                 <a:cs typeface="Calibri" pitchFamily="34" charset="-120"/>
               </a:rPr>
-              <a:t>6 / 14</a:t>
+              <a:t>6 / 15</a:t>
             </a:r>
             <a:endParaRPr lang="en-US" sz="900" dirty="0"/>
           </a:p>
@@ -9124,7 +9912,7 @@
                 <a:ea typeface="Cambria" pitchFamily="34" charset="-122"/>
                 <a:cs typeface="Cambria" pitchFamily="34" charset="-120"/>
               </a:rPr>
-              <a:t>Staff see popups. The POST logs soft ones and fails hard ones.</a:t>
+              <a:t>Soft logs. Hard fails.</a:t>
             </a:r>
             <a:endParaRPr lang="en-US" sz="3000" dirty="0"/>
           </a:p>
@@ -9235,7 +10023,7 @@
                 <a:ea typeface="Cambria" pitchFamily="34" charset="-122"/>
                 <a:cs typeface="Cambria" pitchFamily="34" charset="-120"/>
               </a:rPr>
-              <a:t>Alerts on the screen</a:t>
+              <a:t>Popups on the screen</a:t>
             </a:r>
             <a:endParaRPr lang="en-US" sz="1800" dirty="0"/>
           </a:p>
@@ -9277,7 +10065,7 @@
                 <a:ea typeface="Calibri" pitchFamily="34" charset="-122"/>
                 <a:cs typeface="Calibri" pitchFamily="34" charset="-120"/>
               </a:rPr>
-              <a:t>·  Soft alerts after retrieve. Staff can continue or stop.</a:t>
+              <a:t>·  Soft alerts after retrieve. Staff can continue.</a:t>
             </a:r>
             <a:endParaRPr lang="en-US" sz="1300" dirty="0"/>
           </a:p>
@@ -9318,26 +10106,6 @@
                 <a:cs typeface="Calibri" pitchFamily="34" charset="-120"/>
               </a:rPr>
               <a:t>·  Mixed local and send-out is a soft alert today.</a:t>
-            </a:r>
-            <a:endParaRPr lang="en-US" sz="1300" dirty="0"/>
-          </a:p>
-          <a:p>
-            <a:pPr algn="l" indent="0" marL="0">
-              <a:lnSpc>
-                <a:spcPct val="140000"/>
-              </a:lnSpc>
-              <a:buNone/>
-            </a:pPr>
-            <a:r>
-              <a:rPr lang="en-US" sz="1300" dirty="0">
-                <a:solidFill>
-                  <a:srgbClr val="56676C"/>
-                </a:solidFill>
-                <a:latin typeface="Calibri" pitchFamily="34" charset="0"/>
-                <a:ea typeface="Calibri" pitchFamily="34" charset="-122"/>
-                <a:cs typeface="Calibri" pitchFamily="34" charset="-120"/>
-              </a:rPr>
-              <a:t>·  Staff can tick Relabel USID. STAR unbox can warn, then block if no location.</a:t>
             </a:r>
             <a:endParaRPr lang="en-US" sz="1300" dirty="0"/>
           </a:p>
@@ -9448,7 +10216,7 @@
                 <a:ea typeface="Cambria" pitchFamily="34" charset="-122"/>
                 <a:cs typeface="Cambria" pitchFamily="34" charset="-120"/>
               </a:rPr>
-              <a:t>Same rules, no dialogue</a:t>
+              <a:t>No dialogue</a:t>
             </a:r>
             <a:endParaRPr lang="en-US" sz="1800" dirty="0"/>
           </a:p>
@@ -9490,7 +10258,7 @@
                 <a:ea typeface="Calibri" pitchFamily="34" charset="-122"/>
                 <a:cs typeface="Calibri" pitchFamily="34" charset="-120"/>
               </a:rPr>
-              <a:t>·  Soft alerts: ALS only. Not on the response body. Status is not Relabel.</a:t>
+              <a:t>·  Soft: ALS only. Not on the body. Not Relabel.</a:t>
             </a:r>
             <a:endParaRPr lang="en-US" sz="1300" dirty="0"/>
           </a:p>
@@ -9510,7 +10278,7 @@
                 <a:ea typeface="Calibri" pitchFamily="34" charset="-122"/>
                 <a:cs typeface="Calibri" pitchFamily="34" charset="-120"/>
               </a:rPr>
-              <a:t>·  Hard checks: HTTP 200 and FAILURE, with the message code on the audit remark.</a:t>
+              <a:t>·  Hard: HTTP 200 and FAILURE, code on the audit remark.</a:t>
             </a:r>
             <a:endParaRPr lang="en-US" sz="1300" dirty="0"/>
           </a:p>
@@ -9530,27 +10298,7 @@
                 <a:ea typeface="Calibri" pitchFamily="34" charset="-122"/>
                 <a:cs typeface="Calibri" pitchFamily="34" charset="-120"/>
               </a:rPr>
-              <a:t>·  Mixed local and send-out is Failure on the API.</a:t>
-            </a:r>
-            <a:endParaRPr lang="en-US" sz="1300" dirty="0"/>
-          </a:p>
-          <a:p>
-            <a:pPr algn="l" indent="0" marL="0">
-              <a:lnSpc>
-                <a:spcPct val="140000"/>
-              </a:lnSpc>
-              <a:buNone/>
-            </a:pPr>
-            <a:r>
-              <a:rPr lang="en-US" sz="1300" dirty="0">
-                <a:solidFill>
-                  <a:srgbClr val="56676C"/>
-                </a:solidFill>
-                <a:latin typeface="Calibri" pitchFamily="34" charset="0"/>
-                <a:ea typeface="Calibri" pitchFamily="34" charset="-122"/>
-                <a:cs typeface="Calibri" pitchFamily="34" charset="-120"/>
-              </a:rPr>
-              <a:t>·  No Relabel checkbox. STAR with no workbench location is Failure 4422.</a:t>
+              <a:t>·  Mixed is Failure. No Relabel checkbox. STAR with no location is 4422.</a:t>
             </a:r>
             <a:endParaRPr lang="en-US" sz="1300" dirty="0"/>
           </a:p>
@@ -9619,7 +10367,7 @@
                 <a:ea typeface="Calibri" pitchFamily="34" charset="-122"/>
                 <a:cs typeface="Calibri" pitchFamily="34" charset="-120"/>
               </a:rPr>
-              <a:t>Ack and register time is server now. Missing collection date is soft. Do not invent a date.</a:t>
+              <a:t>Ack time is server now. Missing collection date is soft. Do not invent a date.</a:t>
             </a:r>
             <a:endParaRPr lang="en-US" sz="1400" dirty="0"/>
           </a:p>
@@ -9661,7 +10409,7 @@
                 <a:ea typeface="Calibri" pitchFamily="34" charset="-122"/>
                 <a:cs typeface="Calibri" pitchFamily="34" charset="-120"/>
               </a:rPr>
-              <a:t>7 / 14</a:t>
+              <a:t>7 / 15</a:t>
             </a:r>
             <a:endParaRPr lang="en-US" sz="900" dirty="0"/>
           </a:p>
@@ -9764,7 +10512,7 @@
                 <a:ea typeface="Cambria" pitchFamily="34" charset="-122"/>
                 <a:cs typeface="Cambria" pitchFamily="34" charset="-120"/>
               </a:rPr>
-              <a:t>Soft alerts the API logs and then continues</a:t>
+              <a:t>Soft alerts - logged, then continue</a:t>
             </a:r>
             <a:endParaRPr lang="en-US" sz="3000" dirty="0"/>
           </a:p>
@@ -9779,11 +10527,11 @@
         <p:spPr>
           <a:xfrm>
             <a:off x="548640" y="1737360"/>
-            <a:ext cx="3526536" cy="1426464"/>
+            <a:ext cx="3526536" cy="3108960"/>
           </a:xfrm>
           <a:prstGeom prst="roundRect">
             <a:avLst>
-              <a:gd name="adj" fmla="val 2564"/>
+              <a:gd name="adj" fmla="val 1176"/>
             </a:avLst>
           </a:prstGeom>
           <a:solidFill>
@@ -9893,7 +10641,7 @@
         <p:spPr>
           <a:xfrm>
             <a:off x="822960" y="3090672"/>
-            <a:ext cx="2977896" cy="-109728"/>
+            <a:ext cx="2977896" cy="1572768"/>
           </a:xfrm>
           <a:prstGeom prst="rect">
             <a:avLst/>
@@ -9920,7 +10668,7 @@
                 <a:ea typeface="Calibri" pitchFamily="34" charset="-122"/>
                 <a:cs typeface="Calibri" pitchFamily="34" charset="-120"/>
               </a:rPr>
-              <a:t>Proceed. Do not invent a collection date.</a:t>
+              <a:t>Proceed. Do not invent a date.</a:t>
             </a:r>
             <a:endParaRPr lang="en-US" sz="1300" dirty="0"/>
           </a:p>
@@ -9935,11 +10683,11 @@
         <p:spPr>
           <a:xfrm>
             <a:off x="4331208" y="1737360"/>
-            <a:ext cx="3526536" cy="1426464"/>
+            <a:ext cx="3526536" cy="3108960"/>
           </a:xfrm>
           <a:prstGeom prst="roundRect">
             <a:avLst>
-              <a:gd name="adj" fmla="val 2564"/>
+              <a:gd name="adj" fmla="val 1176"/>
             </a:avLst>
           </a:prstGeom>
           <a:solidFill>
@@ -10049,7 +10797,7 @@
         <p:spPr>
           <a:xfrm>
             <a:off x="4605528" y="3090672"/>
-            <a:ext cx="2977896" cy="-109728"/>
+            <a:ext cx="2977896" cy="1572768"/>
           </a:xfrm>
           <a:prstGeom prst="rect">
             <a:avLst/>
@@ -10076,7 +10824,7 @@
                 <a:ea typeface="Calibri" pitchFamily="34" charset="-122"/>
                 <a:cs typeface="Calibri" pitchFamily="34" charset="-120"/>
               </a:rPr>
-              <a:t>Same overnight window as Spec Ack. ALS warn only.</a:t>
+              <a:t>Same overnight window as Spec Ack. ALS only.</a:t>
             </a:r>
             <a:endParaRPr lang="en-US" sz="1300" dirty="0"/>
           </a:p>
@@ -10091,11 +10839,11 @@
         <p:spPr>
           <a:xfrm>
             <a:off x="8113776" y="1737360"/>
-            <a:ext cx="3526536" cy="1426464"/>
+            <a:ext cx="3526536" cy="3108960"/>
           </a:xfrm>
           <a:prstGeom prst="roundRect">
             <a:avLst>
-              <a:gd name="adj" fmla="val 2564"/>
+              <a:gd name="adj" fmla="val 1176"/>
             </a:avLst>
           </a:prstGeom>
           <a:solidFill>
@@ -10205,7 +10953,7 @@
         <p:spPr>
           <a:xfrm>
             <a:off x="8388096" y="3090672"/>
-            <a:ext cx="2977896" cy="-109728"/>
+            <a:ext cx="2977896" cy="1572768"/>
           </a:xfrm>
           <a:prstGeom prst="rect">
             <a:avLst/>
@@ -10240,544 +10988,7 @@
       </p:sp>
       <p:sp>
         <p:nvSpPr>
-          <p:cNvPr id="16" name="Shape 14"/>
-          <p:cNvSpPr/>
-          <p:nvPr/>
-        </p:nvSpPr>
-        <p:spPr>
-          <a:xfrm>
-            <a:off x="548640" y="3419856"/>
-            <a:ext cx="3526536" cy="1426464"/>
-          </a:xfrm>
-          <a:prstGeom prst="roundRect">
-            <a:avLst>
-              <a:gd name="adj" fmla="val 2564"/>
-            </a:avLst>
-          </a:prstGeom>
-          <a:solidFill>
-            <a:srgbClr val="F1F3F3"/>
-          </a:solidFill>
-          <a:ln w="12700">
-            <a:solidFill>
-              <a:srgbClr val="F1F3F3"/>
-            </a:solidFill>
-            <a:prstDash val="solid"/>
-          </a:ln>
-        </p:spPr>
-      </p:sp>
-      <p:sp>
-        <p:nvSpPr>
-          <p:cNvPr id="17" name="Text 15"/>
-          <p:cNvSpPr/>
-          <p:nvPr/>
-        </p:nvSpPr>
-        <p:spPr>
-          <a:xfrm>
-            <a:off x="822960" y="3675888"/>
-            <a:ext cx="384048" cy="384048"/>
-          </a:xfrm>
-          <a:prstGeom prst="ellipse">
-            <a:avLst/>
-          </a:prstGeom>
-          <a:solidFill>
-            <a:srgbClr val="56676C"/>
-          </a:solidFill>
-          <a:ln>
-            <a:solidFill>
-              <a:srgbClr val="56676C"/>
-            </a:solidFill>
-          </a:ln>
-        </p:spPr>
-        <p:txBody>
-          <a:bodyPr wrap="square" rtlCol="0" anchor="ctr"/>
-          <a:lstStyle/>
-          <a:p>
-            <a:pPr algn="ctr" indent="0" marL="0">
-              <a:buNone/>
-            </a:pPr>
-            <a:r>
-              <a:rPr lang="en-US" sz="1300" b="1" dirty="0">
-                <a:solidFill>
-                  <a:srgbClr val="FFFFFF"/>
-                </a:solidFill>
-                <a:latin typeface="Calibri" pitchFamily="34" charset="0"/>
-                <a:ea typeface="Calibri" pitchFamily="34" charset="-122"/>
-                <a:cs typeface="Calibri" pitchFamily="34" charset="-120"/>
-              </a:rPr>
-              <a:t>4</a:t>
-            </a:r>
-            <a:endParaRPr lang="en-US" sz="1300" dirty="0"/>
-          </a:p>
-        </p:txBody>
-      </p:sp>
-      <p:sp>
-        <p:nvSpPr>
-          <p:cNvPr id="18" name="Text 16"/>
-          <p:cNvSpPr/>
-          <p:nvPr/>
-        </p:nvSpPr>
-        <p:spPr>
-          <a:xfrm>
-            <a:off x="822960" y="4242816"/>
-            <a:ext cx="2977896" cy="457200"/>
-          </a:xfrm>
-          <a:prstGeom prst="rect">
-            <a:avLst/>
-          </a:prstGeom>
-          <a:noFill/>
-          <a:ln/>
-        </p:spPr>
-        <p:txBody>
-          <a:bodyPr wrap="square" rtlCol="0" anchor="t"/>
-          <a:lstStyle/>
-          <a:p>
-            <a:pPr algn="l" indent="0" marL="0">
-              <a:lnSpc>
-                <a:spcPct val="115000"/>
-              </a:lnSpc>
-              <a:buNone/>
-            </a:pPr>
-            <a:r>
-              <a:rPr lang="en-US" sz="1700" dirty="0">
-                <a:solidFill>
-                  <a:srgbClr val="08323B"/>
-                </a:solidFill>
-                <a:latin typeface="Cambria" pitchFamily="34" charset="0"/>
-                <a:ea typeface="Cambria" pitchFamily="34" charset="-122"/>
-                <a:cs typeface="Cambria" pitchFamily="34" charset="-120"/>
-              </a:rPr>
-              <a:t>Duplicate / A-A-R</a:t>
-            </a:r>
-            <a:endParaRPr lang="en-US" sz="1700" dirty="0"/>
-          </a:p>
-        </p:txBody>
-      </p:sp>
-      <p:sp>
-        <p:nvSpPr>
-          <p:cNvPr id="19" name="Text 17"/>
-          <p:cNvSpPr/>
-          <p:nvPr/>
-        </p:nvSpPr>
-        <p:spPr>
-          <a:xfrm>
-            <a:off x="822960" y="4773168"/>
-            <a:ext cx="2977896" cy="-109728"/>
-          </a:xfrm>
-          <a:prstGeom prst="rect">
-            <a:avLst/>
-          </a:prstGeom>
-          <a:noFill/>
-          <a:ln/>
-        </p:spPr>
-        <p:txBody>
-          <a:bodyPr wrap="square" rtlCol="0" anchor="t"/>
-          <a:lstStyle/>
-          <a:p>
-            <a:pPr algn="l" indent="0" marL="0">
-              <a:lnSpc>
-                <a:spcPct val="115000"/>
-              </a:lnSpc>
-              <a:buNone/>
-            </a:pPr>
-            <a:r>
-              <a:rPr lang="en-US" sz="1300" dirty="0">
-                <a:solidFill>
-                  <a:srgbClr val="56676C"/>
-                </a:solidFill>
-                <a:latin typeface="Calibri" pitchFamily="34" charset="0"/>
-                <a:ea typeface="Calibri" pitchFamily="34" charset="-122"/>
-                <a:cs typeface="Calibri" pitchFamily="34" charset="-120"/>
-              </a:rPr>
-              <a:t>Duplicate-reason and A-A-R-not-ready prompts. ALS only. AAR stays off.</a:t>
-            </a:r>
-            <a:endParaRPr lang="en-US" sz="1300" dirty="0"/>
-          </a:p>
-        </p:txBody>
-      </p:sp>
-      <p:sp>
-        <p:nvSpPr>
-          <p:cNvPr id="20" name="Shape 18"/>
-          <p:cNvSpPr/>
-          <p:nvPr/>
-        </p:nvSpPr>
-        <p:spPr>
-          <a:xfrm>
-            <a:off x="4331208" y="3419856"/>
-            <a:ext cx="3526536" cy="1426464"/>
-          </a:xfrm>
-          <a:prstGeom prst="roundRect">
-            <a:avLst>
-              <a:gd name="adj" fmla="val 2564"/>
-            </a:avLst>
-          </a:prstGeom>
-          <a:solidFill>
-            <a:srgbClr val="F1F3F3"/>
-          </a:solidFill>
-          <a:ln w="12700">
-            <a:solidFill>
-              <a:srgbClr val="F1F3F3"/>
-            </a:solidFill>
-            <a:prstDash val="solid"/>
-          </a:ln>
-        </p:spPr>
-      </p:sp>
-      <p:sp>
-        <p:nvSpPr>
-          <p:cNvPr id="21" name="Text 19"/>
-          <p:cNvSpPr/>
-          <p:nvPr/>
-        </p:nvSpPr>
-        <p:spPr>
-          <a:xfrm>
-            <a:off x="4605528" y="3675888"/>
-            <a:ext cx="384048" cy="384048"/>
-          </a:xfrm>
-          <a:prstGeom prst="ellipse">
-            <a:avLst/>
-          </a:prstGeom>
-          <a:solidFill>
-            <a:srgbClr val="56676C"/>
-          </a:solidFill>
-          <a:ln>
-            <a:solidFill>
-              <a:srgbClr val="56676C"/>
-            </a:solidFill>
-          </a:ln>
-        </p:spPr>
-        <p:txBody>
-          <a:bodyPr wrap="square" rtlCol="0" anchor="ctr"/>
-          <a:lstStyle/>
-          <a:p>
-            <a:pPr algn="ctr" indent="0" marL="0">
-              <a:buNone/>
-            </a:pPr>
-            <a:r>
-              <a:rPr lang="en-US" sz="1300" b="1" dirty="0">
-                <a:solidFill>
-                  <a:srgbClr val="FFFFFF"/>
-                </a:solidFill>
-                <a:latin typeface="Calibri" pitchFamily="34" charset="0"/>
-                <a:ea typeface="Calibri" pitchFamily="34" charset="-122"/>
-                <a:cs typeface="Calibri" pitchFamily="34" charset="-120"/>
-              </a:rPr>
-              <a:t>5</a:t>
-            </a:r>
-            <a:endParaRPr lang="en-US" sz="1300" dirty="0"/>
-          </a:p>
-        </p:txBody>
-      </p:sp>
-      <p:sp>
-        <p:nvSpPr>
-          <p:cNvPr id="22" name="Text 20"/>
-          <p:cNvSpPr/>
-          <p:nvPr/>
-        </p:nvSpPr>
-        <p:spPr>
-          <a:xfrm>
-            <a:off x="4605528" y="4242816"/>
-            <a:ext cx="2977896" cy="457200"/>
-          </a:xfrm>
-          <a:prstGeom prst="rect">
-            <a:avLst/>
-          </a:prstGeom>
-          <a:noFill/>
-          <a:ln/>
-        </p:spPr>
-        <p:txBody>
-          <a:bodyPr wrap="square" rtlCol="0" anchor="t"/>
-          <a:lstStyle/>
-          <a:p>
-            <a:pPr algn="l" indent="0" marL="0">
-              <a:lnSpc>
-                <a:spcPct val="115000"/>
-              </a:lnSpc>
-              <a:buNone/>
-            </a:pPr>
-            <a:r>
-              <a:rPr lang="en-US" sz="1700" dirty="0">
-                <a:solidFill>
-                  <a:srgbClr val="08323B"/>
-                </a:solidFill>
-                <a:latin typeface="Cambria" pitchFamily="34" charset="0"/>
-                <a:ea typeface="Cambria" pitchFamily="34" charset="-122"/>
-                <a:cs typeface="Cambria" pitchFamily="34" charset="-120"/>
-              </a:rPr>
-              <a:t>Patient tag / private</a:t>
-            </a:r>
-            <a:endParaRPr lang="en-US" sz="1700" dirty="0"/>
-          </a:p>
-        </p:txBody>
-      </p:sp>
-      <p:sp>
-        <p:nvSpPr>
-          <p:cNvPr id="23" name="Text 21"/>
-          <p:cNvSpPr/>
-          <p:nvPr/>
-        </p:nvSpPr>
-        <p:spPr>
-          <a:xfrm>
-            <a:off x="4605528" y="4773168"/>
-            <a:ext cx="2977896" cy="-109728"/>
-          </a:xfrm>
-          <a:prstGeom prst="rect">
-            <a:avLst/>
-          </a:prstGeom>
-          <a:noFill/>
-          <a:ln/>
-        </p:spPr>
-        <p:txBody>
-          <a:bodyPr wrap="square" rtlCol="0" anchor="t"/>
-          <a:lstStyle/>
-          <a:p>
-            <a:pPr algn="l" indent="0" marL="0">
-              <a:lnSpc>
-                <a:spcPct val="115000"/>
-              </a:lnSpc>
-              <a:buNone/>
-            </a:pPr>
-            <a:r>
-              <a:rPr lang="en-US" sz="1300" dirty="0">
-                <a:solidFill>
-                  <a:srgbClr val="56676C"/>
-                </a:solidFill>
-                <a:latin typeface="Calibri" pitchFamily="34" charset="0"/>
-                <a:ea typeface="Calibri" pitchFamily="34" charset="-122"/>
-                <a:cs typeface="Calibri" pitchFamily="34" charset="-120"/>
-              </a:rPr>
-              <a:t>Private patient and patient-tag alerts. ALS only.</a:t>
-            </a:r>
-            <a:endParaRPr lang="en-US" sz="1300" dirty="0"/>
-          </a:p>
-        </p:txBody>
-      </p:sp>
-      <p:sp>
-        <p:nvSpPr>
-          <p:cNvPr id="24" name="Shape 22"/>
-          <p:cNvSpPr/>
-          <p:nvPr/>
-        </p:nvSpPr>
-        <p:spPr>
-          <a:xfrm>
-            <a:off x="8113776" y="3419856"/>
-            <a:ext cx="3526536" cy="1426464"/>
-          </a:xfrm>
-          <a:prstGeom prst="roundRect">
-            <a:avLst>
-              <a:gd name="adj" fmla="val 2564"/>
-            </a:avLst>
-          </a:prstGeom>
-          <a:solidFill>
-            <a:srgbClr val="FAEEDB"/>
-          </a:solidFill>
-          <a:ln w="12700">
-            <a:solidFill>
-              <a:srgbClr val="FAEEDB"/>
-            </a:solidFill>
-            <a:prstDash val="solid"/>
-          </a:ln>
-        </p:spPr>
-      </p:sp>
-      <p:sp>
-        <p:nvSpPr>
-          <p:cNvPr id="25" name="Text 23"/>
-          <p:cNvSpPr/>
-          <p:nvPr/>
-        </p:nvSpPr>
-        <p:spPr>
-          <a:xfrm>
-            <a:off x="8388096" y="3675888"/>
-            <a:ext cx="384048" cy="384048"/>
-          </a:xfrm>
-          <a:prstGeom prst="ellipse">
-            <a:avLst/>
-          </a:prstGeom>
-          <a:solidFill>
-            <a:srgbClr val="9A5C15"/>
-          </a:solidFill>
-          <a:ln>
-            <a:solidFill>
-              <a:srgbClr val="9A5C15"/>
-            </a:solidFill>
-          </a:ln>
-        </p:spPr>
-        <p:txBody>
-          <a:bodyPr wrap="square" rtlCol="0" anchor="ctr"/>
-          <a:lstStyle/>
-          <a:p>
-            <a:pPr algn="ctr" indent="0" marL="0">
-              <a:buNone/>
-            </a:pPr>
-            <a:r>
-              <a:rPr lang="en-US" sz="1300" b="1" dirty="0">
-                <a:solidFill>
-                  <a:srgbClr val="FFFFFF"/>
-                </a:solidFill>
-                <a:latin typeface="Calibri" pitchFamily="34" charset="0"/>
-                <a:ea typeface="Calibri" pitchFamily="34" charset="-122"/>
-                <a:cs typeface="Calibri" pitchFamily="34" charset="-120"/>
-              </a:rPr>
-              <a:t>6</a:t>
-            </a:r>
-            <a:endParaRPr lang="en-US" sz="1300" dirty="0"/>
-          </a:p>
-        </p:txBody>
-      </p:sp>
-      <p:sp>
-        <p:nvSpPr>
-          <p:cNvPr id="26" name="Text 24"/>
-          <p:cNvSpPr/>
-          <p:nvPr/>
-        </p:nvSpPr>
-        <p:spPr>
-          <a:xfrm>
-            <a:off x="8388096" y="4242816"/>
-            <a:ext cx="2977896" cy="457200"/>
-          </a:xfrm>
-          <a:prstGeom prst="rect">
-            <a:avLst/>
-          </a:prstGeom>
-          <a:noFill/>
-          <a:ln/>
-        </p:spPr>
-        <p:txBody>
-          <a:bodyPr wrap="square" rtlCol="0" anchor="t"/>
-          <a:lstStyle/>
-          <a:p>
-            <a:pPr algn="l" indent="0" marL="0">
-              <a:lnSpc>
-                <a:spcPct val="115000"/>
-              </a:lnSpc>
-              <a:buNone/>
-            </a:pPr>
-            <a:r>
-              <a:rPr lang="en-US" sz="1700" dirty="0">
-                <a:solidFill>
-                  <a:srgbClr val="08323B"/>
-                </a:solidFill>
-                <a:latin typeface="Cambria" pitchFamily="34" charset="0"/>
-                <a:ea typeface="Cambria" pitchFamily="34" charset="-122"/>
-                <a:cs typeface="Cambria" pitchFamily="34" charset="-120"/>
-              </a:rPr>
-              <a:t>STAR unbox alert</a:t>
-            </a:r>
-            <a:endParaRPr lang="en-US" sz="1700" dirty="0"/>
-          </a:p>
-        </p:txBody>
-      </p:sp>
-      <p:sp>
-        <p:nvSpPr>
-          <p:cNvPr id="27" name="Text 25"/>
-          <p:cNvSpPr/>
-          <p:nvPr/>
-        </p:nvSpPr>
-        <p:spPr>
-          <a:xfrm>
-            <a:off x="8388096" y="4773168"/>
-            <a:ext cx="2977896" cy="-109728"/>
-          </a:xfrm>
-          <a:prstGeom prst="rect">
-            <a:avLst/>
-          </a:prstGeom>
-          <a:noFill/>
-          <a:ln/>
-        </p:spPr>
-        <p:txBody>
-          <a:bodyPr wrap="square" rtlCol="0" anchor="t"/>
-          <a:lstStyle/>
-          <a:p>
-            <a:pPr algn="l" indent="0" marL="0">
-              <a:lnSpc>
-                <a:spcPct val="115000"/>
-              </a:lnSpc>
-              <a:buNone/>
-            </a:pPr>
-            <a:r>
-              <a:rPr lang="en-US" sz="1300" dirty="0">
-                <a:solidFill>
-                  <a:srgbClr val="56676C"/>
-                </a:solidFill>
-                <a:latin typeface="Calibri" pitchFamily="34" charset="0"/>
-                <a:ea typeface="Calibri" pitchFamily="34" charset="-122"/>
-                <a:cs typeface="Calibri" pitchFamily="34" charset="-120"/>
-              </a:rPr>
-              <a:t>Boxed-specimen warning is ALS. No workbench location is hard Failure, not this card.</a:t>
-            </a:r>
-            <a:endParaRPr lang="en-US" sz="1300" dirty="0"/>
-          </a:p>
-        </p:txBody>
-      </p:sp>
-      <p:sp>
-        <p:nvSpPr>
-          <p:cNvPr id="28" name="Shape 26"/>
-          <p:cNvSpPr/>
-          <p:nvPr/>
-        </p:nvSpPr>
-        <p:spPr>
-          <a:xfrm>
-            <a:off x="548640" y="4983480"/>
-            <a:ext cx="11091672" cy="868680"/>
-          </a:xfrm>
-          <a:prstGeom prst="roundRect">
-            <a:avLst>
-              <a:gd name="adj" fmla="val 4211"/>
-            </a:avLst>
-          </a:prstGeom>
-          <a:solidFill>
-            <a:srgbClr val="FAEEDB"/>
-          </a:solidFill>
-          <a:ln w="12700">
-            <a:solidFill>
-              <a:srgbClr val="FAEEDB"/>
-            </a:solidFill>
-            <a:prstDash val="solid"/>
-          </a:ln>
-        </p:spPr>
-      </p:sp>
-      <p:sp>
-        <p:nvSpPr>
-          <p:cNvPr id="29" name="Text 27"/>
-          <p:cNvSpPr/>
-          <p:nvPr/>
-        </p:nvSpPr>
-        <p:spPr>
-          <a:xfrm>
-            <a:off x="868680" y="5120640"/>
-            <a:ext cx="10424160" cy="594360"/>
-          </a:xfrm>
-          <a:prstGeom prst="rect">
-            <a:avLst/>
-          </a:prstGeom>
-          <a:noFill/>
-          <a:ln/>
-        </p:spPr>
-        <p:txBody>
-          <a:bodyPr wrap="square" rtlCol="0" anchor="ctr"/>
-          <a:lstStyle/>
-          <a:p>
-            <a:pPr algn="l" indent="0" marL="0">
-              <a:lnSpc>
-                <a:spcPct val="120000"/>
-              </a:lnSpc>
-              <a:buNone/>
-            </a:pPr>
-            <a:r>
-              <a:rPr lang="en-US" sz="1400" dirty="0">
-                <a:solidFill>
-                  <a:srgbClr val="08323B"/>
-                </a:solidFill>
-                <a:latin typeface="Calibri" pitchFamily="34" charset="0"/>
-                <a:ea typeface="Calibri" pitchFamily="34" charset="-122"/>
-                <a:cs typeface="Calibri" pitchFamily="34" charset="-120"/>
-              </a:rPr>
-              <a:t>BBS blood / category / T&amp;S alerts stay on the staff screen. BBS is out of v1.</a:t>
-            </a:r>
-            <a:endParaRPr lang="en-US" sz="1400" dirty="0"/>
-          </a:p>
-        </p:txBody>
-      </p:sp>
-      <p:sp>
-        <p:nvSpPr>
-          <p:cNvPr id="30" name="Text 28"/>
+          <p:cNvPr id="16" name="Text 14"/>
           <p:cNvSpPr/>
           <p:nvPr/>
         </p:nvSpPr>
@@ -10811,7 +11022,7 @@
                 <a:ea typeface="Calibri" pitchFamily="34" charset="-122"/>
                 <a:cs typeface="Calibri" pitchFamily="34" charset="-120"/>
               </a:rPr>
-              <a:t>8 / 14</a:t>
+              <a:t>8 / 15</a:t>
             </a:r>
             <a:endParaRPr lang="en-US" sz="900" dirty="0"/>
           </a:p>
@@ -10914,1301 +11125,34 @@
                 <a:ea typeface="Cambria" pitchFamily="34" charset="-122"/>
                 <a:cs typeface="Cambria" pitchFamily="34" charset="-120"/>
               </a:rPr>
-              <a:t>Hard checks that return Failure</a:t>
+              <a:t>Soft alerts - the rest of the set</a:t>
             </a:r>
             <a:endParaRPr lang="en-US" sz="3000" dirty="0"/>
           </a:p>
         </p:txBody>
       </p:sp>
-      <p:graphicFrame>
-        <p:nvGraphicFramePr>
-          <p:cNvPr id="10" name="Table 0"/>
-          <p:cNvGraphicFramePr>
-            <a:graphicFrameLocks noGrp="1"/>
-          </p:cNvGraphicFramePr>
-          <p:nvPr>
-            <p:extLst>
-              <p:ext uri="{D42A27DB-BD31-4B8C-83A1-F6EECF244321}">
-                <p14:modId xmlns:p14="http://schemas.microsoft.com/office/powerpoint/2010/main" val="1579011935"/>
-              </p:ext>
-            </p:extLst>
-          </p:nvPr>
-        </p:nvGraphicFramePr>
-        <p:xfrm>
-          <a:off x="548640" y="1783080"/>
-          <a:ext cx="11091672" cy="914400"/>
-        </p:xfrm>
-        <a:graphic>
-          <a:graphicData uri="http://schemas.openxmlformats.org/drawingml/2006/table">
-            <a:tbl>
-              <a:tblPr/>
-              <a:tblGrid>
-                <a:gridCol w="3108960"/>
-                <a:gridCol w="4572000"/>
-                <a:gridCol w="3410712"/>
-              </a:tblGrid>
-              <a:tr h="475488">
-                <a:tc>
-                  <a:txBody>
-                    <a:bodyPr/>
-                    <a:lstStyle/>
-                    <a:p>
-                      <a:pPr algn="l" indent="0" marL="0">
-                        <a:buNone/>
-                      </a:pPr>
-                      <a:r>
-                        <a:rPr lang="en-US" sz="1250" b="1" dirty="0">
-                          <a:solidFill>
-                            <a:srgbClr val="FFFFFF"/>
-                          </a:solidFill>
-                          <a:latin typeface="Calibri" pitchFamily="34" charset="0"/>
-                          <a:ea typeface="Calibri" pitchFamily="34" charset="-122"/>
-                          <a:cs typeface="Calibri" pitchFamily="34" charset="-120"/>
-                        </a:rPr>
-                        <a:t>Check</a:t>
-                      </a:r>
-                      <a:endParaRPr lang="en-US" sz="1250" dirty="0">
-                        <a:latin typeface="Calibri" charset="0"/>
-                        <a:ea typeface="Calibri" charset="0"/>
-                        <a:cs typeface="Calibri" charset="0"/>
-                      </a:endParaRPr>
-                    </a:p>
-                  </a:txBody>
-                  <a:tcPr marL="127000" marR="127000" marT="50800" marB="50800" anchor="ctr">
-                    <a:lnL w="12700" cap="flat" cmpd="sng" algn="ctr">
-                      <a:solidFill>
-                        <a:srgbClr val="D5DEE0"/>
-                      </a:solidFill>
-                      <a:prstDash val="solid"/>
-                      <a:round/>
-                      <a:headEnd type="none" w="med" len="med"/>
-                      <a:tailEnd type="none" w="med" len="med"/>
-                    </a:lnL>
-                    <a:lnR w="12700" cap="flat" cmpd="sng" algn="ctr">
-                      <a:solidFill>
-                        <a:srgbClr val="D5DEE0"/>
-                      </a:solidFill>
-                      <a:prstDash val="solid"/>
-                      <a:round/>
-                      <a:headEnd type="none" w="med" len="med"/>
-                      <a:tailEnd type="none" w="med" len="med"/>
-                    </a:lnR>
-                    <a:lnT w="12700" cap="flat" cmpd="sng" algn="ctr">
-                      <a:solidFill>
-                        <a:srgbClr val="D5DEE0"/>
-                      </a:solidFill>
-                      <a:prstDash val="solid"/>
-                      <a:round/>
-                      <a:headEnd type="none" w="med" len="med"/>
-                      <a:tailEnd type="none" w="med" len="med"/>
-                    </a:lnT>
-                    <a:lnB w="12700" cap="flat" cmpd="sng" algn="ctr">
-                      <a:solidFill>
-                        <a:srgbClr val="D5DEE0"/>
-                      </a:solidFill>
-                      <a:prstDash val="solid"/>
-                      <a:round/>
-                      <a:headEnd type="none" w="med" len="med"/>
-                      <a:tailEnd type="none" w="med" len="med"/>
-                    </a:lnB>
-                    <a:solidFill>
-                      <a:srgbClr val="08323B"/>
-                    </a:solidFill>
-                  </a:tcPr>
-                </a:tc>
-                <a:tc>
-                  <a:txBody>
-                    <a:bodyPr/>
-                    <a:lstStyle/>
-                    <a:p>
-                      <a:pPr algn="l" indent="0" marL="0">
-                        <a:buNone/>
-                      </a:pPr>
-                      <a:r>
-                        <a:rPr lang="en-US" sz="1250" b="1" dirty="0">
-                          <a:solidFill>
-                            <a:srgbClr val="FFFFFF"/>
-                          </a:solidFill>
-                          <a:latin typeface="Calibri" pitchFamily="34" charset="0"/>
-                          <a:ea typeface="Calibri" pitchFamily="34" charset="-122"/>
-                          <a:cs typeface="Calibri" pitchFamily="34" charset="-120"/>
-                        </a:rPr>
-                        <a:t>When it fires</a:t>
-                      </a:r>
-                      <a:endParaRPr lang="en-US" sz="1250" dirty="0">
-                        <a:latin typeface="Calibri" charset="0"/>
-                        <a:ea typeface="Calibri" charset="0"/>
-                        <a:cs typeface="Calibri" charset="0"/>
-                      </a:endParaRPr>
-                    </a:p>
-                  </a:txBody>
-                  <a:tcPr marL="127000" marR="127000" marT="50800" marB="50800" anchor="ctr">
-                    <a:lnL w="12700" cap="flat" cmpd="sng" algn="ctr">
-                      <a:solidFill>
-                        <a:srgbClr val="D5DEE0"/>
-                      </a:solidFill>
-                      <a:prstDash val="solid"/>
-                      <a:round/>
-                      <a:headEnd type="none" w="med" len="med"/>
-                      <a:tailEnd type="none" w="med" len="med"/>
-                    </a:lnL>
-                    <a:lnR w="12700" cap="flat" cmpd="sng" algn="ctr">
-                      <a:solidFill>
-                        <a:srgbClr val="D5DEE0"/>
-                      </a:solidFill>
-                      <a:prstDash val="solid"/>
-                      <a:round/>
-                      <a:headEnd type="none" w="med" len="med"/>
-                      <a:tailEnd type="none" w="med" len="med"/>
-                    </a:lnR>
-                    <a:lnT w="12700" cap="flat" cmpd="sng" algn="ctr">
-                      <a:solidFill>
-                        <a:srgbClr val="D5DEE0"/>
-                      </a:solidFill>
-                      <a:prstDash val="solid"/>
-                      <a:round/>
-                      <a:headEnd type="none" w="med" len="med"/>
-                      <a:tailEnd type="none" w="med" len="med"/>
-                    </a:lnT>
-                    <a:lnB w="12700" cap="flat" cmpd="sng" algn="ctr">
-                      <a:solidFill>
-                        <a:srgbClr val="D5DEE0"/>
-                      </a:solidFill>
-                      <a:prstDash val="solid"/>
-                      <a:round/>
-                      <a:headEnd type="none" w="med" len="med"/>
-                      <a:tailEnd type="none" w="med" len="med"/>
-                    </a:lnB>
-                    <a:solidFill>
-                      <a:srgbClr val="08323B"/>
-                    </a:solidFill>
-                  </a:tcPr>
-                </a:tc>
-                <a:tc>
-                  <a:txBody>
-                    <a:bodyPr/>
-                    <a:lstStyle/>
-                    <a:p>
-                      <a:pPr algn="l" indent="0" marL="0">
-                        <a:buNone/>
-                      </a:pPr>
-                      <a:r>
-                        <a:rPr lang="en-US" sz="1100" b="1" dirty="0">
-                          <a:solidFill>
-                            <a:srgbClr val="FFFFFF"/>
-                          </a:solidFill>
-                          <a:latin typeface="Courier New" pitchFamily="34" charset="0"/>
-                          <a:ea typeface="Courier New" pitchFamily="34" charset="-122"/>
-                          <a:cs typeface="Courier New" pitchFamily="34" charset="-120"/>
-                        </a:rPr>
-                        <a:t>Code</a:t>
-                      </a:r>
-                      <a:endParaRPr lang="en-US" sz="1100" dirty="0">
-                        <a:latin typeface="Courier New" charset="0"/>
-                        <a:ea typeface="Courier New" charset="0"/>
-                        <a:cs typeface="Courier New" charset="0"/>
-                      </a:endParaRPr>
-                    </a:p>
-                  </a:txBody>
-                  <a:tcPr marL="127000" marR="127000" marT="50800" marB="50800" anchor="ctr">
-                    <a:lnL w="12700" cap="flat" cmpd="sng" algn="ctr">
-                      <a:solidFill>
-                        <a:srgbClr val="D5DEE0"/>
-                      </a:solidFill>
-                      <a:prstDash val="solid"/>
-                      <a:round/>
-                      <a:headEnd type="none" w="med" len="med"/>
-                      <a:tailEnd type="none" w="med" len="med"/>
-                    </a:lnL>
-                    <a:lnR w="12700" cap="flat" cmpd="sng" algn="ctr">
-                      <a:solidFill>
-                        <a:srgbClr val="D5DEE0"/>
-                      </a:solidFill>
-                      <a:prstDash val="solid"/>
-                      <a:round/>
-                      <a:headEnd type="none" w="med" len="med"/>
-                      <a:tailEnd type="none" w="med" len="med"/>
-                    </a:lnR>
-                    <a:lnT w="12700" cap="flat" cmpd="sng" algn="ctr">
-                      <a:solidFill>
-                        <a:srgbClr val="D5DEE0"/>
-                      </a:solidFill>
-                      <a:prstDash val="solid"/>
-                      <a:round/>
-                      <a:headEnd type="none" w="med" len="med"/>
-                      <a:tailEnd type="none" w="med" len="med"/>
-                    </a:lnT>
-                    <a:lnB w="12700" cap="flat" cmpd="sng" algn="ctr">
-                      <a:solidFill>
-                        <a:srgbClr val="D5DEE0"/>
-                      </a:solidFill>
-                      <a:prstDash val="solid"/>
-                      <a:round/>
-                      <a:headEnd type="none" w="med" len="med"/>
-                      <a:tailEnd type="none" w="med" len="med"/>
-                    </a:lnB>
-                    <a:solidFill>
-                      <a:srgbClr val="08323B"/>
-                    </a:solidFill>
-                  </a:tcPr>
-                </a:tc>
-              </a:tr>
-              <a:tr h="502920">
-                <a:tc>
-                  <a:txBody>
-                    <a:bodyPr/>
-                    <a:lstStyle/>
-                    <a:p>
-                      <a:pPr algn="l" indent="0" marL="0">
-                        <a:buNone/>
-                      </a:pPr>
-                      <a:r>
-                        <a:rPr lang="en-US" sz="1300" b="1" dirty="0">
-                          <a:solidFill>
-                            <a:srgbClr val="08323B"/>
-                          </a:solidFill>
-                          <a:latin typeface="Calibri" pitchFamily="34" charset="0"/>
-                          <a:ea typeface="Calibri" pitchFamily="34" charset="-122"/>
-                          <a:cs typeface="Calibri" pitchFamily="34" charset="-120"/>
-                        </a:rPr>
-                        <a:t>Unmapped ward / doctor</a:t>
-                      </a:r>
-                      <a:endParaRPr lang="en-US" sz="1300" dirty="0">
-                        <a:latin typeface="Calibri" charset="0"/>
-                        <a:ea typeface="Calibri" charset="0"/>
-                        <a:cs typeface="Calibri" charset="0"/>
-                      </a:endParaRPr>
-                    </a:p>
-                  </a:txBody>
-                  <a:tcPr marL="127000" marR="127000" marT="50800" marB="50800" anchor="ctr">
-                    <a:lnL w="12700" cap="flat" cmpd="sng" algn="ctr">
-                      <a:solidFill>
-                        <a:srgbClr val="D5DEE0"/>
-                      </a:solidFill>
-                      <a:prstDash val="solid"/>
-                      <a:round/>
-                      <a:headEnd type="none" w="med" len="med"/>
-                      <a:tailEnd type="none" w="med" len="med"/>
-                    </a:lnL>
-                    <a:lnR w="12700" cap="flat" cmpd="sng" algn="ctr">
-                      <a:solidFill>
-                        <a:srgbClr val="D5DEE0"/>
-                      </a:solidFill>
-                      <a:prstDash val="solid"/>
-                      <a:round/>
-                      <a:headEnd type="none" w="med" len="med"/>
-                      <a:tailEnd type="none" w="med" len="med"/>
-                    </a:lnR>
-                    <a:lnT w="12700" cap="flat" cmpd="sng" algn="ctr">
-                      <a:solidFill>
-                        <a:srgbClr val="D5DEE0"/>
-                      </a:solidFill>
-                      <a:prstDash val="solid"/>
-                      <a:round/>
-                      <a:headEnd type="none" w="med" len="med"/>
-                      <a:tailEnd type="none" w="med" len="med"/>
-                    </a:lnT>
-                    <a:lnB w="12700" cap="flat" cmpd="sng" algn="ctr">
-                      <a:solidFill>
-                        <a:srgbClr val="D5DEE0"/>
-                      </a:solidFill>
-                      <a:prstDash val="solid"/>
-                      <a:round/>
-                      <a:headEnd type="none" w="med" len="med"/>
-                      <a:tailEnd type="none" w="med" len="med"/>
-                    </a:lnB>
-                    <a:solidFill>
-                      <a:srgbClr val="FFFFFF"/>
-                    </a:solidFill>
-                  </a:tcPr>
-                </a:tc>
-                <a:tc>
-                  <a:txBody>
-                    <a:bodyPr/>
-                    <a:lstStyle/>
-                    <a:p>
-                      <a:pPr algn="l" indent="0" marL="0">
-                        <a:buNone/>
-                      </a:pPr>
-                      <a:r>
-                        <a:rPr lang="en-US" sz="1300" dirty="0">
-                          <a:solidFill>
-                            <a:srgbClr val="08323B"/>
-                          </a:solidFill>
-                          <a:latin typeface="Calibri" pitchFamily="34" charset="0"/>
-                          <a:ea typeface="Calibri" pitchFamily="34" charset="-122"/>
-                          <a:cs typeface="Calibri" pitchFamily="34" charset="-120"/>
-                        </a:rPr>
-                        <a:t>Doctor, location, specialty, report dest, or report copy has no LIS id</a:t>
-                      </a:r>
-                      <a:endParaRPr lang="en-US" sz="1300" dirty="0">
-                        <a:latin typeface="Calibri" charset="0"/>
-                        <a:ea typeface="Calibri" charset="0"/>
-                        <a:cs typeface="Calibri" charset="0"/>
-                      </a:endParaRPr>
-                    </a:p>
-                  </a:txBody>
-                  <a:tcPr marL="127000" marR="127000" marT="50800" marB="50800" anchor="ctr">
-                    <a:lnL w="12700" cap="flat" cmpd="sng" algn="ctr">
-                      <a:solidFill>
-                        <a:srgbClr val="D5DEE0"/>
-                      </a:solidFill>
-                      <a:prstDash val="solid"/>
-                      <a:round/>
-                      <a:headEnd type="none" w="med" len="med"/>
-                      <a:tailEnd type="none" w="med" len="med"/>
-                    </a:lnL>
-                    <a:lnR w="12700" cap="flat" cmpd="sng" algn="ctr">
-                      <a:solidFill>
-                        <a:srgbClr val="D5DEE0"/>
-                      </a:solidFill>
-                      <a:prstDash val="solid"/>
-                      <a:round/>
-                      <a:headEnd type="none" w="med" len="med"/>
-                      <a:tailEnd type="none" w="med" len="med"/>
-                    </a:lnR>
-                    <a:lnT w="12700" cap="flat" cmpd="sng" algn="ctr">
-                      <a:solidFill>
-                        <a:srgbClr val="D5DEE0"/>
-                      </a:solidFill>
-                      <a:prstDash val="solid"/>
-                      <a:round/>
-                      <a:headEnd type="none" w="med" len="med"/>
-                      <a:tailEnd type="none" w="med" len="med"/>
-                    </a:lnT>
-                    <a:lnB w="12700" cap="flat" cmpd="sng" algn="ctr">
-                      <a:solidFill>
-                        <a:srgbClr val="D5DEE0"/>
-                      </a:solidFill>
-                      <a:prstDash val="solid"/>
-                      <a:round/>
-                      <a:headEnd type="none" w="med" len="med"/>
-                      <a:tailEnd type="none" w="med" len="med"/>
-                    </a:lnB>
-                    <a:solidFill>
-                      <a:srgbClr val="FFFFFF"/>
-                    </a:solidFill>
-                  </a:tcPr>
-                </a:tc>
-                <a:tc>
-                  <a:txBody>
-                    <a:bodyPr/>
-                    <a:lstStyle/>
-                    <a:p>
-                      <a:pPr algn="l" indent="0" marL="0">
-                        <a:buNone/>
-                      </a:pPr>
-                      <a:r>
-                        <a:rPr lang="en-US" sz="1300" dirty="0">
-                          <a:solidFill>
-                            <a:srgbClr val="08323B"/>
-                          </a:solidFill>
-                          <a:latin typeface="Courier New" pitchFamily="34" charset="0"/>
-                          <a:ea typeface="Courier New" pitchFamily="34" charset="-122"/>
-                          <a:cs typeface="Courier New" pitchFamily="34" charset="-120"/>
-                        </a:rPr>
-                        <a:t>1162–1170, 1090</a:t>
-                      </a:r>
-                      <a:endParaRPr lang="en-US" sz="1300" dirty="0">
-                        <a:latin typeface="Courier New" charset="0"/>
-                        <a:ea typeface="Courier New" charset="0"/>
-                        <a:cs typeface="Courier New" charset="0"/>
-                      </a:endParaRPr>
-                    </a:p>
-                  </a:txBody>
-                  <a:tcPr marL="127000" marR="127000" marT="50800" marB="50800" anchor="ctr">
-                    <a:lnL w="12700" cap="flat" cmpd="sng" algn="ctr">
-                      <a:solidFill>
-                        <a:srgbClr val="D5DEE0"/>
-                      </a:solidFill>
-                      <a:prstDash val="solid"/>
-                      <a:round/>
-                      <a:headEnd type="none" w="med" len="med"/>
-                      <a:tailEnd type="none" w="med" len="med"/>
-                    </a:lnL>
-                    <a:lnR w="12700" cap="flat" cmpd="sng" algn="ctr">
-                      <a:solidFill>
-                        <a:srgbClr val="D5DEE0"/>
-                      </a:solidFill>
-                      <a:prstDash val="solid"/>
-                      <a:round/>
-                      <a:headEnd type="none" w="med" len="med"/>
-                      <a:tailEnd type="none" w="med" len="med"/>
-                    </a:lnR>
-                    <a:lnT w="12700" cap="flat" cmpd="sng" algn="ctr">
-                      <a:solidFill>
-                        <a:srgbClr val="D5DEE0"/>
-                      </a:solidFill>
-                      <a:prstDash val="solid"/>
-                      <a:round/>
-                      <a:headEnd type="none" w="med" len="med"/>
-                      <a:tailEnd type="none" w="med" len="med"/>
-                    </a:lnT>
-                    <a:lnB w="12700" cap="flat" cmpd="sng" algn="ctr">
-                      <a:solidFill>
-                        <a:srgbClr val="D5DEE0"/>
-                      </a:solidFill>
-                      <a:prstDash val="solid"/>
-                      <a:round/>
-                      <a:headEnd type="none" w="med" len="med"/>
-                      <a:tailEnd type="none" w="med" len="med"/>
-                    </a:lnB>
-                    <a:solidFill>
-                      <a:srgbClr val="FFFFFF"/>
-                    </a:solidFill>
-                  </a:tcPr>
-                </a:tc>
-              </a:tr>
-              <a:tr h="502920">
-                <a:tc>
-                  <a:txBody>
-                    <a:bodyPr/>
-                    <a:lstStyle/>
-                    <a:p>
-                      <a:pPr algn="l" indent="0" marL="0">
-                        <a:buNone/>
-                      </a:pPr>
-                      <a:r>
-                        <a:rPr lang="en-US" sz="1300" b="1" dirty="0">
-                          <a:solidFill>
-                            <a:srgbClr val="08323B"/>
-                          </a:solidFill>
-                          <a:latin typeface="Calibri" pitchFamily="34" charset="0"/>
-                          <a:ea typeface="Calibri" pitchFamily="34" charset="-122"/>
-                          <a:cs typeface="Calibri" pitchFamily="34" charset="-120"/>
-                        </a:rPr>
-                        <a:t>Datetime</a:t>
-                      </a:r>
-                      <a:endParaRPr lang="en-US" sz="1300" dirty="0">
-                        <a:latin typeface="Calibri" charset="0"/>
-                        <a:ea typeface="Calibri" charset="0"/>
-                        <a:cs typeface="Calibri" charset="0"/>
-                      </a:endParaRPr>
-                    </a:p>
-                  </a:txBody>
-                  <a:tcPr marL="127000" marR="127000" marT="50800" marB="50800" anchor="ctr">
-                    <a:lnL w="12700" cap="flat" cmpd="sng" algn="ctr">
-                      <a:solidFill>
-                        <a:srgbClr val="D5DEE0"/>
-                      </a:solidFill>
-                      <a:prstDash val="solid"/>
-                      <a:round/>
-                      <a:headEnd type="none" w="med" len="med"/>
-                      <a:tailEnd type="none" w="med" len="med"/>
-                    </a:lnL>
-                    <a:lnR w="12700" cap="flat" cmpd="sng" algn="ctr">
-                      <a:solidFill>
-                        <a:srgbClr val="D5DEE0"/>
-                      </a:solidFill>
-                      <a:prstDash val="solid"/>
-                      <a:round/>
-                      <a:headEnd type="none" w="med" len="med"/>
-                      <a:tailEnd type="none" w="med" len="med"/>
-                    </a:lnR>
-                    <a:lnT w="12700" cap="flat" cmpd="sng" algn="ctr">
-                      <a:solidFill>
-                        <a:srgbClr val="D5DEE0"/>
-                      </a:solidFill>
-                      <a:prstDash val="solid"/>
-                      <a:round/>
-                      <a:headEnd type="none" w="med" len="med"/>
-                      <a:tailEnd type="none" w="med" len="med"/>
-                    </a:lnT>
-                    <a:lnB w="12700" cap="flat" cmpd="sng" algn="ctr">
-                      <a:solidFill>
-                        <a:srgbClr val="D5DEE0"/>
-                      </a:solidFill>
-                      <a:prstDash val="solid"/>
-                      <a:round/>
-                      <a:headEnd type="none" w="med" len="med"/>
-                      <a:tailEnd type="none" w="med" len="med"/>
-                    </a:lnB>
-                    <a:solidFill>
-                      <a:srgbClr val="FFFFFF"/>
-                    </a:solidFill>
-                  </a:tcPr>
-                </a:tc>
-                <a:tc>
-                  <a:txBody>
-                    <a:bodyPr/>
-                    <a:lstStyle/>
-                    <a:p>
-                      <a:pPr algn="l" indent="0" marL="0">
-                        <a:buNone/>
-                      </a:pPr>
-                      <a:r>
-                        <a:rPr lang="en-US" sz="1300" dirty="0">
-                          <a:solidFill>
-                            <a:srgbClr val="08323B"/>
-                          </a:solidFill>
-                          <a:latin typeface="Calibri" pitchFamily="34" charset="0"/>
-                          <a:ea typeface="Calibri" pitchFamily="34" charset="-122"/>
-                          <a:cs typeface="Calibri" pitchFamily="34" charset="-120"/>
-                        </a:rPr>
-                        <a:t>Collection before DOB; ack before collection or request; ack in the future</a:t>
-                      </a:r>
-                      <a:endParaRPr lang="en-US" sz="1300" dirty="0">
-                        <a:latin typeface="Calibri" charset="0"/>
-                        <a:ea typeface="Calibri" charset="0"/>
-                        <a:cs typeface="Calibri" charset="0"/>
-                      </a:endParaRPr>
-                    </a:p>
-                  </a:txBody>
-                  <a:tcPr marL="127000" marR="127000" marT="50800" marB="50800" anchor="ctr">
-                    <a:lnL w="12700" cap="flat" cmpd="sng" algn="ctr">
-                      <a:solidFill>
-                        <a:srgbClr val="D5DEE0"/>
-                      </a:solidFill>
-                      <a:prstDash val="solid"/>
-                      <a:round/>
-                      <a:headEnd type="none" w="med" len="med"/>
-                      <a:tailEnd type="none" w="med" len="med"/>
-                    </a:lnL>
-                    <a:lnR w="12700" cap="flat" cmpd="sng" algn="ctr">
-                      <a:solidFill>
-                        <a:srgbClr val="D5DEE0"/>
-                      </a:solidFill>
-                      <a:prstDash val="solid"/>
-                      <a:round/>
-                      <a:headEnd type="none" w="med" len="med"/>
-                      <a:tailEnd type="none" w="med" len="med"/>
-                    </a:lnR>
-                    <a:lnT w="12700" cap="flat" cmpd="sng" algn="ctr">
-                      <a:solidFill>
-                        <a:srgbClr val="D5DEE0"/>
-                      </a:solidFill>
-                      <a:prstDash val="solid"/>
-                      <a:round/>
-                      <a:headEnd type="none" w="med" len="med"/>
-                      <a:tailEnd type="none" w="med" len="med"/>
-                    </a:lnT>
-                    <a:lnB w="12700" cap="flat" cmpd="sng" algn="ctr">
-                      <a:solidFill>
-                        <a:srgbClr val="D5DEE0"/>
-                      </a:solidFill>
-                      <a:prstDash val="solid"/>
-                      <a:round/>
-                      <a:headEnd type="none" w="med" len="med"/>
-                      <a:tailEnd type="none" w="med" len="med"/>
-                    </a:lnB>
-                    <a:solidFill>
-                      <a:srgbClr val="FFFFFF"/>
-                    </a:solidFill>
-                  </a:tcPr>
-                </a:tc>
-                <a:tc>
-                  <a:txBody>
-                    <a:bodyPr/>
-                    <a:lstStyle/>
-                    <a:p>
-                      <a:pPr algn="l" indent="0" marL="0">
-                        <a:buNone/>
-                      </a:pPr>
-                      <a:r>
-                        <a:rPr lang="en-US" sz="1300" dirty="0">
-                          <a:solidFill>
-                            <a:srgbClr val="08323B"/>
-                          </a:solidFill>
-                          <a:latin typeface="Courier New" pitchFamily="34" charset="0"/>
-                          <a:ea typeface="Courier New" pitchFamily="34" charset="-122"/>
-                          <a:cs typeface="Courier New" pitchFamily="34" charset="-120"/>
-                        </a:rPr>
-                        <a:t>R12</a:t>
-                      </a:r>
-                      <a:endParaRPr lang="en-US" sz="1300" dirty="0">
-                        <a:latin typeface="Courier New" charset="0"/>
-                        <a:ea typeface="Courier New" charset="0"/>
-                        <a:cs typeface="Courier New" charset="0"/>
-                      </a:endParaRPr>
-                    </a:p>
-                  </a:txBody>
-                  <a:tcPr marL="127000" marR="127000" marT="50800" marB="50800" anchor="ctr">
-                    <a:lnL w="12700" cap="flat" cmpd="sng" algn="ctr">
-                      <a:solidFill>
-                        <a:srgbClr val="D5DEE0"/>
-                      </a:solidFill>
-                      <a:prstDash val="solid"/>
-                      <a:round/>
-                      <a:headEnd type="none" w="med" len="med"/>
-                      <a:tailEnd type="none" w="med" len="med"/>
-                    </a:lnL>
-                    <a:lnR w="12700" cap="flat" cmpd="sng" algn="ctr">
-                      <a:solidFill>
-                        <a:srgbClr val="D5DEE0"/>
-                      </a:solidFill>
-                      <a:prstDash val="solid"/>
-                      <a:round/>
-                      <a:headEnd type="none" w="med" len="med"/>
-                      <a:tailEnd type="none" w="med" len="med"/>
-                    </a:lnR>
-                    <a:lnT w="12700" cap="flat" cmpd="sng" algn="ctr">
-                      <a:solidFill>
-                        <a:srgbClr val="D5DEE0"/>
-                      </a:solidFill>
-                      <a:prstDash val="solid"/>
-                      <a:round/>
-                      <a:headEnd type="none" w="med" len="med"/>
-                      <a:tailEnd type="none" w="med" len="med"/>
-                    </a:lnT>
-                    <a:lnB w="12700" cap="flat" cmpd="sng" algn="ctr">
-                      <a:solidFill>
-                        <a:srgbClr val="D5DEE0"/>
-                      </a:solidFill>
-                      <a:prstDash val="solid"/>
-                      <a:round/>
-                      <a:headEnd type="none" w="med" len="med"/>
-                      <a:tailEnd type="none" w="med" len="med"/>
-                    </a:lnB>
-                    <a:solidFill>
-                      <a:srgbClr val="FFFFFF"/>
-                    </a:solidFill>
-                  </a:tcPr>
-                </a:tc>
-              </a:tr>
-              <a:tr h="502920">
-                <a:tc>
-                  <a:txBody>
-                    <a:bodyPr/>
-                    <a:lstStyle/>
-                    <a:p>
-                      <a:pPr algn="l" indent="0" marL="0">
-                        <a:buNone/>
-                      </a:pPr>
-                      <a:r>
-                        <a:rPr lang="en-US" sz="1300" b="1" dirty="0">
-                          <a:solidFill>
-                            <a:srgbClr val="08323B"/>
-                          </a:solidFill>
-                          <a:latin typeface="Calibri" pitchFamily="34" charset="0"/>
-                          <a:ea typeface="Calibri" pitchFamily="34" charset="-122"/>
-                          <a:cs typeface="Calibri" pitchFamily="34" charset="-120"/>
-                        </a:rPr>
-                        <a:t>Nothing to register</a:t>
-                      </a:r>
-                      <a:endParaRPr lang="en-US" sz="1300" dirty="0">
-                        <a:latin typeface="Calibri" charset="0"/>
-                        <a:ea typeface="Calibri" charset="0"/>
-                        <a:cs typeface="Calibri" charset="0"/>
-                      </a:endParaRPr>
-                    </a:p>
-                  </a:txBody>
-                  <a:tcPr marL="127000" marR="127000" marT="50800" marB="50800" anchor="ctr">
-                    <a:lnL w="12700" cap="flat" cmpd="sng" algn="ctr">
-                      <a:solidFill>
-                        <a:srgbClr val="D5DEE0"/>
-                      </a:solidFill>
-                      <a:prstDash val="solid"/>
-                      <a:round/>
-                      <a:headEnd type="none" w="med" len="med"/>
-                      <a:tailEnd type="none" w="med" len="med"/>
-                    </a:lnL>
-                    <a:lnR w="12700" cap="flat" cmpd="sng" algn="ctr">
-                      <a:solidFill>
-                        <a:srgbClr val="D5DEE0"/>
-                      </a:solidFill>
-                      <a:prstDash val="solid"/>
-                      <a:round/>
-                      <a:headEnd type="none" w="med" len="med"/>
-                      <a:tailEnd type="none" w="med" len="med"/>
-                    </a:lnR>
-                    <a:lnT w="12700" cap="flat" cmpd="sng" algn="ctr">
-                      <a:solidFill>
-                        <a:srgbClr val="D5DEE0"/>
-                      </a:solidFill>
-                      <a:prstDash val="solid"/>
-                      <a:round/>
-                      <a:headEnd type="none" w="med" len="med"/>
-                      <a:tailEnd type="none" w="med" len="med"/>
-                    </a:lnT>
-                    <a:lnB w="12700" cap="flat" cmpd="sng" algn="ctr">
-                      <a:solidFill>
-                        <a:srgbClr val="D5DEE0"/>
-                      </a:solidFill>
-                      <a:prstDash val="solid"/>
-                      <a:round/>
-                      <a:headEnd type="none" w="med" len="med"/>
-                      <a:tailEnd type="none" w="med" len="med"/>
-                    </a:lnB>
-                    <a:solidFill>
-                      <a:srgbClr val="FFFFFF"/>
-                    </a:solidFill>
-                  </a:tcPr>
-                </a:tc>
-                <a:tc>
-                  <a:txBody>
-                    <a:bodyPr/>
-                    <a:lstStyle/>
-                    <a:p>
-                      <a:pPr algn="l" indent="0" marL="0">
-                        <a:buNone/>
-                      </a:pPr>
-                      <a:r>
-                        <a:rPr lang="en-US" sz="1300" dirty="0">
-                          <a:solidFill>
-                            <a:srgbClr val="08323B"/>
-                          </a:solidFill>
-                          <a:latin typeface="Calibri" pitchFamily="34" charset="0"/>
-                          <a:ea typeface="Calibri" pitchFamily="34" charset="-122"/>
-                          <a:cs typeface="Calibri" pitchFamily="34" charset="-120"/>
-                        </a:rPr>
-                        <a:t>Already used, all registered, all deleted, specimen deleted or rejected</a:t>
-                      </a:r>
-                      <a:endParaRPr lang="en-US" sz="1300" dirty="0">
-                        <a:latin typeface="Calibri" charset="0"/>
-                        <a:ea typeface="Calibri" charset="0"/>
-                        <a:cs typeface="Calibri" charset="0"/>
-                      </a:endParaRPr>
-                    </a:p>
-                  </a:txBody>
-                  <a:tcPr marL="127000" marR="127000" marT="50800" marB="50800" anchor="ctr">
-                    <a:lnL w="12700" cap="flat" cmpd="sng" algn="ctr">
-                      <a:solidFill>
-                        <a:srgbClr val="D5DEE0"/>
-                      </a:solidFill>
-                      <a:prstDash val="solid"/>
-                      <a:round/>
-                      <a:headEnd type="none" w="med" len="med"/>
-                      <a:tailEnd type="none" w="med" len="med"/>
-                    </a:lnL>
-                    <a:lnR w="12700" cap="flat" cmpd="sng" algn="ctr">
-                      <a:solidFill>
-                        <a:srgbClr val="D5DEE0"/>
-                      </a:solidFill>
-                      <a:prstDash val="solid"/>
-                      <a:round/>
-                      <a:headEnd type="none" w="med" len="med"/>
-                      <a:tailEnd type="none" w="med" len="med"/>
-                    </a:lnR>
-                    <a:lnT w="12700" cap="flat" cmpd="sng" algn="ctr">
-                      <a:solidFill>
-                        <a:srgbClr val="D5DEE0"/>
-                      </a:solidFill>
-                      <a:prstDash val="solid"/>
-                      <a:round/>
-                      <a:headEnd type="none" w="med" len="med"/>
-                      <a:tailEnd type="none" w="med" len="med"/>
-                    </a:lnT>
-                    <a:lnB w="12700" cap="flat" cmpd="sng" algn="ctr">
-                      <a:solidFill>
-                        <a:srgbClr val="D5DEE0"/>
-                      </a:solidFill>
-                      <a:prstDash val="solid"/>
-                      <a:round/>
-                      <a:headEnd type="none" w="med" len="med"/>
-                      <a:tailEnd type="none" w="med" len="med"/>
-                    </a:lnB>
-                    <a:solidFill>
-                      <a:srgbClr val="FFFFFF"/>
-                    </a:solidFill>
-                  </a:tcPr>
-                </a:tc>
-                <a:tc>
-                  <a:txBody>
-                    <a:bodyPr/>
-                    <a:lstStyle/>
-                    <a:p>
-                      <a:pPr algn="l" indent="0" marL="0">
-                        <a:buNone/>
-                      </a:pPr>
-                      <a:r>
-                        <a:rPr lang="en-US" sz="1300" b="1" dirty="0">
-                          <a:solidFill>
-                            <a:srgbClr val="FFFFFF"/>
-                          </a:solidFill>
-                          <a:latin typeface="Calibri" pitchFamily="34" charset="0"/>
-                          <a:ea typeface="Calibri" pitchFamily="34" charset="-122"/>
-                          <a:cs typeface="Calibri" pitchFamily="34" charset="-120"/>
-                        </a:rPr>
-                        <a:t>Failure</a:t>
-                      </a:r>
-                      <a:endParaRPr lang="en-US" sz="1300" dirty="0">
-                        <a:latin typeface="Calibri" charset="0"/>
-                        <a:ea typeface="Calibri" charset="0"/>
-                        <a:cs typeface="Calibri" charset="0"/>
-                      </a:endParaRPr>
-                    </a:p>
-                  </a:txBody>
-                  <a:tcPr marL="127000" marR="127000" marT="50800" marB="50800" anchor="ctr">
-                    <a:lnL w="12700" cap="flat" cmpd="sng" algn="ctr">
-                      <a:solidFill>
-                        <a:srgbClr val="D5DEE0"/>
-                      </a:solidFill>
-                      <a:prstDash val="solid"/>
-                      <a:round/>
-                      <a:headEnd type="none" w="med" len="med"/>
-                      <a:tailEnd type="none" w="med" len="med"/>
-                    </a:lnL>
-                    <a:lnR w="12700" cap="flat" cmpd="sng" algn="ctr">
-                      <a:solidFill>
-                        <a:srgbClr val="D5DEE0"/>
-                      </a:solidFill>
-                      <a:prstDash val="solid"/>
-                      <a:round/>
-                      <a:headEnd type="none" w="med" len="med"/>
-                      <a:tailEnd type="none" w="med" len="med"/>
-                    </a:lnR>
-                    <a:lnT w="12700" cap="flat" cmpd="sng" algn="ctr">
-                      <a:solidFill>
-                        <a:srgbClr val="D5DEE0"/>
-                      </a:solidFill>
-                      <a:prstDash val="solid"/>
-                      <a:round/>
-                      <a:headEnd type="none" w="med" len="med"/>
-                      <a:tailEnd type="none" w="med" len="med"/>
-                    </a:lnT>
-                    <a:lnB w="12700" cap="flat" cmpd="sng" algn="ctr">
-                      <a:solidFill>
-                        <a:srgbClr val="D5DEE0"/>
-                      </a:solidFill>
-                      <a:prstDash val="solid"/>
-                      <a:round/>
-                      <a:headEnd type="none" w="med" len="med"/>
-                      <a:tailEnd type="none" w="med" len="med"/>
-                    </a:lnB>
-                    <a:solidFill>
-                      <a:srgbClr val="F7E7E4"/>
-                    </a:solidFill>
-                  </a:tcPr>
-                </a:tc>
-              </a:tr>
-              <a:tr h="502920">
-                <a:tc>
-                  <a:txBody>
-                    <a:bodyPr/>
-                    <a:lstStyle/>
-                    <a:p>
-                      <a:pPr algn="l" indent="0" marL="0">
-                        <a:buNone/>
-                      </a:pPr>
-                      <a:r>
-                        <a:rPr lang="en-US" sz="1300" b="1" dirty="0">
-                          <a:solidFill>
-                            <a:srgbClr val="08323B"/>
-                          </a:solidFill>
-                          <a:latin typeface="Calibri" pitchFamily="34" charset="0"/>
-                          <a:ea typeface="Calibri" pitchFamily="34" charset="-122"/>
-                          <a:cs typeface="Calibri" pitchFamily="34" charset="-120"/>
-                        </a:rPr>
-                        <a:t>STAR no location</a:t>
-                      </a:r>
-                      <a:endParaRPr lang="en-US" sz="1300" dirty="0">
-                        <a:latin typeface="Calibri" charset="0"/>
-                        <a:ea typeface="Calibri" charset="0"/>
-                        <a:cs typeface="Calibri" charset="0"/>
-                      </a:endParaRPr>
-                    </a:p>
-                  </a:txBody>
-                  <a:tcPr marL="127000" marR="127000" marT="50800" marB="50800" anchor="ctr">
-                    <a:lnL w="12700" cap="flat" cmpd="sng" algn="ctr">
-                      <a:solidFill>
-                        <a:srgbClr val="D5DEE0"/>
-                      </a:solidFill>
-                      <a:prstDash val="solid"/>
-                      <a:round/>
-                      <a:headEnd type="none" w="med" len="med"/>
-                      <a:tailEnd type="none" w="med" len="med"/>
-                    </a:lnL>
-                    <a:lnR w="12700" cap="flat" cmpd="sng" algn="ctr">
-                      <a:solidFill>
-                        <a:srgbClr val="D5DEE0"/>
-                      </a:solidFill>
-                      <a:prstDash val="solid"/>
-                      <a:round/>
-                      <a:headEnd type="none" w="med" len="med"/>
-                      <a:tailEnd type="none" w="med" len="med"/>
-                    </a:lnR>
-                    <a:lnT w="12700" cap="flat" cmpd="sng" algn="ctr">
-                      <a:solidFill>
-                        <a:srgbClr val="D5DEE0"/>
-                      </a:solidFill>
-                      <a:prstDash val="solid"/>
-                      <a:round/>
-                      <a:headEnd type="none" w="med" len="med"/>
-                      <a:tailEnd type="none" w="med" len="med"/>
-                    </a:lnT>
-                    <a:lnB w="12700" cap="flat" cmpd="sng" algn="ctr">
-                      <a:solidFill>
-                        <a:srgbClr val="D5DEE0"/>
-                      </a:solidFill>
-                      <a:prstDash val="solid"/>
-                      <a:round/>
-                      <a:headEnd type="none" w="med" len="med"/>
-                      <a:tailEnd type="none" w="med" len="med"/>
-                    </a:lnB>
-                    <a:solidFill>
-                      <a:srgbClr val="FFFFFF"/>
-                    </a:solidFill>
-                  </a:tcPr>
-                </a:tc>
-                <a:tc>
-                  <a:txBody>
-                    <a:bodyPr/>
-                    <a:lstStyle/>
-                    <a:p>
-                      <a:pPr algn="l" indent="0" marL="0">
-                        <a:buNone/>
-                      </a:pPr>
-                      <a:r>
-                        <a:rPr lang="en-US" sz="1300" dirty="0">
-                          <a:solidFill>
-                            <a:srgbClr val="08323B"/>
-                          </a:solidFill>
-                          <a:latin typeface="Calibri" pitchFamily="34" charset="0"/>
-                          <a:ea typeface="Calibri" pitchFamily="34" charset="-122"/>
-                          <a:cs typeface="Calibri" pitchFamily="34" charset="-120"/>
-                        </a:rPr>
-                        <a:t>STAR specimen and workbench has no location</a:t>
-                      </a:r>
-                      <a:endParaRPr lang="en-US" sz="1300" dirty="0">
-                        <a:latin typeface="Calibri" charset="0"/>
-                        <a:ea typeface="Calibri" charset="0"/>
-                        <a:cs typeface="Calibri" charset="0"/>
-                      </a:endParaRPr>
-                    </a:p>
-                  </a:txBody>
-                  <a:tcPr marL="127000" marR="127000" marT="50800" marB="50800" anchor="ctr">
-                    <a:lnL w="12700" cap="flat" cmpd="sng" algn="ctr">
-                      <a:solidFill>
-                        <a:srgbClr val="D5DEE0"/>
-                      </a:solidFill>
-                      <a:prstDash val="solid"/>
-                      <a:round/>
-                      <a:headEnd type="none" w="med" len="med"/>
-                      <a:tailEnd type="none" w="med" len="med"/>
-                    </a:lnL>
-                    <a:lnR w="12700" cap="flat" cmpd="sng" algn="ctr">
-                      <a:solidFill>
-                        <a:srgbClr val="D5DEE0"/>
-                      </a:solidFill>
-                      <a:prstDash val="solid"/>
-                      <a:round/>
-                      <a:headEnd type="none" w="med" len="med"/>
-                      <a:tailEnd type="none" w="med" len="med"/>
-                    </a:lnR>
-                    <a:lnT w="12700" cap="flat" cmpd="sng" algn="ctr">
-                      <a:solidFill>
-                        <a:srgbClr val="D5DEE0"/>
-                      </a:solidFill>
-                      <a:prstDash val="solid"/>
-                      <a:round/>
-                      <a:headEnd type="none" w="med" len="med"/>
-                      <a:tailEnd type="none" w="med" len="med"/>
-                    </a:lnT>
-                    <a:lnB w="12700" cap="flat" cmpd="sng" algn="ctr">
-                      <a:solidFill>
-                        <a:srgbClr val="D5DEE0"/>
-                      </a:solidFill>
-                      <a:prstDash val="solid"/>
-                      <a:round/>
-                      <a:headEnd type="none" w="med" len="med"/>
-                      <a:tailEnd type="none" w="med" len="med"/>
-                    </a:lnB>
-                    <a:solidFill>
-                      <a:srgbClr val="FFFFFF"/>
-                    </a:solidFill>
-                  </a:tcPr>
-                </a:tc>
-                <a:tc>
-                  <a:txBody>
-                    <a:bodyPr/>
-                    <a:lstStyle/>
-                    <a:p>
-                      <a:pPr algn="l" indent="0" marL="0">
-                        <a:buNone/>
-                      </a:pPr>
-                      <a:r>
-                        <a:rPr lang="en-US" sz="1300" b="1" dirty="0">
-                          <a:solidFill>
-                            <a:srgbClr val="9A5C15"/>
-                          </a:solidFill>
-                          <a:latin typeface="Courier New" pitchFamily="34" charset="0"/>
-                          <a:ea typeface="Courier New" pitchFamily="34" charset="-122"/>
-                          <a:cs typeface="Courier New" pitchFamily="34" charset="-120"/>
-                        </a:rPr>
-                        <a:t>4422</a:t>
-                      </a:r>
-                      <a:endParaRPr lang="en-US" sz="1300" dirty="0">
-                        <a:latin typeface="Courier New" charset="0"/>
-                        <a:ea typeface="Courier New" charset="0"/>
-                        <a:cs typeface="Courier New" charset="0"/>
-                      </a:endParaRPr>
-                    </a:p>
-                  </a:txBody>
-                  <a:tcPr marL="127000" marR="127000" marT="50800" marB="50800" anchor="ctr">
-                    <a:lnL w="12700" cap="flat" cmpd="sng" algn="ctr">
-                      <a:solidFill>
-                        <a:srgbClr val="D5DEE0"/>
-                      </a:solidFill>
-                      <a:prstDash val="solid"/>
-                      <a:round/>
-                      <a:headEnd type="none" w="med" len="med"/>
-                      <a:tailEnd type="none" w="med" len="med"/>
-                    </a:lnL>
-                    <a:lnR w="12700" cap="flat" cmpd="sng" algn="ctr">
-                      <a:solidFill>
-                        <a:srgbClr val="D5DEE0"/>
-                      </a:solidFill>
-                      <a:prstDash val="solid"/>
-                      <a:round/>
-                      <a:headEnd type="none" w="med" len="med"/>
-                      <a:tailEnd type="none" w="med" len="med"/>
-                    </a:lnR>
-                    <a:lnT w="12700" cap="flat" cmpd="sng" algn="ctr">
-                      <a:solidFill>
-                        <a:srgbClr val="D5DEE0"/>
-                      </a:solidFill>
-                      <a:prstDash val="solid"/>
-                      <a:round/>
-                      <a:headEnd type="none" w="med" len="med"/>
-                      <a:tailEnd type="none" w="med" len="med"/>
-                    </a:lnT>
-                    <a:lnB w="12700" cap="flat" cmpd="sng" algn="ctr">
-                      <a:solidFill>
-                        <a:srgbClr val="D5DEE0"/>
-                      </a:solidFill>
-                      <a:prstDash val="solid"/>
-                      <a:round/>
-                      <a:headEnd type="none" w="med" len="med"/>
-                      <a:tailEnd type="none" w="med" len="med"/>
-                    </a:lnB>
-                    <a:solidFill>
-                      <a:srgbClr val="FAEEDB"/>
-                    </a:solidFill>
-                  </a:tcPr>
-                </a:tc>
-              </a:tr>
-              <a:tr h="502920">
-                <a:tc>
-                  <a:txBody>
-                    <a:bodyPr/>
-                    <a:lstStyle/>
-                    <a:p>
-                      <a:pPr algn="l" indent="0" marL="0">
-                        <a:buNone/>
-                      </a:pPr>
-                      <a:r>
-                        <a:rPr lang="en-US" sz="1300" b="1" dirty="0">
-                          <a:solidFill>
-                            <a:srgbClr val="08323B"/>
-                          </a:solidFill>
-                          <a:latin typeface="Calibri" pitchFamily="34" charset="0"/>
-                          <a:ea typeface="Calibri" pitchFamily="34" charset="-122"/>
-                          <a:cs typeface="Calibri" pitchFamily="34" charset="-120"/>
-                        </a:rPr>
-                        <a:t>Mixed send-out</a:t>
-                      </a:r>
-                      <a:endParaRPr lang="en-US" sz="1300" dirty="0">
-                        <a:latin typeface="Calibri" charset="0"/>
-                        <a:ea typeface="Calibri" charset="0"/>
-                        <a:cs typeface="Calibri" charset="0"/>
-                      </a:endParaRPr>
-                    </a:p>
-                  </a:txBody>
-                  <a:tcPr marL="127000" marR="127000" marT="50800" marB="50800" anchor="ctr">
-                    <a:lnL w="12700" cap="flat" cmpd="sng" algn="ctr">
-                      <a:solidFill>
-                        <a:srgbClr val="D5DEE0"/>
-                      </a:solidFill>
-                      <a:prstDash val="solid"/>
-                      <a:round/>
-                      <a:headEnd type="none" w="med" len="med"/>
-                      <a:tailEnd type="none" w="med" len="med"/>
-                    </a:lnL>
-                    <a:lnR w="12700" cap="flat" cmpd="sng" algn="ctr">
-                      <a:solidFill>
-                        <a:srgbClr val="D5DEE0"/>
-                      </a:solidFill>
-                      <a:prstDash val="solid"/>
-                      <a:round/>
-                      <a:headEnd type="none" w="med" len="med"/>
-                      <a:tailEnd type="none" w="med" len="med"/>
-                    </a:lnR>
-                    <a:lnT w="12700" cap="flat" cmpd="sng" algn="ctr">
-                      <a:solidFill>
-                        <a:srgbClr val="D5DEE0"/>
-                      </a:solidFill>
-                      <a:prstDash val="solid"/>
-                      <a:round/>
-                      <a:headEnd type="none" w="med" len="med"/>
-                      <a:tailEnd type="none" w="med" len="med"/>
-                    </a:lnT>
-                    <a:lnB w="12700" cap="flat" cmpd="sng" algn="ctr">
-                      <a:solidFill>
-                        <a:srgbClr val="D5DEE0"/>
-                      </a:solidFill>
-                      <a:prstDash val="solid"/>
-                      <a:round/>
-                      <a:headEnd type="none" w="med" len="med"/>
-                      <a:tailEnd type="none" w="med" len="med"/>
-                    </a:lnB>
-                    <a:solidFill>
-                      <a:srgbClr val="FFFFFF"/>
-                    </a:solidFill>
-                  </a:tcPr>
-                </a:tc>
-                <a:tc>
-                  <a:txBody>
-                    <a:bodyPr/>
-                    <a:lstStyle/>
-                    <a:p>
-                      <a:pPr algn="l" indent="0" marL="0">
-                        <a:buNone/>
-                      </a:pPr>
-                      <a:r>
-                        <a:rPr lang="en-US" sz="1300" dirty="0">
-                          <a:solidFill>
-                            <a:srgbClr val="08323B"/>
-                          </a:solidFill>
-                          <a:latin typeface="Calibri" pitchFamily="34" charset="0"/>
-                          <a:ea typeface="Calibri" pitchFamily="34" charset="-122"/>
-                          <a:cs typeface="Calibri" pitchFamily="34" charset="-120"/>
-                        </a:rPr>
-                        <a:t>Local and send-out tests on the same USID</a:t>
-                      </a:r>
-                      <a:endParaRPr lang="en-US" sz="1300" dirty="0">
-                        <a:latin typeface="Calibri" charset="0"/>
-                        <a:ea typeface="Calibri" charset="0"/>
-                        <a:cs typeface="Calibri" charset="0"/>
-                      </a:endParaRPr>
-                    </a:p>
-                  </a:txBody>
-                  <a:tcPr marL="127000" marR="127000" marT="50800" marB="50800" anchor="ctr">
-                    <a:lnL w="12700" cap="flat" cmpd="sng" algn="ctr">
-                      <a:solidFill>
-                        <a:srgbClr val="D5DEE0"/>
-                      </a:solidFill>
-                      <a:prstDash val="solid"/>
-                      <a:round/>
-                      <a:headEnd type="none" w="med" len="med"/>
-                      <a:tailEnd type="none" w="med" len="med"/>
-                    </a:lnL>
-                    <a:lnR w="12700" cap="flat" cmpd="sng" algn="ctr">
-                      <a:solidFill>
-                        <a:srgbClr val="D5DEE0"/>
-                      </a:solidFill>
-                      <a:prstDash val="solid"/>
-                      <a:round/>
-                      <a:headEnd type="none" w="med" len="med"/>
-                      <a:tailEnd type="none" w="med" len="med"/>
-                    </a:lnR>
-                    <a:lnT w="12700" cap="flat" cmpd="sng" algn="ctr">
-                      <a:solidFill>
-                        <a:srgbClr val="D5DEE0"/>
-                      </a:solidFill>
-                      <a:prstDash val="solid"/>
-                      <a:round/>
-                      <a:headEnd type="none" w="med" len="med"/>
-                      <a:tailEnd type="none" w="med" len="med"/>
-                    </a:lnT>
-                    <a:lnB w="12700" cap="flat" cmpd="sng" algn="ctr">
-                      <a:solidFill>
-                        <a:srgbClr val="D5DEE0"/>
-                      </a:solidFill>
-                      <a:prstDash val="solid"/>
-                      <a:round/>
-                      <a:headEnd type="none" w="med" len="med"/>
-                      <a:tailEnd type="none" w="med" len="med"/>
-                    </a:lnB>
-                    <a:solidFill>
-                      <a:srgbClr val="FFFFFF"/>
-                    </a:solidFill>
-                  </a:tcPr>
-                </a:tc>
-                <a:tc>
-                  <a:txBody>
-                    <a:bodyPr/>
-                    <a:lstStyle/>
-                    <a:p>
-                      <a:pPr algn="l" indent="0" marL="0">
-                        <a:buNone/>
-                      </a:pPr>
-                      <a:r>
-                        <a:rPr lang="en-US" sz="1300" b="1" dirty="0">
-                          <a:solidFill>
-                            <a:srgbClr val="FFFFFF"/>
-                          </a:solidFill>
-                          <a:latin typeface="Calibri" pitchFamily="34" charset="0"/>
-                          <a:ea typeface="Calibri" pitchFamily="34" charset="-122"/>
-                          <a:cs typeface="Calibri" pitchFamily="34" charset="-120"/>
-                        </a:rPr>
-                        <a:t>Failure</a:t>
-                      </a:r>
-                      <a:endParaRPr lang="en-US" sz="1300" dirty="0">
-                        <a:latin typeface="Calibri" charset="0"/>
-                        <a:ea typeface="Calibri" charset="0"/>
-                        <a:cs typeface="Calibri" charset="0"/>
-                      </a:endParaRPr>
-                    </a:p>
-                  </a:txBody>
-                  <a:tcPr marL="127000" marR="127000" marT="50800" marB="50800" anchor="ctr">
-                    <a:lnL w="12700" cap="flat" cmpd="sng" algn="ctr">
-                      <a:solidFill>
-                        <a:srgbClr val="D5DEE0"/>
-                      </a:solidFill>
-                      <a:prstDash val="solid"/>
-                      <a:round/>
-                      <a:headEnd type="none" w="med" len="med"/>
-                      <a:tailEnd type="none" w="med" len="med"/>
-                    </a:lnL>
-                    <a:lnR w="12700" cap="flat" cmpd="sng" algn="ctr">
-                      <a:solidFill>
-                        <a:srgbClr val="D5DEE0"/>
-                      </a:solidFill>
-                      <a:prstDash val="solid"/>
-                      <a:round/>
-                      <a:headEnd type="none" w="med" len="med"/>
-                      <a:tailEnd type="none" w="med" len="med"/>
-                    </a:lnR>
-                    <a:lnT w="12700" cap="flat" cmpd="sng" algn="ctr">
-                      <a:solidFill>
-                        <a:srgbClr val="D5DEE0"/>
-                      </a:solidFill>
-                      <a:prstDash val="solid"/>
-                      <a:round/>
-                      <a:headEnd type="none" w="med" len="med"/>
-                      <a:tailEnd type="none" w="med" len="med"/>
-                    </a:lnT>
-                    <a:lnB w="12700" cap="flat" cmpd="sng" algn="ctr">
-                      <a:solidFill>
-                        <a:srgbClr val="D5DEE0"/>
-                      </a:solidFill>
-                      <a:prstDash val="solid"/>
-                      <a:round/>
-                      <a:headEnd type="none" w="med" len="med"/>
-                      <a:tailEnd type="none" w="med" len="med"/>
-                    </a:lnB>
-                    <a:solidFill>
-                      <a:srgbClr val="F7E7E4"/>
-                    </a:solidFill>
-                  </a:tcPr>
-                </a:tc>
-              </a:tr>
-            </a:tbl>
-          </a:graphicData>
-        </a:graphic>
-      </p:graphicFrame>
-      <p:sp>
-        <p:nvSpPr>
-          <p:cNvPr id="5" name="Shape 2"/>
-          <p:cNvSpPr/>
-          <p:nvPr/>
-        </p:nvSpPr>
-        <p:spPr>
-          <a:xfrm>
-            <a:off x="548640" y="4434840"/>
-            <a:ext cx="5440680" cy="1417320"/>
+      <p:sp>
+        <p:nvSpPr>
+          <p:cNvPr id="4" name="Shape 2"/>
+          <p:cNvSpPr/>
+          <p:nvPr/>
+        </p:nvSpPr>
+        <p:spPr>
+          <a:xfrm>
+            <a:off x="548640" y="1737360"/>
+            <a:ext cx="3526536" cy="3108960"/>
           </a:xfrm>
           <a:prstGeom prst="roundRect">
             <a:avLst>
-              <a:gd name="adj" fmla="val 2581"/>
+              <a:gd name="adj" fmla="val 1176"/>
             </a:avLst>
           </a:prstGeom>
           <a:solidFill>
-            <a:srgbClr val="F7E7E4"/>
+            <a:srgbClr val="F1F3F3"/>
           </a:solidFill>
           <a:ln w="12700">
             <a:solidFill>
-              <a:srgbClr val="F7E7E4"/>
+              <a:srgbClr val="F1F3F3"/>
             </a:solidFill>
             <a:prstDash val="solid"/>
           </a:ln>
@@ -12216,14 +11160,59 @@
       </p:sp>
       <p:sp>
         <p:nvSpPr>
-          <p:cNvPr id="6" name="Text 3"/>
-          <p:cNvSpPr/>
-          <p:nvPr/>
-        </p:nvSpPr>
-        <p:spPr>
-          <a:xfrm>
-            <a:off x="822960" y="4590288"/>
-            <a:ext cx="4937760" cy="310896"/>
+          <p:cNvPr id="5" name="Text 3"/>
+          <p:cNvSpPr/>
+          <p:nvPr/>
+        </p:nvSpPr>
+        <p:spPr>
+          <a:xfrm>
+            <a:off x="822960" y="1993392"/>
+            <a:ext cx="384048" cy="384048"/>
+          </a:xfrm>
+          <a:prstGeom prst="ellipse">
+            <a:avLst/>
+          </a:prstGeom>
+          <a:solidFill>
+            <a:srgbClr val="56676C"/>
+          </a:solidFill>
+          <a:ln>
+            <a:solidFill>
+              <a:srgbClr val="56676C"/>
+            </a:solidFill>
+          </a:ln>
+        </p:spPr>
+        <p:txBody>
+          <a:bodyPr wrap="square" rtlCol="0" anchor="ctr"/>
+          <a:lstStyle/>
+          <a:p>
+            <a:pPr algn="ctr" indent="0" marL="0">
+              <a:buNone/>
+            </a:pPr>
+            <a:r>
+              <a:rPr lang="en-US" sz="1300" b="1" dirty="0">
+                <a:solidFill>
+                  <a:srgbClr val="FFFFFF"/>
+                </a:solidFill>
+                <a:latin typeface="Calibri" pitchFamily="34" charset="0"/>
+                <a:ea typeface="Calibri" pitchFamily="34" charset="-122"/>
+                <a:cs typeface="Calibri" pitchFamily="34" charset="-120"/>
+              </a:rPr>
+              <a:t>4</a:t>
+            </a:r>
+            <a:endParaRPr lang="en-US" sz="1300" dirty="0"/>
+          </a:p>
+        </p:txBody>
+      </p:sp>
+      <p:sp>
+        <p:nvSpPr>
+          <p:cNvPr id="6" name="Text 4"/>
+          <p:cNvSpPr/>
+          <p:nvPr/>
+        </p:nvSpPr>
+        <p:spPr>
+          <a:xfrm>
+            <a:off x="822960" y="2560320"/>
+            <a:ext cx="2977896" cy="457200"/>
           </a:xfrm>
           <a:prstGeom prst="rect">
             <a:avLst/>
@@ -12250,7 +11239,7 @@
                 <a:ea typeface="Cambria" pitchFamily="34" charset="-122"/>
                 <a:cs typeface="Cambria" pitchFamily="34" charset="-120"/>
               </a:rPr>
-              <a:t>Also Failure</a:t>
+              <a:t>Duplicate / A-A-R</a:t>
             </a:r>
             <a:endParaRPr lang="en-US" sz="1700" dirty="0"/>
           </a:p>
@@ -12258,14 +11247,14 @@
       </p:sp>
       <p:sp>
         <p:nvSpPr>
-          <p:cNvPr id="7" name="Text 4"/>
-          <p:cNvSpPr/>
-          <p:nvPr/>
-        </p:nvSpPr>
-        <p:spPr>
-          <a:xfrm>
-            <a:off x="822960" y="4956048"/>
-            <a:ext cx="4937760" cy="731520"/>
+          <p:cNvPr id="7" name="Text 5"/>
+          <p:cNvSpPr/>
+          <p:nvPr/>
+        </p:nvSpPr>
+        <p:spPr>
+          <a:xfrm>
+            <a:off x="822960" y="3090672"/>
+            <a:ext cx="2977896" cy="1572768"/>
           </a:xfrm>
           <a:prstGeom prst="rect">
             <a:avLst/>
@@ -12292,7 +11281,7 @@
                 <a:ea typeface="Calibri" pitchFamily="34" charset="-122"/>
                 <a:cs typeface="Calibri" pitchFamily="34" charset="-120"/>
               </a:rPr>
-              <a:t>Missing test dictionary, patient HKID or name mismatch, APS / BBS / MBS, unknown sorter id.</a:t>
+              <a:t>Duplicate-reason and A-A-R-not-ready. ALS only. AAR stays off.</a:t>
             </a:r>
             <a:endParaRPr lang="en-US" sz="1300" dirty="0"/>
           </a:p>
@@ -12300,26 +11289,26 @@
       </p:sp>
       <p:sp>
         <p:nvSpPr>
-          <p:cNvPr id="8" name="Shape 5"/>
-          <p:cNvSpPr/>
-          <p:nvPr/>
-        </p:nvSpPr>
-        <p:spPr>
-          <a:xfrm>
-            <a:off x="6199632" y="4434840"/>
-            <a:ext cx="5440680" cy="1417320"/>
+          <p:cNvPr id="8" name="Shape 6"/>
+          <p:cNvSpPr/>
+          <p:nvPr/>
+        </p:nvSpPr>
+        <p:spPr>
+          <a:xfrm>
+            <a:off x="4331208" y="1737360"/>
+            <a:ext cx="3526536" cy="3108960"/>
           </a:xfrm>
           <a:prstGeom prst="roundRect">
             <a:avLst>
-              <a:gd name="adj" fmla="val 2581"/>
+              <a:gd name="adj" fmla="val 1176"/>
             </a:avLst>
           </a:prstGeom>
           <a:solidFill>
-            <a:srgbClr val="E4F0F2"/>
+            <a:srgbClr val="F1F3F3"/>
           </a:solidFill>
           <a:ln w="12700">
             <a:solidFill>
-              <a:srgbClr val="E4F0F2"/>
+              <a:srgbClr val="F1F3F3"/>
             </a:solidFill>
             <a:prstDash val="solid"/>
           </a:ln>
@@ -12327,14 +11316,59 @@
       </p:sp>
       <p:sp>
         <p:nvSpPr>
-          <p:cNvPr id="9" name="Text 6"/>
-          <p:cNvSpPr/>
-          <p:nvPr/>
-        </p:nvSpPr>
-        <p:spPr>
-          <a:xfrm>
-            <a:off x="6473952" y="4590288"/>
-            <a:ext cx="4937760" cy="310896"/>
+          <p:cNvPr id="9" name="Text 7"/>
+          <p:cNvSpPr/>
+          <p:nvPr/>
+        </p:nvSpPr>
+        <p:spPr>
+          <a:xfrm>
+            <a:off x="4605528" y="1993392"/>
+            <a:ext cx="384048" cy="384048"/>
+          </a:xfrm>
+          <a:prstGeom prst="ellipse">
+            <a:avLst/>
+          </a:prstGeom>
+          <a:solidFill>
+            <a:srgbClr val="56676C"/>
+          </a:solidFill>
+          <a:ln>
+            <a:solidFill>
+              <a:srgbClr val="56676C"/>
+            </a:solidFill>
+          </a:ln>
+        </p:spPr>
+        <p:txBody>
+          <a:bodyPr wrap="square" rtlCol="0" anchor="ctr"/>
+          <a:lstStyle/>
+          <a:p>
+            <a:pPr algn="ctr" indent="0" marL="0">
+              <a:buNone/>
+            </a:pPr>
+            <a:r>
+              <a:rPr lang="en-US" sz="1300" b="1" dirty="0">
+                <a:solidFill>
+                  <a:srgbClr val="FFFFFF"/>
+                </a:solidFill>
+                <a:latin typeface="Calibri" pitchFamily="34" charset="0"/>
+                <a:ea typeface="Calibri" pitchFamily="34" charset="-122"/>
+                <a:cs typeface="Calibri" pitchFamily="34" charset="-120"/>
+              </a:rPr>
+              <a:t>5</a:t>
+            </a:r>
+            <a:endParaRPr lang="en-US" sz="1300" dirty="0"/>
+          </a:p>
+        </p:txBody>
+      </p:sp>
+      <p:sp>
+        <p:nvSpPr>
+          <p:cNvPr id="10" name="Text 8"/>
+          <p:cNvSpPr/>
+          <p:nvPr/>
+        </p:nvSpPr>
+        <p:spPr>
+          <a:xfrm>
+            <a:off x="4605528" y="2560320"/>
+            <a:ext cx="2977896" cy="457200"/>
           </a:xfrm>
           <a:prstGeom prst="rect">
             <a:avLst/>
@@ -12361,7 +11395,7 @@
                 <a:ea typeface="Cambria" pitchFamily="34" charset="-122"/>
                 <a:cs typeface="Cambria" pitchFamily="34" charset="-120"/>
               </a:rPr>
-              <a:t>Not Failure</a:t>
+              <a:t>Patient tag / private</a:t>
             </a:r>
             <a:endParaRPr lang="en-US" sz="1700" dirty="0"/>
           </a:p>
@@ -12369,14 +11403,14 @@
       </p:sp>
       <p:sp>
         <p:nvSpPr>
-          <p:cNvPr id="10" name="Text 7"/>
-          <p:cNvSpPr/>
-          <p:nvPr/>
-        </p:nvSpPr>
-        <p:spPr>
-          <a:xfrm>
-            <a:off x="6473952" y="4956048"/>
-            <a:ext cx="4937760" cy="731520"/>
+          <p:cNvPr id="11" name="Text 9"/>
+          <p:cNvSpPr/>
+          <p:nvPr/>
+        </p:nvSpPr>
+        <p:spPr>
+          <a:xfrm>
+            <a:off x="4605528" y="3090672"/>
+            <a:ext cx="2977896" cy="1572768"/>
           </a:xfrm>
           <a:prstGeom prst="rect">
             <a:avLst/>
@@ -12403,7 +11437,7 @@
                 <a:ea typeface="Calibri" pitchFamily="34" charset="-122"/>
                 <a:cs typeface="Calibri" pitchFamily="34" charset="-120"/>
               </a:rPr>
-              <a:t>Overnight, valid period, duplicate, patient tag, missing collection date, STAR unbox alert.</a:t>
+              <a:t>Private patient and patient-tag alerts. ALS only.</a:t>
             </a:r>
             <a:endParaRPr lang="en-US" sz="1300" dirty="0"/>
           </a:p>
@@ -12411,7 +11445,232 @@
       </p:sp>
       <p:sp>
         <p:nvSpPr>
-          <p:cNvPr id="11" name="Text 8"/>
+          <p:cNvPr id="12" name="Shape 10"/>
+          <p:cNvSpPr/>
+          <p:nvPr/>
+        </p:nvSpPr>
+        <p:spPr>
+          <a:xfrm>
+            <a:off x="8113776" y="1737360"/>
+            <a:ext cx="3526536" cy="3108960"/>
+          </a:xfrm>
+          <a:prstGeom prst="roundRect">
+            <a:avLst>
+              <a:gd name="adj" fmla="val 1176"/>
+            </a:avLst>
+          </a:prstGeom>
+          <a:solidFill>
+            <a:srgbClr val="FAEEDB"/>
+          </a:solidFill>
+          <a:ln w="12700">
+            <a:solidFill>
+              <a:srgbClr val="FAEEDB"/>
+            </a:solidFill>
+            <a:prstDash val="solid"/>
+          </a:ln>
+        </p:spPr>
+      </p:sp>
+      <p:sp>
+        <p:nvSpPr>
+          <p:cNvPr id="13" name="Text 11"/>
+          <p:cNvSpPr/>
+          <p:nvPr/>
+        </p:nvSpPr>
+        <p:spPr>
+          <a:xfrm>
+            <a:off x="8388096" y="1993392"/>
+            <a:ext cx="384048" cy="384048"/>
+          </a:xfrm>
+          <a:prstGeom prst="ellipse">
+            <a:avLst/>
+          </a:prstGeom>
+          <a:solidFill>
+            <a:srgbClr val="9A5C15"/>
+          </a:solidFill>
+          <a:ln>
+            <a:solidFill>
+              <a:srgbClr val="9A5C15"/>
+            </a:solidFill>
+          </a:ln>
+        </p:spPr>
+        <p:txBody>
+          <a:bodyPr wrap="square" rtlCol="0" anchor="ctr"/>
+          <a:lstStyle/>
+          <a:p>
+            <a:pPr algn="ctr" indent="0" marL="0">
+              <a:buNone/>
+            </a:pPr>
+            <a:r>
+              <a:rPr lang="en-US" sz="1300" b="1" dirty="0">
+                <a:solidFill>
+                  <a:srgbClr val="FFFFFF"/>
+                </a:solidFill>
+                <a:latin typeface="Calibri" pitchFamily="34" charset="0"/>
+                <a:ea typeface="Calibri" pitchFamily="34" charset="-122"/>
+                <a:cs typeface="Calibri" pitchFamily="34" charset="-120"/>
+              </a:rPr>
+              <a:t>6</a:t>
+            </a:r>
+            <a:endParaRPr lang="en-US" sz="1300" dirty="0"/>
+          </a:p>
+        </p:txBody>
+      </p:sp>
+      <p:sp>
+        <p:nvSpPr>
+          <p:cNvPr id="14" name="Text 12"/>
+          <p:cNvSpPr/>
+          <p:nvPr/>
+        </p:nvSpPr>
+        <p:spPr>
+          <a:xfrm>
+            <a:off x="8388096" y="2560320"/>
+            <a:ext cx="2977896" cy="457200"/>
+          </a:xfrm>
+          <a:prstGeom prst="rect">
+            <a:avLst/>
+          </a:prstGeom>
+          <a:noFill/>
+          <a:ln/>
+        </p:spPr>
+        <p:txBody>
+          <a:bodyPr wrap="square" rtlCol="0" anchor="t"/>
+          <a:lstStyle/>
+          <a:p>
+            <a:pPr algn="l" indent="0" marL="0">
+              <a:lnSpc>
+                <a:spcPct val="115000"/>
+              </a:lnSpc>
+              <a:buNone/>
+            </a:pPr>
+            <a:r>
+              <a:rPr lang="en-US" sz="1700" dirty="0">
+                <a:solidFill>
+                  <a:srgbClr val="08323B"/>
+                </a:solidFill>
+                <a:latin typeface="Cambria" pitchFamily="34" charset="0"/>
+                <a:ea typeface="Cambria" pitchFamily="34" charset="-122"/>
+                <a:cs typeface="Cambria" pitchFamily="34" charset="-120"/>
+              </a:rPr>
+              <a:t>STAR unbox alert</a:t>
+            </a:r>
+            <a:endParaRPr lang="en-US" sz="1700" dirty="0"/>
+          </a:p>
+        </p:txBody>
+      </p:sp>
+      <p:sp>
+        <p:nvSpPr>
+          <p:cNvPr id="15" name="Text 13"/>
+          <p:cNvSpPr/>
+          <p:nvPr/>
+        </p:nvSpPr>
+        <p:spPr>
+          <a:xfrm>
+            <a:off x="8388096" y="3090672"/>
+            <a:ext cx="2977896" cy="1572768"/>
+          </a:xfrm>
+          <a:prstGeom prst="rect">
+            <a:avLst/>
+          </a:prstGeom>
+          <a:noFill/>
+          <a:ln/>
+        </p:spPr>
+        <p:txBody>
+          <a:bodyPr wrap="square" rtlCol="0" anchor="t"/>
+          <a:lstStyle/>
+          <a:p>
+            <a:pPr algn="l" indent="0" marL="0">
+              <a:lnSpc>
+                <a:spcPct val="115000"/>
+              </a:lnSpc>
+              <a:buNone/>
+            </a:pPr>
+            <a:r>
+              <a:rPr lang="en-US" sz="1300" dirty="0">
+                <a:solidFill>
+                  <a:srgbClr val="56676C"/>
+                </a:solidFill>
+                <a:latin typeface="Calibri" pitchFamily="34" charset="0"/>
+                <a:ea typeface="Calibri" pitchFamily="34" charset="-122"/>
+                <a:cs typeface="Calibri" pitchFamily="34" charset="-120"/>
+              </a:rPr>
+              <a:t>Boxed warning is ALS. No workbench location is Failure 4422, not this card.</a:t>
+            </a:r>
+            <a:endParaRPr lang="en-US" sz="1300" dirty="0"/>
+          </a:p>
+        </p:txBody>
+      </p:sp>
+      <p:sp>
+        <p:nvSpPr>
+          <p:cNvPr id="16" name="Shape 14"/>
+          <p:cNvSpPr/>
+          <p:nvPr/>
+        </p:nvSpPr>
+        <p:spPr>
+          <a:xfrm>
+            <a:off x="548640" y="4983480"/>
+            <a:ext cx="11091672" cy="868680"/>
+          </a:xfrm>
+          <a:prstGeom prst="roundRect">
+            <a:avLst>
+              <a:gd name="adj" fmla="val 4211"/>
+            </a:avLst>
+          </a:prstGeom>
+          <a:solidFill>
+            <a:srgbClr val="FAEEDB"/>
+          </a:solidFill>
+          <a:ln w="12700">
+            <a:solidFill>
+              <a:srgbClr val="FAEEDB"/>
+            </a:solidFill>
+            <a:prstDash val="solid"/>
+          </a:ln>
+        </p:spPr>
+      </p:sp>
+      <p:sp>
+        <p:nvSpPr>
+          <p:cNvPr id="17" name="Text 15"/>
+          <p:cNvSpPr/>
+          <p:nvPr/>
+        </p:nvSpPr>
+        <p:spPr>
+          <a:xfrm>
+            <a:off x="868680" y="5120640"/>
+            <a:ext cx="10424160" cy="594360"/>
+          </a:xfrm>
+          <a:prstGeom prst="rect">
+            <a:avLst/>
+          </a:prstGeom>
+          <a:noFill/>
+          <a:ln/>
+        </p:spPr>
+        <p:txBody>
+          <a:bodyPr wrap="square" rtlCol="0" anchor="ctr"/>
+          <a:lstStyle/>
+          <a:p>
+            <a:pPr algn="l" indent="0" marL="0">
+              <a:lnSpc>
+                <a:spcPct val="120000"/>
+              </a:lnSpc>
+              <a:buNone/>
+            </a:pPr>
+            <a:r>
+              <a:rPr lang="en-US" sz="1400" dirty="0">
+                <a:solidFill>
+                  <a:srgbClr val="08323B"/>
+                </a:solidFill>
+                <a:latin typeface="Calibri" pitchFamily="34" charset="0"/>
+                <a:ea typeface="Calibri" pitchFamily="34" charset="-122"/>
+                <a:cs typeface="Calibri" pitchFamily="34" charset="-120"/>
+              </a:rPr>
+              <a:t>BBS blood / category / T&amp;S alerts stay on staff Spec Ack. BBS is out of v1.</a:t>
+            </a:r>
+            <a:endParaRPr lang="en-US" sz="1400" dirty="0"/>
+          </a:p>
+        </p:txBody>
+      </p:sp>
+      <p:sp>
+        <p:nvSpPr>
+          <p:cNvPr id="18" name="Text 16"/>
           <p:cNvSpPr/>
           <p:nvPr/>
         </p:nvSpPr>
@@ -12445,7 +11704,7 @@
                 <a:ea typeface="Calibri" pitchFamily="34" charset="-122"/>
                 <a:cs typeface="Calibri" pitchFamily="34" charset="-120"/>
               </a:rPr>
-              <a:t>9 / 14</a:t>
+              <a:t>9 / 15</a:t>
             </a:r>
             <a:endParaRPr lang="en-US" sz="900" dirty="0"/>
           </a:p>

</xml_diff>